<commit_message>
deck: SDLC cycle slide (large-text, greenfield/brownfield + slash commands), bench kit (brownfield project-agnostic + greenfield runners + task templates), methodology slide, docs
</commit_message>
<xml_diff>
--- a/docs/slides/Agentic-SDLC-Tech-Audience.pptx
+++ b/docs/slides/Agentic-SDLC-Tech-Audience.pptx
@@ -15,9 +15,11 @@
     <p:sldId id="263" r:id="rId9"/>
     <p:sldId id="264" r:id="rId10"/>
     <p:sldId id="265" r:id="rId11"/>
+    <p:sldId id="266" r:id="rId12"/>
+    <p:sldId id="267" r:id="rId13"/>
   </p:sldIdLst>
   <p:notesMasterIdLst>
-    <p:notesMasterId r:id="rId12"/>
+    <p:notesMasterId r:id="rId14"/>
   </p:notesMasterIdLst>
   <p:sldSz cx="12192000" cy="6858000"/>
   <p:notesSz cx="6858000" cy="12192000"/>
@@ -599,7 +601,7 @@
           <a:p>
             <a:r>
               <a:rPr lang="en-US" dirty="0"/>
-              <a:t>Close on the gaps. That is the part we defend most.</a:t>
+              <a:t>Methodology slide exists so the results are read with their confounds in frame, not as bare numbers.</a:t>
             </a:r>
             <a:endParaRPr lang="en-US" dirty="0"/>
           </a:p>
@@ -623,6 +625,182 @@
             <a:fld id="{F7021451-1387-4CA6-816F-3879F97B5CBC}" type="slidenum">
               <a:rPr lang="en-US"/>
               <a:t>10</a:t>
+            </a:fld>
+            <a:endParaRPr lang="en-US"/>
+          </a:p>
+        </p:txBody>
+      </p:sp>
+    </p:spTree>
+    <p:extLst>
+      <p:ext uri="{BB962C8B-B14F-4D97-AF65-F5344CB8AC3E}">
+        <p14:creationId xmlns:p14="http://schemas.microsoft.com/office/powerpoint/2010/main" val="1024086991"/>
+      </p:ext>
+    </p:extLst>
+  </p:cSld>
+  <p:clrMapOvr>
+    <a:masterClrMapping/>
+  </p:clrMapOvr>
+</p:notes>
+</file>
+
+<file path=ppt/notesSlides/notesSlide11.xml><?xml version="1.0" encoding="utf-8"?>
+<p:notes xmlns:a="http://schemas.openxmlformats.org/drawingml/2006/main" xmlns:r="http://schemas.openxmlformats.org/officeDocument/2006/relationships" xmlns:p="http://schemas.openxmlformats.org/presentationml/2006/main">
+  <p:cSld>
+    <p:spTree>
+      <p:nvGrpSpPr>
+        <p:cNvPr id="1" name=""/>
+        <p:cNvGrpSpPr/>
+        <p:nvPr/>
+      </p:nvGrpSpPr>
+      <p:grpSpPr>
+        <a:xfrm>
+          <a:off x="0" y="0"/>
+          <a:ext cx="0" cy="0"/>
+          <a:chOff x="0" y="0"/>
+          <a:chExt cx="0" cy="0"/>
+        </a:xfrm>
+      </p:grpSpPr>
+      <p:sp>
+        <p:nvSpPr>
+          <p:cNvPr id="2" name="Slide Image Placeholder 1"/>
+          <p:cNvSpPr>
+            <a:spLocks noGrp="1" noRot="1" noChangeAspect="1"/>
+          </p:cNvSpPr>
+          <p:nvPr>
+            <p:ph type="sldImg"/>
+          </p:nvPr>
+        </p:nvSpPr>
+        <p:spPr/>
+      </p:sp>
+      <p:sp>
+        <p:nvSpPr>
+          <p:cNvPr id="3" name="Notes Placeholder 2"/>
+          <p:cNvSpPr>
+            <a:spLocks noGrp="1"/>
+          </p:cNvSpPr>
+          <p:nvPr>
+            <p:ph type="body" idx="1"/>
+          </p:nvPr>
+        </p:nvSpPr>
+        <p:spPr/>
+        <p:txBody>
+          <a:bodyPr/>
+          <a:lstStyle/>
+          <a:p>
+            <a:r>
+              <a:rPr lang="en-US" dirty="0"/>
+              <a:t>4 runs, 3 arms, real numbers, real gaps. Read the R4 line out loud: the guardrail is advisory — that is the honesty that earns trust.</a:t>
+            </a:r>
+            <a:endParaRPr lang="en-US" dirty="0"/>
+          </a:p>
+        </p:txBody>
+      </p:sp>
+      <p:sp>
+        <p:nvSpPr>
+          <p:cNvPr id="4" name="Slide Number Placeholder 3"/>
+          <p:cNvSpPr>
+            <a:spLocks noGrp="1"/>
+          </p:cNvSpPr>
+          <p:nvPr>
+            <p:ph type="sldNum" sz="quarter" idx="10"/>
+          </p:nvPr>
+        </p:nvSpPr>
+        <p:spPr/>
+        <p:txBody>
+          <a:bodyPr/>
+          <a:lstStyle/>
+          <a:p>
+            <a:fld id="{F7021451-1387-4CA6-816F-3879F97B5CBC}" type="slidenum">
+              <a:rPr lang="en-US"/>
+              <a:t>11</a:t>
+            </a:fld>
+            <a:endParaRPr lang="en-US"/>
+          </a:p>
+        </p:txBody>
+      </p:sp>
+    </p:spTree>
+    <p:extLst>
+      <p:ext uri="{BB962C8B-B14F-4D97-AF65-F5344CB8AC3E}">
+        <p14:creationId xmlns:p14="http://schemas.microsoft.com/office/powerpoint/2010/main" val="1024086991"/>
+      </p:ext>
+    </p:extLst>
+  </p:cSld>
+  <p:clrMapOvr>
+    <a:masterClrMapping/>
+  </p:clrMapOvr>
+</p:notes>
+</file>
+
+<file path=ppt/notesSlides/notesSlide12.xml><?xml version="1.0" encoding="utf-8"?>
+<p:notes xmlns:a="http://schemas.openxmlformats.org/drawingml/2006/main" xmlns:r="http://schemas.openxmlformats.org/officeDocument/2006/relationships" xmlns:p="http://schemas.openxmlformats.org/presentationml/2006/main">
+  <p:cSld>
+    <p:spTree>
+      <p:nvGrpSpPr>
+        <p:cNvPr id="1" name=""/>
+        <p:cNvGrpSpPr/>
+        <p:nvPr/>
+      </p:nvGrpSpPr>
+      <p:grpSpPr>
+        <a:xfrm>
+          <a:off x="0" y="0"/>
+          <a:ext cx="0" cy="0"/>
+          <a:chOff x="0" y="0"/>
+          <a:chExt cx="0" cy="0"/>
+        </a:xfrm>
+      </p:grpSpPr>
+      <p:sp>
+        <p:nvSpPr>
+          <p:cNvPr id="2" name="Slide Image Placeholder 1"/>
+          <p:cNvSpPr>
+            <a:spLocks noGrp="1" noRot="1" noChangeAspect="1"/>
+          </p:cNvSpPr>
+          <p:nvPr>
+            <p:ph type="sldImg"/>
+          </p:nvPr>
+        </p:nvSpPr>
+        <p:spPr/>
+      </p:sp>
+      <p:sp>
+        <p:nvSpPr>
+          <p:cNvPr id="3" name="Notes Placeholder 2"/>
+          <p:cNvSpPr>
+            <a:spLocks noGrp="1"/>
+          </p:cNvSpPr>
+          <p:nvPr>
+            <p:ph type="body" idx="1"/>
+          </p:nvPr>
+        </p:nvSpPr>
+        <p:spPr/>
+        <p:txBody>
+          <a:bodyPr/>
+          <a:lstStyle/>
+          <a:p>
+            <a:r>
+              <a:rPr lang="en-US" dirty="0"/>
+              <a:t>Close on the gaps. That is the part we defend most.</a:t>
+            </a:r>
+            <a:endParaRPr lang="en-US" dirty="0"/>
+          </a:p>
+        </p:txBody>
+      </p:sp>
+      <p:sp>
+        <p:nvSpPr>
+          <p:cNvPr id="4" name="Slide Number Placeholder 3"/>
+          <p:cNvSpPr>
+            <a:spLocks noGrp="1"/>
+          </p:cNvSpPr>
+          <p:nvPr>
+            <p:ph type="sldNum" sz="quarter" idx="10"/>
+          </p:nvPr>
+        </p:nvSpPr>
+        <p:spPr/>
+        <p:txBody>
+          <a:bodyPr/>
+          <a:lstStyle/>
+          <a:p>
+            <a:fld id="{F7021451-1387-4CA6-816F-3879F97B5CBC}" type="slidenum">
+              <a:rPr lang="en-US"/>
+              <a:t>12</a:t>
             </a:fld>
             <a:endParaRPr lang="en-US"/>
           </a:p>
@@ -1127,7 +1305,7 @@
           <a:p>
             <a:r>
               <a:rPr lang="en-US" dirty="0"/>
-              <a:t>Operator decides, PM serializes, dev/qa execute with gates. Three lanes, two approvals, one PR.</a:t>
+              <a:t>Greenfield: /asdlc-project. Brownfield: /asdlc-adopt. Doctor verifies at any stage. Each stage = one skill lane.</a:t>
             </a:r>
             <a:endParaRPr lang="en-US" dirty="0"/>
           </a:p>
@@ -1215,7 +1393,7 @@
           <a:p>
             <a:r>
               <a:rPr lang="en-US" dirty="0"/>
-              <a:t>Install verified live via fcc-claude earlier. Cases: named, and confounds labeled.</a:t>
+              <a:t>Operator decides, PM serializes, dev/qa execute with gates. Three lanes, two approvals, one PR.</a:t>
             </a:r>
             <a:endParaRPr lang="en-US" dirty="0"/>
           </a:p>
@@ -1303,7 +1481,7 @@
           <a:p>
             <a:r>
               <a:rPr lang="en-US" dirty="0"/>
-              <a:t>4 runs, 3 arms, real numbers, real gaps. Read the R4 line out loud: the guardrail is advisory — that is the honesty that earns trust.</a:t>
+              <a:t>Install verified live via fcc-claude earlier. Cases: named, and confounds labeled.</a:t>
             </a:r>
             <a:endParaRPr lang="en-US" dirty="0"/>
           </a:p>
@@ -2213,6 +2391,1834 @@
     <p:bg>
       <p:bgPr>
         <a:solidFill>
+          <a:srgbClr val="FFFFFF"/>
+        </a:solidFill>
+      </p:bgPr>
+    </p:bg>
+    <p:spTree>
+      <p:nvGrpSpPr>
+        <p:cNvPr id="1" name=""/>
+        <p:cNvGrpSpPr/>
+        <p:nvPr/>
+      </p:nvGrpSpPr>
+      <p:grpSpPr>
+        <a:xfrm>
+          <a:off x="0" y="0"/>
+          <a:ext cx="0" cy="0"/>
+          <a:chOff x="0" y="0"/>
+          <a:chExt cx="0" cy="0"/>
+        </a:xfrm>
+      </p:grpSpPr>
+      <p:sp>
+        <p:nvSpPr>
+          <p:cNvPr id="2" name="Text 0"/>
+          <p:cNvSpPr/>
+          <p:nvPr/>
+        </p:nvSpPr>
+        <p:spPr>
+          <a:xfrm>
+            <a:off x="502920" y="256032"/>
+            <a:ext cx="10972800" cy="292608"/>
+          </a:xfrm>
+          <a:prstGeom prst="rect">
+            <a:avLst/>
+          </a:prstGeom>
+          <a:noFill/>
+          <a:ln/>
+        </p:spPr>
+        <p:txBody>
+          <a:bodyPr wrap="square" rtlCol="0" anchor="ctr"/>
+          <a:lstStyle/>
+          <a:p>
+            <a:pPr indent="0" marL="0">
+              <a:buNone/>
+            </a:pPr>
+            <a:r>
+              <a:rPr lang="en-US" sz="1300" b="1" spc="200" kern="0" dirty="0">
+                <a:solidFill>
+                  <a:srgbClr val="B98A00"/>
+                </a:solidFill>
+                <a:latin typeface="Calibri" pitchFamily="34" charset="0"/>
+                <a:ea typeface="Calibri" pitchFamily="34" charset="-122"/>
+                <a:cs typeface="Calibri" pitchFamily="34" charset="-120"/>
+              </a:rPr>
+              <a:t>METHODOLOGY FIRST</a:t>
+            </a:r>
+            <a:endParaRPr lang="en-US" sz="1300" dirty="0"/>
+          </a:p>
+        </p:txBody>
+      </p:sp>
+      <p:sp>
+        <p:nvSpPr>
+          <p:cNvPr id="3" name="Text 1"/>
+          <p:cNvSpPr/>
+          <p:nvPr/>
+        </p:nvSpPr>
+        <p:spPr>
+          <a:xfrm>
+            <a:off x="502920" y="548640"/>
+            <a:ext cx="11155680" cy="822960"/>
+          </a:xfrm>
+          <a:prstGeom prst="rect">
+            <a:avLst/>
+          </a:prstGeom>
+          <a:noFill/>
+          <a:ln/>
+        </p:spPr>
+        <p:txBody>
+          <a:bodyPr wrap="square" rtlCol="0" anchor="ctr"/>
+          <a:lstStyle/>
+          <a:p>
+            <a:pPr indent="0" marL="0">
+              <a:buNone/>
+            </a:pPr>
+            <a:r>
+              <a:rPr lang="en-US" sz="4400" b="1" dirty="0">
+                <a:solidFill>
+                  <a:srgbClr val="1E2761"/>
+                </a:solidFill>
+                <a:latin typeface="Cambria" pitchFamily="34" charset="0"/>
+                <a:ea typeface="Cambria" pitchFamily="34" charset="-122"/>
+                <a:cs typeface="Cambria" pitchFamily="34" charset="-120"/>
+              </a:rPr>
+              <a:t>How we benchmark</a:t>
+            </a:r>
+            <a:endParaRPr lang="en-US" sz="4400" dirty="0"/>
+          </a:p>
+        </p:txBody>
+      </p:sp>
+      <p:sp>
+        <p:nvSpPr>
+          <p:cNvPr id="4" name="Text 2"/>
+          <p:cNvSpPr/>
+          <p:nvPr/>
+        </p:nvSpPr>
+        <p:spPr>
+          <a:xfrm>
+            <a:off x="502920" y="1371600"/>
+            <a:ext cx="11155680" cy="457200"/>
+          </a:xfrm>
+          <a:prstGeom prst="rect">
+            <a:avLst/>
+          </a:prstGeom>
+          <a:noFill/>
+          <a:ln/>
+        </p:spPr>
+        <p:txBody>
+          <a:bodyPr wrap="square" rtlCol="0" anchor="ctr"/>
+          <a:lstStyle/>
+          <a:p>
+            <a:pPr indent="0" marL="0">
+              <a:buNone/>
+            </a:pPr>
+            <a:r>
+              <a:rPr lang="en-US" sz="2000" dirty="0">
+                <a:solidFill>
+                  <a:srgbClr val="6B7280"/>
+                </a:solidFill>
+                <a:latin typeface="Calibri" pitchFamily="34" charset="0"/>
+                <a:ea typeface="Calibri" pitchFamily="34" charset="-122"/>
+                <a:cs typeface="Calibri" pitchFamily="34" charset="-120"/>
+              </a:rPr>
+              <a:t>Context before numbers — same model, frozen tasks, metered, non-merge.</a:t>
+            </a:r>
+            <a:endParaRPr lang="en-US" sz="2000" dirty="0"/>
+          </a:p>
+        </p:txBody>
+      </p:sp>
+      <p:sp>
+        <p:nvSpPr>
+          <p:cNvPr id="5" name="Shape 3"/>
+          <p:cNvSpPr/>
+          <p:nvPr/>
+        </p:nvSpPr>
+        <p:spPr>
+          <a:xfrm>
+            <a:off x="685800" y="2148840"/>
+            <a:ext cx="10835640" cy="658368"/>
+          </a:xfrm>
+          <a:prstGeom prst="roundRect">
+            <a:avLst>
+              <a:gd name="adj" fmla="val 13889"/>
+            </a:avLst>
+          </a:prstGeom>
+          <a:solidFill>
+            <a:srgbClr val="F8FAFC"/>
+          </a:solidFill>
+          <a:ln w="15875">
+            <a:solidFill>
+              <a:srgbClr val="D1D5DB"/>
+            </a:solidFill>
+            <a:prstDash val="solid"/>
+          </a:ln>
+        </p:spPr>
+      </p:sp>
+      <p:sp>
+        <p:nvSpPr>
+          <p:cNvPr id="6" name="Text 4"/>
+          <p:cNvSpPr/>
+          <p:nvPr/>
+        </p:nvSpPr>
+        <p:spPr>
+          <a:xfrm>
+            <a:off x="914400" y="2258568"/>
+            <a:ext cx="1737360" cy="457200"/>
+          </a:xfrm>
+          <a:prstGeom prst="rect">
+            <a:avLst/>
+          </a:prstGeom>
+          <a:noFill/>
+          <a:ln/>
+        </p:spPr>
+        <p:txBody>
+          <a:bodyPr wrap="square" rtlCol="0" anchor="ctr"/>
+          <a:lstStyle/>
+          <a:p>
+            <a:pPr indent="0" marL="0">
+              <a:buNone/>
+            </a:pPr>
+            <a:r>
+              <a:rPr lang="en-US" sz="1400" b="1" dirty="0">
+                <a:solidFill>
+                  <a:srgbClr val="1E2761"/>
+                </a:solidFill>
+                <a:latin typeface="Calibri" pitchFamily="34" charset="0"/>
+                <a:ea typeface="Calibri" pitchFamily="34" charset="-122"/>
+                <a:cs typeface="Calibri" pitchFamily="34" charset="-120"/>
+              </a:rPr>
+              <a:t>Arms</a:t>
+            </a:r>
+            <a:endParaRPr lang="en-US" sz="1400" dirty="0"/>
+          </a:p>
+        </p:txBody>
+      </p:sp>
+      <p:sp>
+        <p:nvSpPr>
+          <p:cNvPr id="7" name="Text 5"/>
+          <p:cNvSpPr/>
+          <p:nvPr/>
+        </p:nvSpPr>
+        <p:spPr>
+          <a:xfrm>
+            <a:off x="2788920" y="2258568"/>
+            <a:ext cx="8595360" cy="457200"/>
+          </a:xfrm>
+          <a:prstGeom prst="rect">
+            <a:avLst/>
+          </a:prstGeom>
+          <a:noFill/>
+          <a:ln/>
+        </p:spPr>
+        <p:txBody>
+          <a:bodyPr wrap="square" rtlCol="0" anchor="ctr"/>
+          <a:lstStyle/>
+          <a:p>
+            <a:pPr indent="0" marL="0">
+              <a:buNone/>
+            </a:pPr>
+            <a:r>
+              <a:rPr lang="en-US" sz="1600" dirty="0">
+                <a:solidFill>
+                  <a:srgbClr val="1F2937"/>
+                </a:solidFill>
+                <a:latin typeface="Calibri" pitchFamily="34" charset="0"/>
+                <a:ea typeface="Calibri" pitchFamily="34" charset="-122"/>
+                <a:cs typeface="Calibri" pitchFamily="34" charset="-120"/>
+              </a:rPr>
+              <a:t>B bare · A′ framework passive · A framework activated (routing + lanes)</a:t>
+            </a:r>
+            <a:endParaRPr lang="en-US" sz="1600" dirty="0"/>
+          </a:p>
+        </p:txBody>
+      </p:sp>
+      <p:sp>
+        <p:nvSpPr>
+          <p:cNvPr id="8" name="Shape 6"/>
+          <p:cNvSpPr/>
+          <p:nvPr/>
+        </p:nvSpPr>
+        <p:spPr>
+          <a:xfrm>
+            <a:off x="685800" y="2916936"/>
+            <a:ext cx="10835640" cy="658368"/>
+          </a:xfrm>
+          <a:prstGeom prst="roundRect">
+            <a:avLst>
+              <a:gd name="adj" fmla="val 13889"/>
+            </a:avLst>
+          </a:prstGeom>
+          <a:solidFill>
+            <a:srgbClr val="F8FAFC"/>
+          </a:solidFill>
+          <a:ln w="15875">
+            <a:solidFill>
+              <a:srgbClr val="D1D5DB"/>
+            </a:solidFill>
+            <a:prstDash val="solid"/>
+          </a:ln>
+        </p:spPr>
+      </p:sp>
+      <p:sp>
+        <p:nvSpPr>
+          <p:cNvPr id="9" name="Text 7"/>
+          <p:cNvSpPr/>
+          <p:nvPr/>
+        </p:nvSpPr>
+        <p:spPr>
+          <a:xfrm>
+            <a:off x="914400" y="3026664"/>
+            <a:ext cx="1737360" cy="457200"/>
+          </a:xfrm>
+          <a:prstGeom prst="rect">
+            <a:avLst/>
+          </a:prstGeom>
+          <a:noFill/>
+          <a:ln/>
+        </p:spPr>
+        <p:txBody>
+          <a:bodyPr wrap="square" rtlCol="0" anchor="ctr"/>
+          <a:lstStyle/>
+          <a:p>
+            <a:pPr indent="0" marL="0">
+              <a:buNone/>
+            </a:pPr>
+            <a:r>
+              <a:rPr lang="en-US" sz="1400" b="1" dirty="0">
+                <a:solidFill>
+                  <a:srgbClr val="1E2761"/>
+                </a:solidFill>
+                <a:latin typeface="Calibri" pitchFamily="34" charset="0"/>
+                <a:ea typeface="Calibri" pitchFamily="34" charset="-122"/>
+                <a:cs typeface="Calibri" pitchFamily="34" charset="-120"/>
+              </a:rPr>
+              <a:t>Fairness</a:t>
+            </a:r>
+            <a:endParaRPr lang="en-US" sz="1400" dirty="0"/>
+          </a:p>
+        </p:txBody>
+      </p:sp>
+      <p:sp>
+        <p:nvSpPr>
+          <p:cNvPr id="10" name="Text 8"/>
+          <p:cNvSpPr/>
+          <p:nvPr/>
+        </p:nvSpPr>
+        <p:spPr>
+          <a:xfrm>
+            <a:off x="2788920" y="3026664"/>
+            <a:ext cx="8595360" cy="457200"/>
+          </a:xfrm>
+          <a:prstGeom prst="rect">
+            <a:avLst/>
+          </a:prstGeom>
+          <a:noFill/>
+          <a:ln/>
+        </p:spPr>
+        <p:txBody>
+          <a:bodyPr wrap="square" rtlCol="0" anchor="ctr"/>
+          <a:lstStyle/>
+          <a:p>
+            <a:pPr indent="0" marL="0">
+              <a:buNone/>
+            </a:pPr>
+            <a:r>
+              <a:rPr lang="en-US" sz="1600" dirty="0">
+                <a:solidFill>
+                  <a:srgbClr val="1F2937"/>
+                </a:solidFill>
+                <a:latin typeface="Calibri" pitchFamily="34" charset="0"/>
+                <a:ea typeface="Calibri" pitchFamily="34" charset="-122"/>
+                <a:cs typeface="Calibri" pitchFamily="34" charset="-120"/>
+              </a:rPr>
+              <a:t>Same commit · same model pin · identical frozen task text · same tooling flags</a:t>
+            </a:r>
+            <a:endParaRPr lang="en-US" sz="1600" dirty="0"/>
+          </a:p>
+        </p:txBody>
+      </p:sp>
+      <p:sp>
+        <p:nvSpPr>
+          <p:cNvPr id="11" name="Shape 9"/>
+          <p:cNvSpPr/>
+          <p:nvPr/>
+        </p:nvSpPr>
+        <p:spPr>
+          <a:xfrm>
+            <a:off x="685800" y="3685032"/>
+            <a:ext cx="10835640" cy="658368"/>
+          </a:xfrm>
+          <a:prstGeom prst="roundRect">
+            <a:avLst>
+              <a:gd name="adj" fmla="val 13889"/>
+            </a:avLst>
+          </a:prstGeom>
+          <a:solidFill>
+            <a:srgbClr val="F8FAFC"/>
+          </a:solidFill>
+          <a:ln w="15875">
+            <a:solidFill>
+              <a:srgbClr val="D1D5DB"/>
+            </a:solidFill>
+            <a:prstDash val="solid"/>
+          </a:ln>
+        </p:spPr>
+      </p:sp>
+      <p:sp>
+        <p:nvSpPr>
+          <p:cNvPr id="12" name="Text 10"/>
+          <p:cNvSpPr/>
+          <p:nvPr/>
+        </p:nvSpPr>
+        <p:spPr>
+          <a:xfrm>
+            <a:off x="914400" y="3794760"/>
+            <a:ext cx="1737360" cy="457200"/>
+          </a:xfrm>
+          <a:prstGeom prst="rect">
+            <a:avLst/>
+          </a:prstGeom>
+          <a:noFill/>
+          <a:ln/>
+        </p:spPr>
+        <p:txBody>
+          <a:bodyPr wrap="square" rtlCol="0" anchor="ctr"/>
+          <a:lstStyle/>
+          <a:p>
+            <a:pPr indent="0" marL="0">
+              <a:buNone/>
+            </a:pPr>
+            <a:r>
+              <a:rPr lang="en-US" sz="1400" b="1" dirty="0">
+                <a:solidFill>
+                  <a:srgbClr val="1E2761"/>
+                </a:solidFill>
+                <a:latin typeface="Calibri" pitchFamily="34" charset="0"/>
+                <a:ea typeface="Calibri" pitchFamily="34" charset="-122"/>
+                <a:cs typeface="Calibri" pitchFamily="34" charset="-120"/>
+              </a:rPr>
+              <a:t>Metering</a:t>
+            </a:r>
+            <a:endParaRPr lang="en-US" sz="1400" dirty="0"/>
+          </a:p>
+        </p:txBody>
+      </p:sp>
+      <p:sp>
+        <p:nvSpPr>
+          <p:cNvPr id="13" name="Text 11"/>
+          <p:cNvSpPr/>
+          <p:nvPr/>
+        </p:nvSpPr>
+        <p:spPr>
+          <a:xfrm>
+            <a:off x="2788920" y="3794760"/>
+            <a:ext cx="8595360" cy="457200"/>
+          </a:xfrm>
+          <a:prstGeom prst="rect">
+            <a:avLst/>
+          </a:prstGeom>
+          <a:noFill/>
+          <a:ln/>
+        </p:spPr>
+        <p:txBody>
+          <a:bodyPr wrap="square" rtlCol="0" anchor="ctr"/>
+          <a:lstStyle/>
+          <a:p>
+            <a:pPr indent="0" marL="0">
+              <a:buNone/>
+            </a:pPr>
+            <a:r>
+              <a:rPr lang="en-US" sz="1600" dirty="0">
+                <a:solidFill>
+                  <a:srgbClr val="1F2937"/>
+                </a:solidFill>
+                <a:latin typeface="Calibri" pitchFamily="34" charset="0"/>
+                <a:ea typeface="Calibri" pitchFamily="34" charset="-122"/>
+                <a:cs typeface="Calibri" pitchFamily="34" charset="-120"/>
+              </a:rPr>
+              <a:t>Session JSON: turns, tokens in/out, cost · wall clock · outcome gates (pytest / node --test)</a:t>
+            </a:r>
+            <a:endParaRPr lang="en-US" sz="1600" dirty="0"/>
+          </a:p>
+        </p:txBody>
+      </p:sp>
+      <p:sp>
+        <p:nvSpPr>
+          <p:cNvPr id="14" name="Shape 12"/>
+          <p:cNvSpPr/>
+          <p:nvPr/>
+        </p:nvSpPr>
+        <p:spPr>
+          <a:xfrm>
+            <a:off x="685800" y="4453128"/>
+            <a:ext cx="10835640" cy="658368"/>
+          </a:xfrm>
+          <a:prstGeom prst="roundRect">
+            <a:avLst>
+              <a:gd name="adj" fmla="val 13889"/>
+            </a:avLst>
+          </a:prstGeom>
+          <a:solidFill>
+            <a:srgbClr val="F8FAFC"/>
+          </a:solidFill>
+          <a:ln w="15875">
+            <a:solidFill>
+              <a:srgbClr val="D1D5DB"/>
+            </a:solidFill>
+            <a:prstDash val="solid"/>
+          </a:ln>
+        </p:spPr>
+      </p:sp>
+      <p:sp>
+        <p:nvSpPr>
+          <p:cNvPr id="15" name="Text 13"/>
+          <p:cNvSpPr/>
+          <p:nvPr/>
+        </p:nvSpPr>
+        <p:spPr>
+          <a:xfrm>
+            <a:off x="914400" y="4562856"/>
+            <a:ext cx="1737360" cy="457200"/>
+          </a:xfrm>
+          <a:prstGeom prst="rect">
+            <a:avLst/>
+          </a:prstGeom>
+          <a:noFill/>
+          <a:ln/>
+        </p:spPr>
+        <p:txBody>
+          <a:bodyPr wrap="square" rtlCol="0" anchor="ctr"/>
+          <a:lstStyle/>
+          <a:p>
+            <a:pPr indent="0" marL="0">
+              <a:buNone/>
+            </a:pPr>
+            <a:r>
+              <a:rPr lang="en-US" sz="1400" b="1" dirty="0">
+                <a:solidFill>
+                  <a:srgbClr val="1E2761"/>
+                </a:solidFill>
+                <a:latin typeface="Calibri" pitchFamily="34" charset="0"/>
+                <a:ea typeface="Calibri" pitchFamily="34" charset="-122"/>
+                <a:cs typeface="Calibri" pitchFamily="34" charset="-120"/>
+              </a:rPr>
+              <a:t>Safety</a:t>
+            </a:r>
+            <a:endParaRPr lang="en-US" sz="1400" dirty="0"/>
+          </a:p>
+        </p:txBody>
+      </p:sp>
+      <p:sp>
+        <p:nvSpPr>
+          <p:cNvPr id="16" name="Text 14"/>
+          <p:cNvSpPr/>
+          <p:nvPr/>
+        </p:nvSpPr>
+        <p:spPr>
+          <a:xfrm>
+            <a:off x="2788920" y="4562856"/>
+            <a:ext cx="8595360" cy="457200"/>
+          </a:xfrm>
+          <a:prstGeom prst="rect">
+            <a:avLst/>
+          </a:prstGeom>
+          <a:noFill/>
+          <a:ln/>
+        </p:spPr>
+        <p:txBody>
+          <a:bodyPr wrap="square" rtlCol="0" anchor="ctr"/>
+          <a:lstStyle/>
+          <a:p>
+            <a:pPr indent="0" marL="0">
+              <a:buNone/>
+            </a:pPr>
+            <a:r>
+              <a:rPr lang="en-US" sz="1600" dirty="0">
+                <a:solidFill>
+                  <a:srgbClr val="1F2937"/>
+                </a:solidFill>
+                <a:latin typeface="Calibri" pitchFamily="34" charset="0"/>
+                <a:ea typeface="Calibri" pitchFamily="34" charset="-122"/>
+                <a:cs typeface="Calibri" pitchFamily="34" charset="-120"/>
+              </a:rPr>
+              <a:t>Offline acceptance (no live DB, no deploys) · exp branches, never merged to main</a:t>
+            </a:r>
+            <a:endParaRPr lang="en-US" sz="1600" dirty="0"/>
+          </a:p>
+        </p:txBody>
+      </p:sp>
+      <p:sp>
+        <p:nvSpPr>
+          <p:cNvPr id="17" name="Shape 15"/>
+          <p:cNvSpPr/>
+          <p:nvPr/>
+        </p:nvSpPr>
+        <p:spPr>
+          <a:xfrm>
+            <a:off x="685800" y="5221224"/>
+            <a:ext cx="10835640" cy="658368"/>
+          </a:xfrm>
+          <a:prstGeom prst="roundRect">
+            <a:avLst>
+              <a:gd name="adj" fmla="val 13889"/>
+            </a:avLst>
+          </a:prstGeom>
+          <a:solidFill>
+            <a:srgbClr val="F8FAFC"/>
+          </a:solidFill>
+          <a:ln w="15875">
+            <a:solidFill>
+              <a:srgbClr val="D1D5DB"/>
+            </a:solidFill>
+            <a:prstDash val="solid"/>
+          </a:ln>
+        </p:spPr>
+      </p:sp>
+      <p:sp>
+        <p:nvSpPr>
+          <p:cNvPr id="18" name="Text 16"/>
+          <p:cNvSpPr/>
+          <p:nvPr/>
+        </p:nvSpPr>
+        <p:spPr>
+          <a:xfrm>
+            <a:off x="914400" y="5330952"/>
+            <a:ext cx="1737360" cy="457200"/>
+          </a:xfrm>
+          <a:prstGeom prst="rect">
+            <a:avLst/>
+          </a:prstGeom>
+          <a:noFill/>
+          <a:ln/>
+        </p:spPr>
+        <p:txBody>
+          <a:bodyPr wrap="square" rtlCol="0" anchor="ctr"/>
+          <a:lstStyle/>
+          <a:p>
+            <a:pPr indent="0" marL="0">
+              <a:buNone/>
+            </a:pPr>
+            <a:r>
+              <a:rPr lang="en-US" sz="1400" b="1" dirty="0">
+                <a:solidFill>
+                  <a:srgbClr val="1E2761"/>
+                </a:solidFill>
+                <a:latin typeface="Calibri" pitchFamily="34" charset="0"/>
+                <a:ea typeface="Calibri" pitchFamily="34" charset="-122"/>
+                <a:cs typeface="Calibri" pitchFamily="34" charset="-120"/>
+              </a:rPr>
+              <a:t>Scoring</a:t>
+            </a:r>
+            <a:endParaRPr lang="en-US" sz="1400" dirty="0"/>
+          </a:p>
+        </p:txBody>
+      </p:sp>
+      <p:sp>
+        <p:nvSpPr>
+          <p:cNvPr id="19" name="Text 17"/>
+          <p:cNvSpPr/>
+          <p:nvPr/>
+        </p:nvSpPr>
+        <p:spPr>
+          <a:xfrm>
+            <a:off x="2788920" y="5330952"/>
+            <a:ext cx="8595360" cy="457200"/>
+          </a:xfrm>
+          <a:prstGeom prst="rect">
+            <a:avLst/>
+          </a:prstGeom>
+          <a:noFill/>
+          <a:ln/>
+        </p:spPr>
+        <p:txBody>
+          <a:bodyPr wrap="square" rtlCol="0" anchor="ctr"/>
+          <a:lstStyle/>
+          <a:p>
+            <a:pPr indent="0" marL="0">
+              <a:buNone/>
+            </a:pPr>
+            <a:r>
+              <a:rPr lang="en-US" sz="1600" dirty="0">
+                <a:solidFill>
+                  <a:srgbClr val="1F2937"/>
+                </a:solidFill>
+                <a:latin typeface="Calibri" pitchFamily="34" charset="0"/>
+                <a:ea typeface="Calibri" pitchFamily="34" charset="-122"/>
+                <a:cs typeface="Calibri" pitchFamily="34" charset="-120"/>
+              </a:rPr>
+              <a:t>Acceptance + hidden rubric checks (crash-safety, idempotency, concurrency) + traceability (spec→plan→tasks artifacts)</a:t>
+            </a:r>
+            <a:endParaRPr lang="en-US" sz="1600" dirty="0"/>
+          </a:p>
+        </p:txBody>
+      </p:sp>
+      <p:sp>
+        <p:nvSpPr>
+          <p:cNvPr id="20" name="Text 18"/>
+          <p:cNvSpPr/>
+          <p:nvPr/>
+        </p:nvSpPr>
+        <p:spPr>
+          <a:xfrm>
+            <a:off x="685800" y="6035040"/>
+            <a:ext cx="10835640" cy="457200"/>
+          </a:xfrm>
+          <a:prstGeom prst="rect">
+            <a:avLst/>
+          </a:prstGeom>
+          <a:noFill/>
+          <a:ln/>
+        </p:spPr>
+        <p:txBody>
+          <a:bodyPr wrap="square" rtlCol="0" anchor="ctr"/>
+          <a:lstStyle/>
+          <a:p>
+            <a:pPr indent="0" marL="0">
+              <a:buNone/>
+            </a:pPr>
+            <a:r>
+              <a:rPr lang="en-US" sz="1400" i="1" dirty="0">
+                <a:solidFill>
+                  <a:srgbClr val="6B7280"/>
+                </a:solidFill>
+                <a:latin typeface="Calibri" pitchFamily="34" charset="0"/>
+                <a:ea typeface="Calibri" pitchFamily="34" charset="-122"/>
+                <a:cs typeface="Calibri" pitchFamily="34" charset="-120"/>
+              </a:rPr>
+              <a:t>Everything on this deck's results slide came from the bench kit in the repo — rerun any cell with one command (docs/benchmarks/BENCHMARK-SUMMARY.md).</a:t>
+            </a:r>
+            <a:endParaRPr lang="en-US" sz="1400" dirty="0"/>
+          </a:p>
+        </p:txBody>
+      </p:sp>
+    </p:spTree>
+  </p:cSld>
+  <p:clrMapOvr>
+    <a:masterClrMapping/>
+  </p:clrMapOvr>
+</p:sld>
+</file>
+
+<file path=ppt/slides/slide11.xml><?xml version="1.0" encoding="utf-8"?>
+<p:sld xmlns:a="http://schemas.openxmlformats.org/drawingml/2006/main" xmlns:r="http://schemas.openxmlformats.org/officeDocument/2006/relationships" xmlns:p="http://schemas.openxmlformats.org/presentationml/2006/main">
+  <p:cSld name="Slide 11">
+    <p:bg>
+      <p:bgPr>
+        <a:solidFill>
+          <a:srgbClr val="FFFFFF"/>
+        </a:solidFill>
+      </p:bgPr>
+    </p:bg>
+    <p:spTree>
+      <p:nvGrpSpPr>
+        <p:cNvPr id="1" name=""/>
+        <p:cNvGrpSpPr/>
+        <p:nvPr/>
+      </p:nvGrpSpPr>
+      <p:grpSpPr>
+        <a:xfrm>
+          <a:off x="0" y="0"/>
+          <a:ext cx="0" cy="0"/>
+          <a:chOff x="0" y="0"/>
+          <a:chExt cx="0" cy="0"/>
+        </a:xfrm>
+      </p:grpSpPr>
+      <p:sp>
+        <p:nvSpPr>
+          <p:cNvPr id="2" name="Text 0"/>
+          <p:cNvSpPr/>
+          <p:nvPr/>
+        </p:nvSpPr>
+        <p:spPr>
+          <a:xfrm>
+            <a:off x="502920" y="256032"/>
+            <a:ext cx="10972800" cy="292608"/>
+          </a:xfrm>
+          <a:prstGeom prst="rect">
+            <a:avLst/>
+          </a:prstGeom>
+          <a:noFill/>
+          <a:ln/>
+        </p:spPr>
+        <p:txBody>
+          <a:bodyPr wrap="square" rtlCol="0" anchor="ctr"/>
+          <a:lstStyle/>
+          <a:p>
+            <a:pPr indent="0" marL="0">
+              <a:buNone/>
+            </a:pPr>
+            <a:r>
+              <a:rPr lang="en-US" sz="1300" b="1" spc="200" kern="0" dirty="0">
+                <a:solidFill>
+                  <a:srgbClr val="B98A00"/>
+                </a:solidFill>
+                <a:latin typeface="Calibri" pitchFamily="34" charset="0"/>
+                <a:ea typeface="Calibri" pitchFamily="34" charset="-122"/>
+                <a:cs typeface="Calibri" pitchFamily="34" charset="-120"/>
+              </a:rPr>
+              <a:t>BENCHMARK · 4 RUNS, 3 ARMS</a:t>
+            </a:r>
+            <a:endParaRPr lang="en-US" sz="1300" dirty="0"/>
+          </a:p>
+        </p:txBody>
+      </p:sp>
+      <p:sp>
+        <p:nvSpPr>
+          <p:cNvPr id="3" name="Text 1"/>
+          <p:cNvSpPr/>
+          <p:nvPr/>
+        </p:nvSpPr>
+        <p:spPr>
+          <a:xfrm>
+            <a:off x="502920" y="548640"/>
+            <a:ext cx="11155680" cy="822960"/>
+          </a:xfrm>
+          <a:prstGeom prst="rect">
+            <a:avLst/>
+          </a:prstGeom>
+          <a:noFill/>
+          <a:ln/>
+        </p:spPr>
+        <p:txBody>
+          <a:bodyPr wrap="square" rtlCol="0" anchor="ctr"/>
+          <a:lstStyle/>
+          <a:p>
+            <a:pPr indent="0" marL="0">
+              <a:buNone/>
+            </a:pPr>
+            <a:r>
+              <a:rPr lang="en-US" sz="4400" b="1" dirty="0">
+                <a:solidFill>
+                  <a:srgbClr val="1E2761"/>
+                </a:solidFill>
+                <a:latin typeface="Cambria" pitchFamily="34" charset="0"/>
+                <a:ea typeface="Cambria" pitchFamily="34" charset="-122"/>
+                <a:cs typeface="Cambria" pitchFamily="34" charset="-120"/>
+              </a:rPr>
+              <a:t>Measured: bare vs passive vs activated</a:t>
+            </a:r>
+            <a:endParaRPr lang="en-US" sz="4400" dirty="0"/>
+          </a:p>
+        </p:txBody>
+      </p:sp>
+      <p:sp>
+        <p:nvSpPr>
+          <p:cNvPr id="4" name="Text 2"/>
+          <p:cNvSpPr/>
+          <p:nvPr/>
+        </p:nvSpPr>
+        <p:spPr>
+          <a:xfrm>
+            <a:off x="502920" y="1371600"/>
+            <a:ext cx="11155680" cy="457200"/>
+          </a:xfrm>
+          <a:prstGeom prst="rect">
+            <a:avLst/>
+          </a:prstGeom>
+          <a:noFill/>
+          <a:ln/>
+        </p:spPr>
+        <p:txBody>
+          <a:bodyPr wrap="square" rtlCol="0" anchor="ctr"/>
+          <a:lstStyle/>
+          <a:p>
+            <a:pPr indent="0" marL="0">
+              <a:buNone/>
+            </a:pPr>
+            <a:r>
+              <a:rPr lang="en-US" sz="2000" dirty="0">
+                <a:solidFill>
+                  <a:srgbClr val="6B7280"/>
+                </a:solidFill>
+                <a:latin typeface="Calibri" pitchFamily="34" charset="0"/>
+                <a:ea typeface="Calibri" pitchFamily="34" charset="-122"/>
+                <a:cs typeface="Calibri" pitchFamily="34" charset="-120"/>
+              </a:rPr>
+              <a:t>Same repos · same frozen tasks · same model · metered. Froam exp branches (non-merge).</a:t>
+            </a:r>
+            <a:endParaRPr lang="en-US" sz="2000" dirty="0"/>
+          </a:p>
+        </p:txBody>
+      </p:sp>
+      <p:sp>
+        <p:nvSpPr>
+          <p:cNvPr id="5" name="Text 3"/>
+          <p:cNvSpPr/>
+          <p:nvPr/>
+        </p:nvSpPr>
+        <p:spPr>
+          <a:xfrm>
+            <a:off x="822960" y="1828800"/>
+            <a:ext cx="2834640" cy="274320"/>
+          </a:xfrm>
+          <a:prstGeom prst="rect">
+            <a:avLst/>
+          </a:prstGeom>
+          <a:noFill/>
+          <a:ln/>
+        </p:spPr>
+        <p:txBody>
+          <a:bodyPr wrap="square" rtlCol="0" anchor="ctr"/>
+          <a:lstStyle/>
+          <a:p>
+            <a:pPr indent="0" marL="0">
+              <a:buNone/>
+            </a:pPr>
+            <a:r>
+              <a:rPr lang="en-US" sz="1100" b="1" dirty="0">
+                <a:solidFill>
+                  <a:srgbClr val="6B7280"/>
+                </a:solidFill>
+                <a:latin typeface="Calibri" pitchFamily="34" charset="0"/>
+                <a:ea typeface="Calibri" pitchFamily="34" charset="-122"/>
+                <a:cs typeface="Calibri" pitchFamily="34" charset="-120"/>
+              </a:rPr>
+              <a:t>TASK</a:t>
+            </a:r>
+            <a:endParaRPr lang="en-US" sz="1100" dirty="0"/>
+          </a:p>
+        </p:txBody>
+      </p:sp>
+      <p:sp>
+        <p:nvSpPr>
+          <p:cNvPr id="6" name="Text 4"/>
+          <p:cNvSpPr/>
+          <p:nvPr/>
+        </p:nvSpPr>
+        <p:spPr>
+          <a:xfrm>
+            <a:off x="3749040" y="1828800"/>
+            <a:ext cx="2377440" cy="274320"/>
+          </a:xfrm>
+          <a:prstGeom prst="rect">
+            <a:avLst/>
+          </a:prstGeom>
+          <a:noFill/>
+          <a:ln/>
+        </p:spPr>
+        <p:txBody>
+          <a:bodyPr wrap="square" rtlCol="0" anchor="ctr"/>
+          <a:lstStyle/>
+          <a:p>
+            <a:pPr algn="ctr" indent="0" marL="0">
+              <a:buNone/>
+            </a:pPr>
+            <a:r>
+              <a:rPr lang="en-US" sz="1100" b="1" dirty="0">
+                <a:solidFill>
+                  <a:srgbClr val="6B7280"/>
+                </a:solidFill>
+                <a:latin typeface="Calibri" pitchFamily="34" charset="0"/>
+                <a:ea typeface="Calibri" pitchFamily="34" charset="-122"/>
+                <a:cs typeface="Calibri" pitchFamily="34" charset="-120"/>
+              </a:rPr>
+              <a:t>B · BARE</a:t>
+            </a:r>
+            <a:endParaRPr lang="en-US" sz="1100" dirty="0"/>
+          </a:p>
+        </p:txBody>
+      </p:sp>
+      <p:sp>
+        <p:nvSpPr>
+          <p:cNvPr id="7" name="Text 5"/>
+          <p:cNvSpPr/>
+          <p:nvPr/>
+        </p:nvSpPr>
+        <p:spPr>
+          <a:xfrm>
+            <a:off x="6309360" y="1828800"/>
+            <a:ext cx="2377440" cy="274320"/>
+          </a:xfrm>
+          <a:prstGeom prst="rect">
+            <a:avLst/>
+          </a:prstGeom>
+          <a:noFill/>
+          <a:ln/>
+        </p:spPr>
+        <p:txBody>
+          <a:bodyPr wrap="square" rtlCol="0" anchor="ctr"/>
+          <a:lstStyle/>
+          <a:p>
+            <a:pPr algn="ctr" indent="0" marL="0">
+              <a:buNone/>
+            </a:pPr>
+            <a:r>
+              <a:rPr lang="en-US" sz="1100" b="1" dirty="0">
+                <a:solidFill>
+                  <a:srgbClr val="6B7280"/>
+                </a:solidFill>
+                <a:latin typeface="Calibri" pitchFamily="34" charset="0"/>
+                <a:ea typeface="Calibri" pitchFamily="34" charset="-122"/>
+                <a:cs typeface="Calibri" pitchFamily="34" charset="-120"/>
+              </a:rPr>
+              <a:t>A′ · PASSIVE</a:t>
+            </a:r>
+            <a:endParaRPr lang="en-US" sz="1100" dirty="0"/>
+          </a:p>
+        </p:txBody>
+      </p:sp>
+      <p:sp>
+        <p:nvSpPr>
+          <p:cNvPr id="8" name="Text 6"/>
+          <p:cNvSpPr/>
+          <p:nvPr/>
+        </p:nvSpPr>
+        <p:spPr>
+          <a:xfrm>
+            <a:off x="8869680" y="1828800"/>
+            <a:ext cx="2560320" cy="274320"/>
+          </a:xfrm>
+          <a:prstGeom prst="rect">
+            <a:avLst/>
+          </a:prstGeom>
+          <a:noFill/>
+          <a:ln/>
+        </p:spPr>
+        <p:txBody>
+          <a:bodyPr wrap="square" rtlCol="0" anchor="ctr"/>
+          <a:lstStyle/>
+          <a:p>
+            <a:pPr algn="ctr" indent="0" marL="0">
+              <a:buNone/>
+            </a:pPr>
+            <a:r>
+              <a:rPr lang="en-US" sz="1100" b="1" dirty="0">
+                <a:solidFill>
+                  <a:srgbClr val="6B7280"/>
+                </a:solidFill>
+                <a:latin typeface="Calibri" pitchFamily="34" charset="0"/>
+                <a:ea typeface="Calibri" pitchFamily="34" charset="-122"/>
+                <a:cs typeface="Calibri" pitchFamily="34" charset="-120"/>
+              </a:rPr>
+              <a:t>A · ACTIVATED</a:t>
+            </a:r>
+            <a:endParaRPr lang="en-US" sz="1100" dirty="0"/>
+          </a:p>
+        </p:txBody>
+      </p:sp>
+      <p:sp>
+        <p:nvSpPr>
+          <p:cNvPr id="9" name="Shape 7"/>
+          <p:cNvSpPr/>
+          <p:nvPr/>
+        </p:nvSpPr>
+        <p:spPr>
+          <a:xfrm>
+            <a:off x="685800" y="2148840"/>
+            <a:ext cx="10835640" cy="658368"/>
+          </a:xfrm>
+          <a:prstGeom prst="roundRect">
+            <a:avLst>
+              <a:gd name="adj" fmla="val 13889"/>
+            </a:avLst>
+          </a:prstGeom>
+          <a:solidFill>
+            <a:srgbClr val="F8FAFC"/>
+          </a:solidFill>
+          <a:ln w="15875">
+            <a:solidFill>
+              <a:srgbClr val="D1D5DB"/>
+            </a:solidFill>
+            <a:prstDash val="solid"/>
+          </a:ln>
+        </p:spPr>
+      </p:sp>
+      <p:sp>
+        <p:nvSpPr>
+          <p:cNvPr id="10" name="Text 8"/>
+          <p:cNvSpPr/>
+          <p:nvPr/>
+        </p:nvSpPr>
+        <p:spPr>
+          <a:xfrm>
+            <a:off x="822960" y="2276856"/>
+            <a:ext cx="2834640" cy="411480"/>
+          </a:xfrm>
+          <a:prstGeom prst="rect">
+            <a:avLst/>
+          </a:prstGeom>
+          <a:noFill/>
+          <a:ln/>
+        </p:spPr>
+        <p:txBody>
+          <a:bodyPr wrap="square" rtlCol="0" anchor="ctr"/>
+          <a:lstStyle/>
+          <a:p>
+            <a:pPr indent="0" marL="0">
+              <a:buNone/>
+            </a:pPr>
+            <a:r>
+              <a:rPr lang="en-US" sz="1200" b="1" dirty="0">
+                <a:solidFill>
+                  <a:srgbClr val="1E2761"/>
+                </a:solidFill>
+                <a:latin typeface="Calibri" pitchFamily="34" charset="0"/>
+                <a:ea typeface="Calibri" pitchFamily="34" charset="-122"/>
+                <a:cs typeface="Calibri" pitchFamily="34" charset="-120"/>
+              </a:rPr>
+              <a:t>R1 · add-tests (trivial)</a:t>
+            </a:r>
+            <a:endParaRPr lang="en-US" sz="1200" dirty="0"/>
+          </a:p>
+        </p:txBody>
+      </p:sp>
+      <p:sp>
+        <p:nvSpPr>
+          <p:cNvPr id="11" name="Text 9"/>
+          <p:cNvSpPr/>
+          <p:nvPr/>
+        </p:nvSpPr>
+        <p:spPr>
+          <a:xfrm>
+            <a:off x="3749040" y="2276856"/>
+            <a:ext cx="2377440" cy="411480"/>
+          </a:xfrm>
+          <a:prstGeom prst="rect">
+            <a:avLst/>
+          </a:prstGeom>
+          <a:noFill/>
+          <a:ln/>
+        </p:spPr>
+        <p:txBody>
+          <a:bodyPr wrap="square" rtlCol="0" anchor="ctr"/>
+          <a:lstStyle/>
+          <a:p>
+            <a:pPr algn="ctr" indent="0" marL="0">
+              <a:buNone/>
+            </a:pPr>
+            <a:r>
+              <a:rPr lang="en-US" sz="1150" dirty="0">
+                <a:solidFill>
+                  <a:srgbClr val="1F2937"/>
+                </a:solidFill>
+                <a:latin typeface="Calibri" pitchFamily="34" charset="0"/>
+                <a:ea typeface="Calibri" pitchFamily="34" charset="-122"/>
+                <a:cs typeface="Calibri" pitchFamily="34" charset="-120"/>
+              </a:rPr>
+              <a:t>$0.63 · 6 tests</a:t>
+            </a:r>
+            <a:endParaRPr lang="en-US" sz="1150" dirty="0"/>
+          </a:p>
+        </p:txBody>
+      </p:sp>
+      <p:sp>
+        <p:nvSpPr>
+          <p:cNvPr id="12" name="Text 10"/>
+          <p:cNvSpPr/>
+          <p:nvPr/>
+        </p:nvSpPr>
+        <p:spPr>
+          <a:xfrm>
+            <a:off x="6309360" y="2276856"/>
+            <a:ext cx="2377440" cy="411480"/>
+          </a:xfrm>
+          <a:prstGeom prst="rect">
+            <a:avLst/>
+          </a:prstGeom>
+          <a:noFill/>
+          <a:ln/>
+        </p:spPr>
+        <p:txBody>
+          <a:bodyPr wrap="square" rtlCol="0" anchor="ctr"/>
+          <a:lstStyle/>
+          <a:p>
+            <a:pPr algn="ctr" indent="0" marL="0">
+              <a:buNone/>
+            </a:pPr>
+            <a:r>
+              <a:rPr lang="en-US" sz="1150" dirty="0">
+                <a:solidFill>
+                  <a:srgbClr val="1F2937"/>
+                </a:solidFill>
+                <a:latin typeface="Calibri" pitchFamily="34" charset="0"/>
+                <a:ea typeface="Calibri" pitchFamily="34" charset="-122"/>
+                <a:cs typeface="Calibri" pitchFamily="34" charset="-120"/>
+              </a:rPr>
+              <a:t>$0.62 · 7 tests</a:t>
+            </a:r>
+            <a:endParaRPr lang="en-US" sz="1150" dirty="0"/>
+          </a:p>
+        </p:txBody>
+      </p:sp>
+      <p:sp>
+        <p:nvSpPr>
+          <p:cNvPr id="13" name="Text 11"/>
+          <p:cNvSpPr/>
+          <p:nvPr/>
+        </p:nvSpPr>
+        <p:spPr>
+          <a:xfrm>
+            <a:off x="8869680" y="2276856"/>
+            <a:ext cx="2560320" cy="411480"/>
+          </a:xfrm>
+          <a:prstGeom prst="rect">
+            <a:avLst/>
+          </a:prstGeom>
+          <a:noFill/>
+          <a:ln/>
+        </p:spPr>
+        <p:txBody>
+          <a:bodyPr wrap="square" rtlCol="0" anchor="ctr"/>
+          <a:lstStyle/>
+          <a:p>
+            <a:pPr algn="ctr" indent="0" marL="0">
+              <a:buNone/>
+            </a:pPr>
+            <a:r>
+              <a:rPr lang="en-US" sz="1150" dirty="0">
+                <a:solidFill>
+                  <a:srgbClr val="1B5E20"/>
+                </a:solidFill>
+                <a:latin typeface="Calibri" pitchFamily="34" charset="0"/>
+                <a:ea typeface="Calibri" pitchFamily="34" charset="-122"/>
+                <a:cs typeface="Calibri" pitchFamily="34" charset="-120"/>
+              </a:rPr>
+              <a:t>$0.47 · 10 tests · 2.5× turns</a:t>
+            </a:r>
+            <a:endParaRPr lang="en-US" sz="1150" dirty="0"/>
+          </a:p>
+        </p:txBody>
+      </p:sp>
+      <p:sp>
+        <p:nvSpPr>
+          <p:cNvPr id="14" name="Shape 12"/>
+          <p:cNvSpPr/>
+          <p:nvPr/>
+        </p:nvSpPr>
+        <p:spPr>
+          <a:xfrm>
+            <a:off x="685800" y="2898648"/>
+            <a:ext cx="10835640" cy="658368"/>
+          </a:xfrm>
+          <a:prstGeom prst="roundRect">
+            <a:avLst>
+              <a:gd name="adj" fmla="val 13889"/>
+            </a:avLst>
+          </a:prstGeom>
+          <a:solidFill>
+            <a:srgbClr val="F8FAFC"/>
+          </a:solidFill>
+          <a:ln w="15875">
+            <a:solidFill>
+              <a:srgbClr val="D1D5DB"/>
+            </a:solidFill>
+            <a:prstDash val="solid"/>
+          </a:ln>
+        </p:spPr>
+      </p:sp>
+      <p:sp>
+        <p:nvSpPr>
+          <p:cNvPr id="15" name="Text 13"/>
+          <p:cNvSpPr/>
+          <p:nvPr/>
+        </p:nvSpPr>
+        <p:spPr>
+          <a:xfrm>
+            <a:off x="822960" y="3026664"/>
+            <a:ext cx="2834640" cy="411480"/>
+          </a:xfrm>
+          <a:prstGeom prst="rect">
+            <a:avLst/>
+          </a:prstGeom>
+          <a:noFill/>
+          <a:ln/>
+        </p:spPr>
+        <p:txBody>
+          <a:bodyPr wrap="square" rtlCol="0" anchor="ctr"/>
+          <a:lstStyle/>
+          <a:p>
+            <a:pPr indent="0" marL="0">
+              <a:buNone/>
+            </a:pPr>
+            <a:r>
+              <a:rPr lang="en-US" sz="1200" b="1" dirty="0">
+                <a:solidFill>
+                  <a:srgbClr val="1E2761"/>
+                </a:solidFill>
+                <a:latin typeface="Calibri" pitchFamily="34" charset="0"/>
+                <a:ea typeface="Calibri" pitchFamily="34" charset="-122"/>
+                <a:cs typeface="Calibri" pitchFamily="34" charset="-120"/>
+              </a:rPr>
+              <a:t>R2 · DB + RLS</a:t>
+            </a:r>
+            <a:endParaRPr lang="en-US" sz="1200" dirty="0"/>
+          </a:p>
+        </p:txBody>
+      </p:sp>
+      <p:sp>
+        <p:nvSpPr>
+          <p:cNvPr id="16" name="Text 14"/>
+          <p:cNvSpPr/>
+          <p:nvPr/>
+        </p:nvSpPr>
+        <p:spPr>
+          <a:xfrm>
+            <a:off x="3749040" y="3026664"/>
+            <a:ext cx="2377440" cy="411480"/>
+          </a:xfrm>
+          <a:prstGeom prst="rect">
+            <a:avLst/>
+          </a:prstGeom>
+          <a:noFill/>
+          <a:ln/>
+        </p:spPr>
+        <p:txBody>
+          <a:bodyPr wrap="square" rtlCol="0" anchor="ctr"/>
+          <a:lstStyle/>
+          <a:p>
+            <a:pPr algn="ctr" indent="0" marL="0">
+              <a:buNone/>
+            </a:pPr>
+            <a:r>
+              <a:rPr lang="en-US" sz="1150" dirty="0">
+                <a:solidFill>
+                  <a:srgbClr val="1F2937"/>
+                </a:solidFill>
+                <a:latin typeface="Calibri" pitchFamily="34" charset="0"/>
+                <a:ea typeface="Calibri" pitchFamily="34" charset="-122"/>
+                <a:cs typeface="Calibri" pitchFamily="34" charset="-120"/>
+              </a:rPr>
+              <a:t>$0.22 · 11 tests</a:t>
+            </a:r>
+            <a:endParaRPr lang="en-US" sz="1150" dirty="0"/>
+          </a:p>
+        </p:txBody>
+      </p:sp>
+      <p:sp>
+        <p:nvSpPr>
+          <p:cNvPr id="17" name="Text 15"/>
+          <p:cNvSpPr/>
+          <p:nvPr/>
+        </p:nvSpPr>
+        <p:spPr>
+          <a:xfrm>
+            <a:off x="6309360" y="3026664"/>
+            <a:ext cx="2377440" cy="411480"/>
+          </a:xfrm>
+          <a:prstGeom prst="rect">
+            <a:avLst/>
+          </a:prstGeom>
+          <a:noFill/>
+          <a:ln/>
+        </p:spPr>
+        <p:txBody>
+          <a:bodyPr wrap="square" rtlCol="0" anchor="ctr"/>
+          <a:lstStyle/>
+          <a:p>
+            <a:pPr algn="ctr" indent="0" marL="0">
+              <a:buNone/>
+            </a:pPr>
+            <a:r>
+              <a:rPr lang="en-US" sz="1150" dirty="0">
+                <a:solidFill>
+                  <a:srgbClr val="1F2937"/>
+                </a:solidFill>
+                <a:latin typeface="Calibri" pitchFamily="34" charset="0"/>
+                <a:ea typeface="Calibri" pitchFamily="34" charset="-122"/>
+                <a:cs typeface="Calibri" pitchFamily="34" charset="-120"/>
+              </a:rPr>
+              <a:t>$0.27 · 11 tests</a:t>
+            </a:r>
+            <a:endParaRPr lang="en-US" sz="1150" dirty="0"/>
+          </a:p>
+        </p:txBody>
+      </p:sp>
+      <p:sp>
+        <p:nvSpPr>
+          <p:cNvPr id="18" name="Text 16"/>
+          <p:cNvSpPr/>
+          <p:nvPr/>
+        </p:nvSpPr>
+        <p:spPr>
+          <a:xfrm>
+            <a:off x="8869680" y="3026664"/>
+            <a:ext cx="2560320" cy="411480"/>
+          </a:xfrm>
+          <a:prstGeom prst="rect">
+            <a:avLst/>
+          </a:prstGeom>
+          <a:noFill/>
+          <a:ln/>
+        </p:spPr>
+        <p:txBody>
+          <a:bodyPr wrap="square" rtlCol="0" anchor="ctr"/>
+          <a:lstStyle/>
+          <a:p>
+            <a:pPr algn="ctr" indent="0" marL="0">
+              <a:buNone/>
+            </a:pPr>
+            <a:r>
+              <a:rPr lang="en-US" sz="1150" dirty="0">
+                <a:solidFill>
+                  <a:srgbClr val="1B5E20"/>
+                </a:solidFill>
+                <a:latin typeface="Calibri" pitchFamily="34" charset="0"/>
+                <a:ea typeface="Calibri" pitchFamily="34" charset="-122"/>
+                <a:cs typeface="Calibri" pitchFamily="34" charset="-120"/>
+              </a:rPr>
+              <a:t>$0.67 · 11 tests + plan/QA</a:t>
+            </a:r>
+            <a:endParaRPr lang="en-US" sz="1150" dirty="0"/>
+          </a:p>
+        </p:txBody>
+      </p:sp>
+      <p:sp>
+        <p:nvSpPr>
+          <p:cNvPr id="19" name="Shape 17"/>
+          <p:cNvSpPr/>
+          <p:nvPr/>
+        </p:nvSpPr>
+        <p:spPr>
+          <a:xfrm>
+            <a:off x="685800" y="3648456"/>
+            <a:ext cx="10835640" cy="658368"/>
+          </a:xfrm>
+          <a:prstGeom prst="roundRect">
+            <a:avLst>
+              <a:gd name="adj" fmla="val 13889"/>
+            </a:avLst>
+          </a:prstGeom>
+          <a:solidFill>
+            <a:srgbClr val="F8FAFC"/>
+          </a:solidFill>
+          <a:ln w="15875">
+            <a:solidFill>
+              <a:srgbClr val="D1D5DB"/>
+            </a:solidFill>
+            <a:prstDash val="solid"/>
+          </a:ln>
+        </p:spPr>
+      </p:sp>
+      <p:sp>
+        <p:nvSpPr>
+          <p:cNvPr id="20" name="Text 18"/>
+          <p:cNvSpPr/>
+          <p:nvPr/>
+        </p:nvSpPr>
+        <p:spPr>
+          <a:xfrm>
+            <a:off x="822960" y="3776472"/>
+            <a:ext cx="2834640" cy="411480"/>
+          </a:xfrm>
+          <a:prstGeom prst="rect">
+            <a:avLst/>
+          </a:prstGeom>
+          <a:noFill/>
+          <a:ln/>
+        </p:spPr>
+        <p:txBody>
+          <a:bodyPr wrap="square" rtlCol="0" anchor="ctr"/>
+          <a:lstStyle/>
+          <a:p>
+            <a:pPr indent="0" marL="0">
+              <a:buNone/>
+            </a:pPr>
+            <a:r>
+              <a:rPr lang="en-US" sz="1200" b="1" dirty="0">
+                <a:solidFill>
+                  <a:srgbClr val="1E2761"/>
+                </a:solidFill>
+                <a:latin typeface="Calibri" pitchFamily="34" charset="0"/>
+                <a:ea typeface="Calibri" pitchFamily="34" charset="-122"/>
+                <a:cs typeface="Calibri" pitchFamily="34" charset="-120"/>
+              </a:rPr>
+              <a:t>R4 · fragile refactor</a:t>
+            </a:r>
+            <a:endParaRPr lang="en-US" sz="1200" dirty="0"/>
+          </a:p>
+        </p:txBody>
+      </p:sp>
+      <p:sp>
+        <p:nvSpPr>
+          <p:cNvPr id="21" name="Text 19"/>
+          <p:cNvSpPr/>
+          <p:nvPr/>
+        </p:nvSpPr>
+        <p:spPr>
+          <a:xfrm>
+            <a:off x="3749040" y="3776472"/>
+            <a:ext cx="2377440" cy="411480"/>
+          </a:xfrm>
+          <a:prstGeom prst="rect">
+            <a:avLst/>
+          </a:prstGeom>
+          <a:noFill/>
+          <a:ln/>
+        </p:spPr>
+        <p:txBody>
+          <a:bodyPr wrap="square" rtlCol="0" anchor="ctr"/>
+          <a:lstStyle/>
+          <a:p>
+            <a:pPr algn="ctr" indent="0" marL="0">
+              <a:buNone/>
+            </a:pPr>
+            <a:r>
+              <a:rPr lang="en-US" sz="1150" dirty="0">
+                <a:solidFill>
+                  <a:srgbClr val="1F2937"/>
+                </a:solidFill>
+                <a:latin typeface="Calibri" pitchFamily="34" charset="0"/>
+                <a:ea typeface="Calibri" pitchFamily="34" charset="-122"/>
+                <a:cs typeface="Calibri" pitchFamily="34" charset="-120"/>
+              </a:rPr>
+              <a:t>refused · restraint pass</a:t>
+            </a:r>
+            <a:endParaRPr lang="en-US" sz="1150" dirty="0"/>
+          </a:p>
+        </p:txBody>
+      </p:sp>
+      <p:sp>
+        <p:nvSpPr>
+          <p:cNvPr id="22" name="Text 20"/>
+          <p:cNvSpPr/>
+          <p:nvPr/>
+        </p:nvSpPr>
+        <p:spPr>
+          <a:xfrm>
+            <a:off x="6309360" y="3776472"/>
+            <a:ext cx="2377440" cy="411480"/>
+          </a:xfrm>
+          <a:prstGeom prst="rect">
+            <a:avLst/>
+          </a:prstGeom>
+          <a:noFill/>
+          <a:ln/>
+        </p:spPr>
+        <p:txBody>
+          <a:bodyPr wrap="square" rtlCol="0" anchor="ctr"/>
+          <a:lstStyle/>
+          <a:p>
+            <a:pPr algn="ctr" indent="0" marL="0">
+              <a:buNone/>
+            </a:pPr>
+            <a:r>
+              <a:rPr lang="en-US" sz="1150" dirty="0">
+                <a:solidFill>
+                  <a:srgbClr val="1F2937"/>
+                </a:solidFill>
+                <a:latin typeface="Calibri" pitchFamily="34" charset="0"/>
+                <a:ea typeface="Calibri" pitchFamily="34" charset="-122"/>
+                <a:cs typeface="Calibri" pitchFamily="34" charset="-120"/>
+              </a:rPr>
+              <a:t>—</a:t>
+            </a:r>
+            <a:endParaRPr lang="en-US" sz="1150" dirty="0"/>
+          </a:p>
+        </p:txBody>
+      </p:sp>
+      <p:sp>
+        <p:nvSpPr>
+          <p:cNvPr id="23" name="Text 21"/>
+          <p:cNvSpPr/>
+          <p:nvPr/>
+        </p:nvSpPr>
+        <p:spPr>
+          <a:xfrm>
+            <a:off x="8869680" y="3776472"/>
+            <a:ext cx="2560320" cy="411480"/>
+          </a:xfrm>
+          <a:prstGeom prst="rect">
+            <a:avLst/>
+          </a:prstGeom>
+          <a:noFill/>
+          <a:ln/>
+        </p:spPr>
+        <p:txBody>
+          <a:bodyPr wrap="square" rtlCol="0" anchor="ctr"/>
+          <a:lstStyle/>
+          <a:p>
+            <a:pPr algn="ctr" indent="0" marL="0">
+              <a:buNone/>
+            </a:pPr>
+            <a:r>
+              <a:rPr lang="en-US" sz="1150" dirty="0">
+                <a:solidFill>
+                  <a:srgbClr val="1B5E20"/>
+                </a:solidFill>
+                <a:latin typeface="Calibri" pitchFamily="34" charset="0"/>
+                <a:ea typeface="Calibri" pitchFamily="34" charset="-122"/>
+                <a:cs typeface="Calibri" pitchFamily="34" charset="-120"/>
+              </a:rPr>
+              <a:t>violated (guardrail advisory) · prod-correct when approved</a:t>
+            </a:r>
+            <a:endParaRPr lang="en-US" sz="1150" dirty="0"/>
+          </a:p>
+        </p:txBody>
+      </p:sp>
+      <p:sp>
+        <p:nvSpPr>
+          <p:cNvPr id="24" name="Shape 22"/>
+          <p:cNvSpPr/>
+          <p:nvPr/>
+        </p:nvSpPr>
+        <p:spPr>
+          <a:xfrm>
+            <a:off x="685800" y="4398264"/>
+            <a:ext cx="10835640" cy="658368"/>
+          </a:xfrm>
+          <a:prstGeom prst="roundRect">
+            <a:avLst>
+              <a:gd name="adj" fmla="val 13889"/>
+            </a:avLst>
+          </a:prstGeom>
+          <a:solidFill>
+            <a:srgbClr val="F8FAFC"/>
+          </a:solidFill>
+          <a:ln w="15875">
+            <a:solidFill>
+              <a:srgbClr val="D1D5DB"/>
+            </a:solidFill>
+            <a:prstDash val="solid"/>
+          </a:ln>
+        </p:spPr>
+      </p:sp>
+      <p:sp>
+        <p:nvSpPr>
+          <p:cNvPr id="25" name="Text 23"/>
+          <p:cNvSpPr/>
+          <p:nvPr/>
+        </p:nvSpPr>
+        <p:spPr>
+          <a:xfrm>
+            <a:off x="822960" y="4526280"/>
+            <a:ext cx="2834640" cy="411480"/>
+          </a:xfrm>
+          <a:prstGeom prst="rect">
+            <a:avLst/>
+          </a:prstGeom>
+          <a:noFill/>
+          <a:ln/>
+        </p:spPr>
+        <p:txBody>
+          <a:bodyPr wrap="square" rtlCol="0" anchor="ctr"/>
+          <a:lstStyle/>
+          <a:p>
+            <a:pPr indent="0" marL="0">
+              <a:buNone/>
+            </a:pPr>
+            <a:r>
+              <a:rPr lang="en-US" sz="1200" b="1" dirty="0">
+                <a:solidFill>
+                  <a:srgbClr val="1E2761"/>
+                </a:solidFill>
+                <a:latin typeface="Calibri" pitchFamily="34" charset="0"/>
+                <a:ea typeface="Calibri" pitchFamily="34" charset="-122"/>
+                <a:cs typeface="Calibri" pitchFamily="34" charset="-120"/>
+              </a:rPr>
+              <a:t>R3 · vertical FE+BE</a:t>
+            </a:r>
+            <a:endParaRPr lang="en-US" sz="1200" dirty="0"/>
+          </a:p>
+        </p:txBody>
+      </p:sp>
+      <p:sp>
+        <p:nvSpPr>
+          <p:cNvPr id="26" name="Text 24"/>
+          <p:cNvSpPr/>
+          <p:nvPr/>
+        </p:nvSpPr>
+        <p:spPr>
+          <a:xfrm>
+            <a:off x="3749040" y="4526280"/>
+            <a:ext cx="2377440" cy="411480"/>
+          </a:xfrm>
+          <a:prstGeom prst="rect">
+            <a:avLst/>
+          </a:prstGeom>
+          <a:noFill/>
+          <a:ln/>
+        </p:spPr>
+        <p:txBody>
+          <a:bodyPr wrap="square" rtlCol="0" anchor="ctr"/>
+          <a:lstStyle/>
+          <a:p>
+            <a:pPr algn="ctr" indent="0" marL="0">
+              <a:buNone/>
+            </a:pPr>
+            <a:r>
+              <a:rPr lang="en-US" sz="1150" dirty="0">
+                <a:solidFill>
+                  <a:srgbClr val="1F2937"/>
+                </a:solidFill>
+                <a:latin typeface="Calibri" pitchFamily="34" charset="0"/>
+                <a:ea typeface="Calibri" pitchFamily="34" charset="-122"/>
+                <a:cs typeface="Calibri" pitchFamily="34" charset="-120"/>
+              </a:rPr>
+              <a:t>$0.94 · 4 tests</a:t>
+            </a:r>
+            <a:endParaRPr lang="en-US" sz="1150" dirty="0"/>
+          </a:p>
+        </p:txBody>
+      </p:sp>
+      <p:sp>
+        <p:nvSpPr>
+          <p:cNvPr id="27" name="Text 25"/>
+          <p:cNvSpPr/>
+          <p:nvPr/>
+        </p:nvSpPr>
+        <p:spPr>
+          <a:xfrm>
+            <a:off x="6309360" y="4526280"/>
+            <a:ext cx="2377440" cy="411480"/>
+          </a:xfrm>
+          <a:prstGeom prst="rect">
+            <a:avLst/>
+          </a:prstGeom>
+          <a:noFill/>
+          <a:ln/>
+        </p:spPr>
+        <p:txBody>
+          <a:bodyPr wrap="square" rtlCol="0" anchor="ctr"/>
+          <a:lstStyle/>
+          <a:p>
+            <a:pPr algn="ctr" indent="0" marL="0">
+              <a:buNone/>
+            </a:pPr>
+            <a:r>
+              <a:rPr lang="en-US" sz="1150" dirty="0">
+                <a:solidFill>
+                  <a:srgbClr val="1F2937"/>
+                </a:solidFill>
+                <a:latin typeface="Calibri" pitchFamily="34" charset="0"/>
+                <a:ea typeface="Calibri" pitchFamily="34" charset="-122"/>
+                <a:cs typeface="Calibri" pitchFamily="34" charset="-120"/>
+              </a:rPr>
+              <a:t>—</a:t>
+            </a:r>
+            <a:endParaRPr lang="en-US" sz="1150" dirty="0"/>
+          </a:p>
+        </p:txBody>
+      </p:sp>
+      <p:sp>
+        <p:nvSpPr>
+          <p:cNvPr id="28" name="Text 26"/>
+          <p:cNvSpPr/>
+          <p:nvPr/>
+        </p:nvSpPr>
+        <p:spPr>
+          <a:xfrm>
+            <a:off x="8869680" y="4526280"/>
+            <a:ext cx="2560320" cy="411480"/>
+          </a:xfrm>
+          <a:prstGeom prst="rect">
+            <a:avLst/>
+          </a:prstGeom>
+          <a:noFill/>
+          <a:ln/>
+        </p:spPr>
+        <p:txBody>
+          <a:bodyPr wrap="square" rtlCol="0" anchor="ctr"/>
+          <a:lstStyle/>
+          <a:p>
+            <a:pPr algn="ctr" indent="0" marL="0">
+              <a:buNone/>
+            </a:pPr>
+            <a:r>
+              <a:rPr lang="en-US" sz="1150" dirty="0">
+                <a:solidFill>
+                  <a:srgbClr val="1B5E20"/>
+                </a:solidFill>
+                <a:latin typeface="Calibri" pitchFamily="34" charset="0"/>
+                <a:ea typeface="Calibri" pitchFamily="34" charset="-122"/>
+                <a:cs typeface="Calibri" pitchFamily="34" charset="-120"/>
+              </a:rPr>
+              <a:t>$0.98 · 4 tests + plan/tasks</a:t>
+            </a:r>
+            <a:endParaRPr lang="en-US" sz="1150" dirty="0"/>
+          </a:p>
+        </p:txBody>
+      </p:sp>
+      <p:sp>
+        <p:nvSpPr>
+          <p:cNvPr id="29" name="Text 27"/>
+          <p:cNvSpPr/>
+          <p:nvPr/>
+        </p:nvSpPr>
+        <p:spPr>
+          <a:xfrm>
+            <a:off x="685800" y="5486400"/>
+            <a:ext cx="10835640" cy="502920"/>
+          </a:xfrm>
+          <a:prstGeom prst="rect">
+            <a:avLst/>
+          </a:prstGeom>
+          <a:noFill/>
+          <a:ln/>
+        </p:spPr>
+        <p:txBody>
+          <a:bodyPr wrap="square" rtlCol="0" anchor="ctr"/>
+          <a:lstStyle/>
+          <a:p>
+            <a:pPr indent="0" marL="0">
+              <a:buNone/>
+            </a:pPr>
+            <a:r>
+              <a:rPr lang="en-US" sz="1400" b="1" dirty="0">
+                <a:solidFill>
+                  <a:srgbClr val="1E2761"/>
+                </a:solidFill>
+                <a:latin typeface="Calibri" pitchFamily="34" charset="0"/>
+                <a:ea typeface="Calibri" pitchFamily="34" charset="-122"/>
+                <a:cs typeface="Calibri" pitchFamily="34" charset="-120"/>
+              </a:rPr>
+              <a:t>Findings: passive ≈ bare (placebo) · activation tax scales with ceremony, benefit with risk · restraint is advisory, not structural · QA lane is the value on risky approved change.</a:t>
+            </a:r>
+            <a:endParaRPr lang="en-US" sz="1400" dirty="0"/>
+          </a:p>
+        </p:txBody>
+      </p:sp>
+      <p:sp>
+        <p:nvSpPr>
+          <p:cNvPr id="30" name="Text 28"/>
+          <p:cNvSpPr/>
+          <p:nvPr/>
+        </p:nvSpPr>
+        <p:spPr>
+          <a:xfrm>
+            <a:off x="685800" y="6080760"/>
+            <a:ext cx="10835640" cy="411480"/>
+          </a:xfrm>
+          <a:prstGeom prst="rect">
+            <a:avLst/>
+          </a:prstGeom>
+          <a:noFill/>
+          <a:ln/>
+        </p:spPr>
+        <p:txBody>
+          <a:bodyPr wrap="square" rtlCol="0" anchor="ctr"/>
+          <a:lstStyle/>
+          <a:p>
+            <a:pPr indent="0" marL="0">
+              <a:buNone/>
+            </a:pPr>
+            <a:r>
+              <a:rPr lang="en-US" sz="1400" i="1" dirty="0">
+                <a:solidFill>
+                  <a:srgbClr val="6B7280"/>
+                </a:solidFill>
+                <a:latin typeface="Calibri" pitchFamily="34" charset="0"/>
+                <a:ea typeface="Calibri" pitchFamily="34" charset="-122"/>
+                <a:cs typeface="Calibri" pitchFamily="34" charset="-120"/>
+              </a:rPr>
+              <a:t>Harness gap fixed via dev-agent-router (16→17 skills) · DeepSeek pin since R2 · world anchor: SWE-bench-style floor check pending.</a:t>
+            </a:r>
+            <a:endParaRPr lang="en-US" sz="1400" dirty="0"/>
+          </a:p>
+        </p:txBody>
+      </p:sp>
+    </p:spTree>
+  </p:cSld>
+  <p:clrMapOvr>
+    <a:masterClrMapping/>
+  </p:clrMapOvr>
+</p:sld>
+</file>
+
+<file path=ppt/slides/slide12.xml><?xml version="1.0" encoding="utf-8"?>
+<p:sld xmlns:a="http://schemas.openxmlformats.org/drawingml/2006/main" xmlns:r="http://schemas.openxmlformats.org/officeDocument/2006/relationships" xmlns:p="http://schemas.openxmlformats.org/presentationml/2006/main">
+  <p:cSld name="Slide 12">
+    <p:bg>
+      <p:bgPr>
+        <a:solidFill>
           <a:srgbClr val="1E2761"/>
         </a:solidFill>
       </p:bgPr>
@@ -3606,7 +5612,7 @@
                 <a:ea typeface="Cambria" pitchFamily="34" charset="-122"/>
                 <a:cs typeface="Cambria" pitchFamily="34" charset="-120"/>
               </a:rPr>
-              <a:t>SDLC is an information pipeline. Fix the pipeline, not the prompt.</a:t>
+              <a:t>A standard SDLC, agent-executed: from idea to clean POC.</a:t>
             </a:r>
             <a:endParaRPr lang="en-US" sz="2100" dirty="0"/>
           </a:p>
@@ -3887,7 +5893,7 @@
                 <a:ea typeface="Calibri" pitchFamily="34" charset="-122"/>
                 <a:cs typeface="Calibri" pitchFamily="34" charset="-120"/>
               </a:rPr>
-              <a:t>Non-technical founders, one engineer of support</a:t>
+              <a:t>Technical AND non-technical founders, one engineer of support</a:t>
             </a:r>
             <a:endParaRPr lang="en-US" sz="2000" dirty="0"/>
           </a:p>
@@ -3992,7 +5998,7 @@
                 <a:ea typeface="Calibri" pitchFamily="34" charset="-122"/>
                 <a:cs typeface="Calibri" pitchFamily="34" charset="-120"/>
               </a:rPr>
-              <a:t>A working POC in days, with a quality floor</a:t>
+              <a:t>Idea → working POC in days — clean codebase + docs</a:t>
             </a:r>
             <a:endParaRPr lang="en-US" sz="2000" dirty="0"/>
           </a:p>
@@ -4097,7 +6103,7 @@
                 <a:ea typeface="Calibri" pitchFamily="34" charset="-122"/>
                 <a:cs typeface="Calibri" pitchFamily="34" charset="-120"/>
               </a:rPr>
-              <a:t>One machine, one install, one team</a:t>
+              <a:t>Greenfield-first \u00B7 maps to standard SDLC phases</a:t>
             </a:r>
             <a:endParaRPr lang="en-US" sz="2000" dirty="0"/>
           </a:p>
@@ -7558,7 +9564,7 @@
                 <a:ea typeface="Calibri" pitchFamily="34" charset="-122"/>
                 <a:cs typeface="Calibri" pitchFamily="34" charset="-120"/>
               </a:rPr>
-              <a:t>THE FLOW</a:t>
+              <a:t>THE MODEL</a:t>
             </a:r>
             <a:endParaRPr lang="en-US" sz="1300" dirty="0"/>
           </a:p>
@@ -7597,15 +9603,54 @@
                 <a:ea typeface="Cambria" pitchFamily="34" charset="-122"/>
                 <a:cs typeface="Cambria" pitchFamily="34" charset="-120"/>
               </a:rPr>
-              <a:t>One request: first command → merged PR</a:t>
+              <a:t>One SDLC cycle, two entry points</a:t>
             </a:r>
             <a:endParaRPr lang="en-US" sz="4400" dirty="0"/>
+          </a:p>
+        </p:txBody>
+      </p:sp>
+      <p:sp>
+        <p:nvSpPr>
+          <p:cNvPr id="4" name="Text 2"/>
+          <p:cNvSpPr/>
+          <p:nvPr/>
+        </p:nvSpPr>
+        <p:spPr>
+          <a:xfrm>
+            <a:off x="502920" y="1371600"/>
+            <a:ext cx="11155680" cy="457200"/>
+          </a:xfrm>
+          <a:prstGeom prst="rect">
+            <a:avLst/>
+          </a:prstGeom>
+          <a:noFill/>
+          <a:ln/>
+        </p:spPr>
+        <p:txBody>
+          <a:bodyPr wrap="square" rtlCol="0" anchor="ctr"/>
+          <a:lstStyle/>
+          <a:p>
+            <a:pPr indent="0" marL="0">
+              <a:buNone/>
+            </a:pPr>
+            <a:r>
+              <a:rPr lang="en-US" sz="2000" dirty="0">
+                <a:solidFill>
+                  <a:srgbClr val="6B7280"/>
+                </a:solidFill>
+                <a:latin typeface="Calibri" pitchFamily="34" charset="0"/>
+                <a:ea typeface="Calibri" pitchFamily="34" charset="-122"/>
+                <a:cs typeface="Calibri" pitchFamily="34" charset="-120"/>
+              </a:rPr>
+              <a:t>Greenfield · brownfield · slash commands mark every stage.</a:t>
+            </a:r>
+            <a:endParaRPr lang="en-US" sz="2000" dirty="0"/>
           </a:p>
         </p:txBody>
       </p:sp>
       <p:pic>
         <p:nvPicPr>
-          <p:cNvPr id="4" name="Image 0" descr="D:\TRANSFER DATA\Coding\claude-code-agentic-sdlc\docs\slides/workflow-diagram.png">    </p:cNvPr>
+          <p:cNvPr id="5" name="Image 0" descr="D:\TRANSFER DATA\Coding\claude-code-agentic-sdlc\docs\slides/sdlc-cycle.png">    </p:cNvPr>
           <p:cNvPicPr>
             <a:picLocks noChangeAspect="1"/>
           </p:cNvPicPr>
@@ -7619,8 +9664,8 @@
         </p:blipFill>
         <p:spPr>
           <a:xfrm>
-            <a:off x="411480" y="1828800"/>
-            <a:ext cx="11384280" cy="4133088"/>
+            <a:off x="640080" y="1965960"/>
+            <a:ext cx="10881360" cy="3950208"/>
           </a:xfrm>
           <a:prstGeom prst="rect">
             <a:avLst/>
@@ -7629,14 +9674,14 @@
       </p:pic>
       <p:sp>
         <p:nvSpPr>
-          <p:cNvPr id="5" name="Text 2"/>
-          <p:cNvSpPr/>
-          <p:nvPr/>
-        </p:nvSpPr>
-        <p:spPr>
-          <a:xfrm>
-            <a:off x="411480" y="6080760"/>
-            <a:ext cx="11384280" cy="457200"/>
+          <p:cNvPr id="6" name="Text 3"/>
+          <p:cNvSpPr/>
+          <p:nvPr/>
+        </p:nvSpPr>
+        <p:spPr>
+          <a:xfrm>
+            <a:off x="640080" y="6035040"/>
+            <a:ext cx="10881360" cy="411480"/>
           </a:xfrm>
           <a:prstGeom prst="rect">
             <a:avLst/>
@@ -7660,7 +9705,7 @@
                 <a:ea typeface="Calibri" pitchFamily="34" charset="-122"/>
                 <a:cs typeface="Calibri" pitchFamily="34" charset="-120"/>
               </a:rPr>
-              <a:t>Spec gate · plan gate · TDD per task · QA before merge — the diagram IS the two-phase story.</a:t>
+              <a:t>Six stages, standard SDLC — the framework maps a skill to each stage and a command to each entry.</a:t>
             </a:r>
             <a:endParaRPr lang="en-US" sz="1400" dirty="0"/>
           </a:p>
@@ -7731,7 +9776,7 @@
                 <a:ea typeface="Calibri" pitchFamily="34" charset="-122"/>
                 <a:cs typeface="Calibri" pitchFamily="34" charset="-120"/>
               </a:rPr>
-              <a:t>ADOPTION &amp; EVIDENCE</a:t>
+              <a:t>THE FLOW</a:t>
             </a:r>
             <a:endParaRPr lang="en-US" sz="1300" dirty="0"/>
           </a:p>
@@ -7770,116 +9815,62 @@
                 <a:ea typeface="Cambria" pitchFamily="34" charset="-122"/>
                 <a:cs typeface="Cambria" pitchFamily="34" charset="-120"/>
               </a:rPr>
-              <a:t>Two commands. Two one-week POCs.</a:t>
+              <a:t>One request: first command → merged PR</a:t>
             </a:r>
             <a:endParaRPr lang="en-US" sz="4400" dirty="0"/>
           </a:p>
         </p:txBody>
       </p:sp>
-      <p:sp>
-        <p:nvSpPr>
-          <p:cNvPr id="4" name="Text 2"/>
-          <p:cNvSpPr/>
-          <p:nvPr/>
-        </p:nvSpPr>
-        <p:spPr>
-          <a:xfrm>
-            <a:off x="685800" y="2057400"/>
-            <a:ext cx="10835640" cy="457200"/>
-          </a:xfrm>
-          <a:prstGeom prst="rect">
-            <a:avLst/>
-          </a:prstGeom>
-          <a:noFill/>
-          <a:ln/>
-        </p:spPr>
-        <p:txBody>
-          <a:bodyPr wrap="square" rtlCol="0" anchor="ctr"/>
-          <a:lstStyle/>
-          <a:p>
-            <a:pPr indent="0" marL="0">
-              <a:buNone/>
-            </a:pPr>
-            <a:r>
-              <a:rPr lang="en-US" sz="1800" b="1" dirty="0">
-                <a:solidFill>
-                  <a:srgbClr val="1B5E20"/>
-                </a:solidFill>
-                <a:latin typeface="Courier New" pitchFamily="34" charset="0"/>
-                <a:ea typeface="Courier New" pitchFamily="34" charset="-122"/>
-                <a:cs typeface="Courier New" pitchFamily="34" charset="-120"/>
-              </a:rPr>
-              <a:t>claude plugin marketplace add trac41799/claude-code-agentic-sdlc</a:t>
-            </a:r>
-            <a:endParaRPr lang="en-US" sz="1800" dirty="0"/>
-          </a:p>
-        </p:txBody>
-      </p:sp>
-      <p:sp>
-        <p:nvSpPr>
-          <p:cNvPr id="5" name="Text 3"/>
-          <p:cNvSpPr/>
-          <p:nvPr/>
-        </p:nvSpPr>
-        <p:spPr>
-          <a:xfrm>
-            <a:off x="685800" y="2606040"/>
-            <a:ext cx="10835640" cy="457200"/>
-          </a:xfrm>
-          <a:prstGeom prst="rect">
-            <a:avLst/>
-          </a:prstGeom>
-          <a:noFill/>
-          <a:ln/>
-        </p:spPr>
-        <p:txBody>
-          <a:bodyPr wrap="square" rtlCol="0" anchor="ctr"/>
-          <a:lstStyle/>
-          <a:p>
-            <a:pPr indent="0" marL="0">
-              <a:buNone/>
-            </a:pPr>
-            <a:r>
-              <a:rPr lang="en-US" sz="1800" b="1" dirty="0">
-                <a:solidFill>
-                  <a:srgbClr val="1B5E20"/>
-                </a:solidFill>
-                <a:latin typeface="Courier New" pitchFamily="34" charset="0"/>
-                <a:ea typeface="Courier New" pitchFamily="34" charset="-122"/>
-                <a:cs typeface="Courier New" pitchFamily="34" charset="-120"/>
-              </a:rPr>
-              <a:t>claude plugin install agentic-sdlc@agentic-sdlc</a:t>
-            </a:r>
-            <a:endParaRPr lang="en-US" sz="1800" dirty="0"/>
-          </a:p>
-        </p:txBody>
-      </p:sp>
-      <p:sp>
-        <p:nvSpPr>
-          <p:cNvPr id="6" name="Text 4"/>
-          <p:cNvSpPr/>
-          <p:nvPr/>
-        </p:nvSpPr>
-        <p:spPr>
-          <a:xfrm>
-            <a:off x="685800" y="3154680"/>
-            <a:ext cx="10835640" cy="411480"/>
-          </a:xfrm>
-          <a:prstGeom prst="rect">
-            <a:avLst/>
-          </a:prstGeom>
-          <a:noFill/>
-          <a:ln/>
-        </p:spPr>
-        <p:txBody>
-          <a:bodyPr wrap="square" rtlCol="0" anchor="ctr"/>
-          <a:lstStyle/>
-          <a:p>
-            <a:pPr indent="0" marL="0">
-              <a:buNone/>
-            </a:pPr>
-            <a:r>
-              <a:rPr lang="en-US" sz="1400" dirty="0">
+      <p:pic>
+        <p:nvPicPr>
+          <p:cNvPr id="4" name="Image 0" descr="D:\TRANSFER DATA\Coding\claude-code-agentic-sdlc\docs\slides/workflow-diagram.png">    </p:cNvPr>
+          <p:cNvPicPr>
+            <a:picLocks noChangeAspect="1"/>
+          </p:cNvPicPr>
+          <p:nvPr/>
+        </p:nvPicPr>
+        <p:blipFill>
+          <a:blip r:embed="rId1"/>
+          <a:stretch>
+            <a:fillRect/>
+          </a:stretch>
+        </p:blipFill>
+        <p:spPr>
+          <a:xfrm>
+            <a:off x="411480" y="1828800"/>
+            <a:ext cx="11384280" cy="4133088"/>
+          </a:xfrm>
+          <a:prstGeom prst="rect">
+            <a:avLst/>
+          </a:prstGeom>
+        </p:spPr>
+      </p:pic>
+      <p:sp>
+        <p:nvSpPr>
+          <p:cNvPr id="5" name="Text 2"/>
+          <p:cNvSpPr/>
+          <p:nvPr/>
+        </p:nvSpPr>
+        <p:spPr>
+          <a:xfrm>
+            <a:off x="411480" y="6080760"/>
+            <a:ext cx="11384280" cy="457200"/>
+          </a:xfrm>
+          <a:prstGeom prst="rect">
+            <a:avLst/>
+          </a:prstGeom>
+          <a:noFill/>
+          <a:ln/>
+        </p:spPr>
+        <p:txBody>
+          <a:bodyPr wrap="square" rtlCol="0" anchor="ctr"/>
+          <a:lstStyle/>
+          <a:p>
+            <a:pPr indent="0" marL="0">
+              <a:buNone/>
+            </a:pPr>
+            <a:r>
+              <a:rPr lang="en-US" sz="1400" i="1" dirty="0">
                 <a:solidFill>
                   <a:srgbClr val="6B7280"/>
                 </a:solidFill>
@@ -7887,361 +9878,7 @@
                 <a:ea typeface="Calibri" pitchFamily="34" charset="-122"/>
                 <a:cs typeface="Calibri" pitchFamily="34" charset="-120"/>
               </a:rPr>
-              <a:t>Then /asdlc-doctor · /asdlc-project (new repo) · /asdlc-adopt (existing)</a:t>
-            </a:r>
-            <a:endParaRPr lang="en-US" sz="1400" dirty="0"/>
-          </a:p>
-        </p:txBody>
-      </p:sp>
-      <p:sp>
-        <p:nvSpPr>
-          <p:cNvPr id="7" name="Shape 5"/>
-          <p:cNvSpPr/>
-          <p:nvPr/>
-        </p:nvSpPr>
-        <p:spPr>
-          <a:xfrm>
-            <a:off x="685800" y="3749040"/>
-            <a:ext cx="10835640" cy="868680"/>
-          </a:xfrm>
-          <a:prstGeom prst="roundRect">
-            <a:avLst>
-              <a:gd name="adj" fmla="val 10526"/>
-            </a:avLst>
-          </a:prstGeom>
-          <a:solidFill>
-            <a:srgbClr val="F8FAFC"/>
-          </a:solidFill>
-          <a:ln w="15875">
-            <a:solidFill>
-              <a:srgbClr val="D1D5DB"/>
-            </a:solidFill>
-            <a:prstDash val="solid"/>
-          </a:ln>
-        </p:spPr>
-      </p:sp>
-      <p:sp>
-        <p:nvSpPr>
-          <p:cNvPr id="8" name="Text 6"/>
-          <p:cNvSpPr/>
-          <p:nvPr/>
-        </p:nvSpPr>
-        <p:spPr>
-          <a:xfrm>
-            <a:off x="960120" y="3895344"/>
-            <a:ext cx="3383280" cy="640080"/>
-          </a:xfrm>
-          <a:prstGeom prst="rect">
-            <a:avLst/>
-          </a:prstGeom>
-          <a:noFill/>
-          <a:ln/>
-        </p:spPr>
-        <p:txBody>
-          <a:bodyPr wrap="square" rtlCol="0" anchor="ctr"/>
-          <a:lstStyle/>
-          <a:p>
-            <a:pPr indent="0" marL="0">
-              <a:buNone/>
-            </a:pPr>
-            <a:r>
-              <a:rPr lang="en-US" sz="2200" b="1" dirty="0">
-                <a:solidFill>
-                  <a:srgbClr val="1E2761"/>
-                </a:solidFill>
-                <a:latin typeface="Cambria" pitchFamily="34" charset="0"/>
-                <a:ea typeface="Cambria" pitchFamily="34" charset="-122"/>
-                <a:cs typeface="Cambria" pitchFamily="34" charset="-120"/>
-              </a:rPr>
-              <a:t>WorkHealthyAustralia</a:t>
-            </a:r>
-            <a:endParaRPr lang="en-US" sz="2200" dirty="0"/>
-          </a:p>
-        </p:txBody>
-      </p:sp>
-      <p:sp>
-        <p:nvSpPr>
-          <p:cNvPr id="9" name="Text 7"/>
-          <p:cNvSpPr/>
-          <p:nvPr/>
-        </p:nvSpPr>
-        <p:spPr>
-          <a:xfrm>
-            <a:off x="4023360" y="3858768"/>
-            <a:ext cx="7315200" cy="640080"/>
-          </a:xfrm>
-          <a:prstGeom prst="rect">
-            <a:avLst/>
-          </a:prstGeom>
-          <a:noFill/>
-          <a:ln/>
-        </p:spPr>
-        <p:txBody>
-          <a:bodyPr wrap="square" rtlCol="0" anchor="ctr"/>
-          <a:lstStyle/>
-          <a:p>
-            <a:pPr indent="0" marL="0">
-              <a:buNone/>
-            </a:pPr>
-            <a:r>
-              <a:rPr lang="en-US" sz="1600" dirty="0">
-                <a:solidFill>
-                  <a:srgbClr val="1F2937"/>
-                </a:solidFill>
-                <a:latin typeface="Calibri" pitchFamily="34" charset="0"/>
-                <a:ea typeface="Calibri" pitchFamily="34" charset="-122"/>
-                <a:cs typeface="Calibri" pitchFamily="34" charset="-120"/>
-              </a:rPr>
-              <a:t>AU · healthcare — janet.care (personal healthcare AI-assistant) + occuspan.com · POC in 1 week</a:t>
-            </a:r>
-            <a:endParaRPr lang="en-US" sz="1600" dirty="0"/>
-          </a:p>
-        </p:txBody>
-      </p:sp>
-      <p:sp>
-        <p:nvSpPr>
-          <p:cNvPr id="10" name="Shape 8"/>
-          <p:cNvSpPr/>
-          <p:nvPr/>
-        </p:nvSpPr>
-        <p:spPr>
-          <a:xfrm>
-            <a:off x="685800" y="4754880"/>
-            <a:ext cx="10835640" cy="868680"/>
-          </a:xfrm>
-          <a:prstGeom prst="roundRect">
-            <a:avLst>
-              <a:gd name="adj" fmla="val 10526"/>
-            </a:avLst>
-          </a:prstGeom>
-          <a:solidFill>
-            <a:srgbClr val="F8FAFC"/>
-          </a:solidFill>
-          <a:ln w="15875">
-            <a:solidFill>
-              <a:srgbClr val="D1D5DB"/>
-            </a:solidFill>
-            <a:prstDash val="solid"/>
-          </a:ln>
-        </p:spPr>
-      </p:sp>
-      <p:sp>
-        <p:nvSpPr>
-          <p:cNvPr id="11" name="Text 9"/>
-          <p:cNvSpPr/>
-          <p:nvPr/>
-        </p:nvSpPr>
-        <p:spPr>
-          <a:xfrm>
-            <a:off x="960120" y="4901184"/>
-            <a:ext cx="3383280" cy="640080"/>
-          </a:xfrm>
-          <a:prstGeom prst="rect">
-            <a:avLst/>
-          </a:prstGeom>
-          <a:noFill/>
-          <a:ln/>
-        </p:spPr>
-        <p:txBody>
-          <a:bodyPr wrap="square" rtlCol="0" anchor="ctr"/>
-          <a:lstStyle/>
-          <a:p>
-            <a:pPr indent="0" marL="0">
-              <a:buNone/>
-            </a:pPr>
-            <a:r>
-              <a:rPr lang="en-US" sz="2200" b="1" dirty="0">
-                <a:solidFill>
-                  <a:srgbClr val="1E2761"/>
-                </a:solidFill>
-                <a:latin typeface="Cambria" pitchFamily="34" charset="0"/>
-                <a:ea typeface="Cambria" pitchFamily="34" charset="-122"/>
-                <a:cs typeface="Cambria" pitchFamily="34" charset="-120"/>
-              </a:rPr>
-              <a:t>DOXA</a:t>
-            </a:r>
-            <a:endParaRPr lang="en-US" sz="2200" dirty="0"/>
-          </a:p>
-        </p:txBody>
-      </p:sp>
-      <p:sp>
-        <p:nvSpPr>
-          <p:cNvPr id="12" name="Text 10"/>
-          <p:cNvSpPr/>
-          <p:nvPr/>
-        </p:nvSpPr>
-        <p:spPr>
-          <a:xfrm>
-            <a:off x="4023360" y="4864608"/>
-            <a:ext cx="7315200" cy="640080"/>
-          </a:xfrm>
-          <a:prstGeom prst="rect">
-            <a:avLst/>
-          </a:prstGeom>
-          <a:noFill/>
-          <a:ln/>
-        </p:spPr>
-        <p:txBody>
-          <a:bodyPr wrap="square" rtlCol="0" anchor="ctr"/>
-          <a:lstStyle/>
-          <a:p>
-            <a:pPr indent="0" marL="0">
-              <a:buNone/>
-            </a:pPr>
-            <a:r>
-              <a:rPr lang="en-US" sz="1600" dirty="0">
-                <a:solidFill>
-                  <a:srgbClr val="1F2937"/>
-                </a:solidFill>
-                <a:latin typeface="Calibri" pitchFamily="34" charset="0"/>
-                <a:ea typeface="Calibri" pitchFamily="34" charset="-122"/>
-                <a:cs typeface="Calibri" pitchFamily="34" charset="-120"/>
-              </a:rPr>
-              <a:t>US · staffing — multiple projects under NDA · POC in 1 week</a:t>
-            </a:r>
-            <a:endParaRPr lang="en-US" sz="1600" dirty="0"/>
-          </a:p>
-        </p:txBody>
-      </p:sp>
-      <p:sp>
-        <p:nvSpPr>
-          <p:cNvPr id="13" name="Text 11"/>
-          <p:cNvSpPr/>
-          <p:nvPr/>
-        </p:nvSpPr>
-        <p:spPr>
-          <a:xfrm>
-            <a:off x="685800" y="5760720"/>
-            <a:ext cx="10835640" cy="365760"/>
-          </a:xfrm>
-          <a:prstGeom prst="rect">
-            <a:avLst/>
-          </a:prstGeom>
-          <a:noFill/>
-          <a:ln/>
-        </p:spPr>
-        <p:txBody>
-          <a:bodyPr wrap="square" rtlCol="0" anchor="ctr"/>
-          <a:lstStyle/>
-          <a:p>
-            <a:pPr indent="0" marL="0">
-              <a:buNone/>
-            </a:pPr>
-            <a:r>
-              <a:rPr lang="en-US" sz="1400" i="1" dirty="0">
-                <a:solidFill>
-                  <a:srgbClr val="6B7280"/>
-                </a:solidFill>
-                <a:latin typeface="Calibri" pitchFamily="34" charset="0"/>
-                <a:ea typeface="Calibri" pitchFamily="34" charset="-122"/>
-                <a:cs typeface="Calibri" pitchFamily="34" charset="-120"/>
-              </a:rPr>
-              <a:t>Both: non-technical founders, one engineer of support, one engineer of trust.</a:t>
-            </a:r>
-            <a:endParaRPr lang="en-US" sz="1400" dirty="0"/>
-          </a:p>
-        </p:txBody>
-      </p:sp>
-      <p:sp>
-        <p:nvSpPr>
-          <p:cNvPr id="14" name="Shape 12"/>
-          <p:cNvSpPr/>
-          <p:nvPr/>
-        </p:nvSpPr>
-        <p:spPr>
-          <a:xfrm>
-            <a:off x="685800" y="6172200"/>
-            <a:ext cx="1170432" cy="292608"/>
-          </a:xfrm>
-          <a:prstGeom prst="roundRect">
-            <a:avLst>
-              <a:gd name="adj" fmla="val 50000"/>
-            </a:avLst>
-          </a:prstGeom>
-          <a:solidFill>
-            <a:srgbClr val="B98A00"/>
-          </a:solidFill>
-          <a:ln w="12700">
-            <a:solidFill>
-              <a:srgbClr val="B98A00"/>
-            </a:solidFill>
-            <a:prstDash val="solid"/>
-          </a:ln>
-        </p:spPr>
-      </p:sp>
-      <p:sp>
-        <p:nvSpPr>
-          <p:cNvPr id="15" name="Text 13"/>
-          <p:cNvSpPr/>
-          <p:nvPr/>
-        </p:nvSpPr>
-        <p:spPr>
-          <a:xfrm>
-            <a:off x="685800" y="6144768"/>
-            <a:ext cx="1170432" cy="292608"/>
-          </a:xfrm>
-          <a:prstGeom prst="rect">
-            <a:avLst/>
-          </a:prstGeom>
-          <a:noFill/>
-          <a:ln/>
-        </p:spPr>
-        <p:txBody>
-          <a:bodyPr wrap="square" lIns="0" tIns="0" rIns="0" bIns="0" rtlCol="0" anchor="ctr"/>
-          <a:lstStyle/>
-          <a:p>
-            <a:pPr algn="ctr" indent="0" marL="0">
-              <a:buNone/>
-            </a:pPr>
-            <a:r>
-              <a:rPr lang="en-US" sz="1100" b="1" dirty="0">
-                <a:solidFill>
-                  <a:srgbClr val="FFFFFF"/>
-                </a:solidFill>
-                <a:latin typeface="Calibri" pitchFamily="34" charset="0"/>
-                <a:ea typeface="Calibri" pitchFamily="34" charset="-122"/>
-                <a:cs typeface="Calibri" pitchFamily="34" charset="-120"/>
-              </a:rPr>
-              <a:t>CASE STUDY</a:t>
-            </a:r>
-            <a:endParaRPr lang="en-US" sz="1100" dirty="0"/>
-          </a:p>
-        </p:txBody>
-      </p:sp>
-      <p:sp>
-        <p:nvSpPr>
-          <p:cNvPr id="16" name="Text 14"/>
-          <p:cNvSpPr/>
-          <p:nvPr/>
-        </p:nvSpPr>
-        <p:spPr>
-          <a:xfrm>
-            <a:off x="2194560" y="6199632"/>
-            <a:ext cx="9326880" cy="320040"/>
-          </a:xfrm>
-          <a:prstGeom prst="rect">
-            <a:avLst/>
-          </a:prstGeom>
-          <a:noFill/>
-          <a:ln/>
-        </p:spPr>
-        <p:txBody>
-          <a:bodyPr wrap="square" rtlCol="0" anchor="ctr"/>
-          <a:lstStyle/>
-          <a:p>
-            <a:pPr indent="0" marL="0">
-              <a:buNone/>
-            </a:pPr>
-            <a:r>
-              <a:rPr lang="en-US" sz="1400" dirty="0">
-                <a:solidFill>
-                  <a:srgbClr val="6B7280"/>
-                </a:solidFill>
-                <a:latin typeface="Calibri" pitchFamily="34" charset="0"/>
-                <a:ea typeface="Calibri" pitchFamily="34" charset="-122"/>
-                <a:cs typeface="Calibri" pitchFamily="34" charset="-120"/>
-              </a:rPr>
-              <a:t>Confounded: model mix drifted mid-build · no cost tracking · n = 2</a:t>
+              <a:t>Spec gate · plan gate · TDD per task · QA before merge — the diagram IS the two-phase story.</a:t>
             </a:r>
             <a:endParaRPr lang="en-US" sz="1400" dirty="0"/>
           </a:p>
@@ -8312,7 +9949,7 @@
                 <a:ea typeface="Calibri" pitchFamily="34" charset="-122"/>
                 <a:cs typeface="Calibri" pitchFamily="34" charset="-120"/>
               </a:rPr>
-              <a:t>BENCHMARK · 4 RUNS, 3 ARMS</a:t>
+              <a:t>ADOPTION &amp; EVIDENCE</a:t>
             </a:r>
             <a:endParaRPr lang="en-US" sz="1300" dirty="0"/>
           </a:p>
@@ -8351,7 +9988,7 @@
                 <a:ea typeface="Cambria" pitchFamily="34" charset="-122"/>
                 <a:cs typeface="Cambria" pitchFamily="34" charset="-120"/>
               </a:rPr>
-              <a:t>Measured: bare vs passive vs activated</a:t>
+              <a:t>Two commands. Two one-week POCs.</a:t>
             </a:r>
             <a:endParaRPr lang="en-US" sz="4400" dirty="0"/>
           </a:p>
@@ -8365,24 +10002,102 @@
         </p:nvSpPr>
         <p:spPr>
           <a:xfrm>
-            <a:off x="502920" y="1371600"/>
-            <a:ext cx="11155680" cy="457200"/>
-          </a:xfrm>
-          <a:prstGeom prst="rect">
-            <a:avLst/>
-          </a:prstGeom>
-          <a:noFill/>
-          <a:ln/>
-        </p:spPr>
-        <p:txBody>
-          <a:bodyPr wrap="square" rtlCol="0" anchor="ctr"/>
-          <a:lstStyle/>
-          <a:p>
-            <a:pPr indent="0" marL="0">
-              <a:buNone/>
-            </a:pPr>
-            <a:r>
-              <a:rPr lang="en-US" sz="2000" dirty="0">
+            <a:off x="685800" y="2057400"/>
+            <a:ext cx="10835640" cy="457200"/>
+          </a:xfrm>
+          <a:prstGeom prst="rect">
+            <a:avLst/>
+          </a:prstGeom>
+          <a:noFill/>
+          <a:ln/>
+        </p:spPr>
+        <p:txBody>
+          <a:bodyPr wrap="square" rtlCol="0" anchor="ctr"/>
+          <a:lstStyle/>
+          <a:p>
+            <a:pPr indent="0" marL="0">
+              <a:buNone/>
+            </a:pPr>
+            <a:r>
+              <a:rPr lang="en-US" sz="1800" b="1" dirty="0">
+                <a:solidFill>
+                  <a:srgbClr val="1B5E20"/>
+                </a:solidFill>
+                <a:latin typeface="Courier New" pitchFamily="34" charset="0"/>
+                <a:ea typeface="Courier New" pitchFamily="34" charset="-122"/>
+                <a:cs typeface="Courier New" pitchFamily="34" charset="-120"/>
+              </a:rPr>
+              <a:t>claude plugin marketplace add trac41799/claude-code-agentic-sdlc</a:t>
+            </a:r>
+            <a:endParaRPr lang="en-US" sz="1800" dirty="0"/>
+          </a:p>
+        </p:txBody>
+      </p:sp>
+      <p:sp>
+        <p:nvSpPr>
+          <p:cNvPr id="5" name="Text 3"/>
+          <p:cNvSpPr/>
+          <p:nvPr/>
+        </p:nvSpPr>
+        <p:spPr>
+          <a:xfrm>
+            <a:off x="685800" y="2606040"/>
+            <a:ext cx="10835640" cy="457200"/>
+          </a:xfrm>
+          <a:prstGeom prst="rect">
+            <a:avLst/>
+          </a:prstGeom>
+          <a:noFill/>
+          <a:ln/>
+        </p:spPr>
+        <p:txBody>
+          <a:bodyPr wrap="square" rtlCol="0" anchor="ctr"/>
+          <a:lstStyle/>
+          <a:p>
+            <a:pPr indent="0" marL="0">
+              <a:buNone/>
+            </a:pPr>
+            <a:r>
+              <a:rPr lang="en-US" sz="1800" b="1" dirty="0">
+                <a:solidFill>
+                  <a:srgbClr val="1B5E20"/>
+                </a:solidFill>
+                <a:latin typeface="Courier New" pitchFamily="34" charset="0"/>
+                <a:ea typeface="Courier New" pitchFamily="34" charset="-122"/>
+                <a:cs typeface="Courier New" pitchFamily="34" charset="-120"/>
+              </a:rPr>
+              <a:t>claude plugin install agentic-sdlc@agentic-sdlc</a:t>
+            </a:r>
+            <a:endParaRPr lang="en-US" sz="1800" dirty="0"/>
+          </a:p>
+        </p:txBody>
+      </p:sp>
+      <p:sp>
+        <p:nvSpPr>
+          <p:cNvPr id="6" name="Text 4"/>
+          <p:cNvSpPr/>
+          <p:nvPr/>
+        </p:nvSpPr>
+        <p:spPr>
+          <a:xfrm>
+            <a:off x="685800" y="3154680"/>
+            <a:ext cx="10835640" cy="411480"/>
+          </a:xfrm>
+          <a:prstGeom prst="rect">
+            <a:avLst/>
+          </a:prstGeom>
+          <a:noFill/>
+          <a:ln/>
+        </p:spPr>
+        <p:txBody>
+          <a:bodyPr wrap="square" rtlCol="0" anchor="ctr"/>
+          <a:lstStyle/>
+          <a:p>
+            <a:pPr indent="0" marL="0">
+              <a:buNone/>
+            </a:pPr>
+            <a:r>
+              <a:rPr lang="en-US" sz="1400" dirty="0">
                 <a:solidFill>
                   <a:srgbClr val="6B7280"/>
                 </a:solidFill>
@@ -8390,182 +10105,26 @@
                 <a:ea typeface="Calibri" pitchFamily="34" charset="-122"/>
                 <a:cs typeface="Calibri" pitchFamily="34" charset="-120"/>
               </a:rPr>
-              <a:t>Same repos · same frozen tasks · same model · metered. Froam exp branches (non-merge).</a:t>
-            </a:r>
-            <a:endParaRPr lang="en-US" sz="2000" dirty="0"/>
-          </a:p>
-        </p:txBody>
-      </p:sp>
-      <p:sp>
-        <p:nvSpPr>
-          <p:cNvPr id="5" name="Text 3"/>
-          <p:cNvSpPr/>
-          <p:nvPr/>
-        </p:nvSpPr>
-        <p:spPr>
-          <a:xfrm>
-            <a:off x="822960" y="1828800"/>
-            <a:ext cx="2834640" cy="274320"/>
-          </a:xfrm>
-          <a:prstGeom prst="rect">
-            <a:avLst/>
-          </a:prstGeom>
-          <a:noFill/>
-          <a:ln/>
-        </p:spPr>
-        <p:txBody>
-          <a:bodyPr wrap="square" rtlCol="0" anchor="ctr"/>
-          <a:lstStyle/>
-          <a:p>
-            <a:pPr indent="0" marL="0">
-              <a:buNone/>
-            </a:pPr>
-            <a:r>
-              <a:rPr lang="en-US" sz="1100" b="1" dirty="0">
-                <a:solidFill>
-                  <a:srgbClr val="6B7280"/>
-                </a:solidFill>
-                <a:latin typeface="Calibri" pitchFamily="34" charset="0"/>
-                <a:ea typeface="Calibri" pitchFamily="34" charset="-122"/>
-                <a:cs typeface="Calibri" pitchFamily="34" charset="-120"/>
-              </a:rPr>
-              <a:t>TASK</a:t>
-            </a:r>
-            <a:endParaRPr lang="en-US" sz="1100" dirty="0"/>
-          </a:p>
-        </p:txBody>
-      </p:sp>
-      <p:sp>
-        <p:nvSpPr>
-          <p:cNvPr id="6" name="Text 4"/>
-          <p:cNvSpPr/>
-          <p:nvPr/>
-        </p:nvSpPr>
-        <p:spPr>
-          <a:xfrm>
-            <a:off x="3749040" y="1828800"/>
-            <a:ext cx="2377440" cy="274320"/>
-          </a:xfrm>
-          <a:prstGeom prst="rect">
-            <a:avLst/>
-          </a:prstGeom>
-          <a:noFill/>
-          <a:ln/>
-        </p:spPr>
-        <p:txBody>
-          <a:bodyPr wrap="square" rtlCol="0" anchor="ctr"/>
-          <a:lstStyle/>
-          <a:p>
-            <a:pPr algn="ctr" indent="0" marL="0">
-              <a:buNone/>
-            </a:pPr>
-            <a:r>
-              <a:rPr lang="en-US" sz="1100" b="1" dirty="0">
-                <a:solidFill>
-                  <a:srgbClr val="6B7280"/>
-                </a:solidFill>
-                <a:latin typeface="Calibri" pitchFamily="34" charset="0"/>
-                <a:ea typeface="Calibri" pitchFamily="34" charset="-122"/>
-                <a:cs typeface="Calibri" pitchFamily="34" charset="-120"/>
-              </a:rPr>
-              <a:t>B · BARE</a:t>
-            </a:r>
-            <a:endParaRPr lang="en-US" sz="1100" dirty="0"/>
-          </a:p>
-        </p:txBody>
-      </p:sp>
-      <p:sp>
-        <p:nvSpPr>
-          <p:cNvPr id="7" name="Text 5"/>
-          <p:cNvSpPr/>
-          <p:nvPr/>
-        </p:nvSpPr>
-        <p:spPr>
-          <a:xfrm>
-            <a:off x="6309360" y="1828800"/>
-            <a:ext cx="2377440" cy="274320"/>
-          </a:xfrm>
-          <a:prstGeom prst="rect">
-            <a:avLst/>
-          </a:prstGeom>
-          <a:noFill/>
-          <a:ln/>
-        </p:spPr>
-        <p:txBody>
-          <a:bodyPr wrap="square" rtlCol="0" anchor="ctr"/>
-          <a:lstStyle/>
-          <a:p>
-            <a:pPr algn="ctr" indent="0" marL="0">
-              <a:buNone/>
-            </a:pPr>
-            <a:r>
-              <a:rPr lang="en-US" sz="1100" b="1" dirty="0">
-                <a:solidFill>
-                  <a:srgbClr val="6B7280"/>
-                </a:solidFill>
-                <a:latin typeface="Calibri" pitchFamily="34" charset="0"/>
-                <a:ea typeface="Calibri" pitchFamily="34" charset="-122"/>
-                <a:cs typeface="Calibri" pitchFamily="34" charset="-120"/>
-              </a:rPr>
-              <a:t>A′ · PASSIVE</a:t>
-            </a:r>
-            <a:endParaRPr lang="en-US" sz="1100" dirty="0"/>
-          </a:p>
-        </p:txBody>
-      </p:sp>
-      <p:sp>
-        <p:nvSpPr>
-          <p:cNvPr id="8" name="Text 6"/>
-          <p:cNvSpPr/>
-          <p:nvPr/>
-        </p:nvSpPr>
-        <p:spPr>
-          <a:xfrm>
-            <a:off x="8869680" y="1828800"/>
-            <a:ext cx="2560320" cy="274320"/>
-          </a:xfrm>
-          <a:prstGeom prst="rect">
-            <a:avLst/>
-          </a:prstGeom>
-          <a:noFill/>
-          <a:ln/>
-        </p:spPr>
-        <p:txBody>
-          <a:bodyPr wrap="square" rtlCol="0" anchor="ctr"/>
-          <a:lstStyle/>
-          <a:p>
-            <a:pPr algn="ctr" indent="0" marL="0">
-              <a:buNone/>
-            </a:pPr>
-            <a:r>
-              <a:rPr lang="en-US" sz="1100" b="1" dirty="0">
-                <a:solidFill>
-                  <a:srgbClr val="6B7280"/>
-                </a:solidFill>
-                <a:latin typeface="Calibri" pitchFamily="34" charset="0"/>
-                <a:ea typeface="Calibri" pitchFamily="34" charset="-122"/>
-                <a:cs typeface="Calibri" pitchFamily="34" charset="-120"/>
-              </a:rPr>
-              <a:t>A · ACTIVATED</a:t>
-            </a:r>
-            <a:endParaRPr lang="en-US" sz="1100" dirty="0"/>
-          </a:p>
-        </p:txBody>
-      </p:sp>
-      <p:sp>
-        <p:nvSpPr>
-          <p:cNvPr id="9" name="Shape 7"/>
-          <p:cNvSpPr/>
-          <p:nvPr/>
-        </p:nvSpPr>
-        <p:spPr>
-          <a:xfrm>
-            <a:off x="685800" y="2148840"/>
-            <a:ext cx="10835640" cy="658368"/>
+              <a:t>Then /asdlc-doctor · /asdlc-project (new repo) · /asdlc-adopt (existing)</a:t>
+            </a:r>
+            <a:endParaRPr lang="en-US" sz="1400" dirty="0"/>
+          </a:p>
+        </p:txBody>
+      </p:sp>
+      <p:sp>
+        <p:nvSpPr>
+          <p:cNvPr id="7" name="Shape 5"/>
+          <p:cNvSpPr/>
+          <p:nvPr/>
+        </p:nvSpPr>
+        <p:spPr>
+          <a:xfrm>
+            <a:off x="685800" y="3749040"/>
+            <a:ext cx="10835640" cy="868680"/>
           </a:xfrm>
           <a:prstGeom prst="roundRect">
             <a:avLst>
-              <a:gd name="adj" fmla="val 13889"/>
+              <a:gd name="adj" fmla="val 10526"/>
             </a:avLst>
           </a:prstGeom>
           <a:solidFill>
@@ -8581,69 +10140,69 @@
       </p:sp>
       <p:sp>
         <p:nvSpPr>
-          <p:cNvPr id="10" name="Text 8"/>
-          <p:cNvSpPr/>
-          <p:nvPr/>
-        </p:nvSpPr>
-        <p:spPr>
-          <a:xfrm>
-            <a:off x="822960" y="2276856"/>
-            <a:ext cx="2834640" cy="411480"/>
-          </a:xfrm>
-          <a:prstGeom prst="rect">
-            <a:avLst/>
-          </a:prstGeom>
-          <a:noFill/>
-          <a:ln/>
-        </p:spPr>
-        <p:txBody>
-          <a:bodyPr wrap="square" rtlCol="0" anchor="ctr"/>
-          <a:lstStyle/>
-          <a:p>
-            <a:pPr indent="0" marL="0">
-              <a:buNone/>
-            </a:pPr>
-            <a:r>
-              <a:rPr lang="en-US" sz="1200" b="1" dirty="0">
+          <p:cNvPr id="8" name="Text 6"/>
+          <p:cNvSpPr/>
+          <p:nvPr/>
+        </p:nvSpPr>
+        <p:spPr>
+          <a:xfrm>
+            <a:off x="960120" y="3895344"/>
+            <a:ext cx="3383280" cy="640080"/>
+          </a:xfrm>
+          <a:prstGeom prst="rect">
+            <a:avLst/>
+          </a:prstGeom>
+          <a:noFill/>
+          <a:ln/>
+        </p:spPr>
+        <p:txBody>
+          <a:bodyPr wrap="square" rtlCol="0" anchor="ctr"/>
+          <a:lstStyle/>
+          <a:p>
+            <a:pPr indent="0" marL="0">
+              <a:buNone/>
+            </a:pPr>
+            <a:r>
+              <a:rPr lang="en-US" sz="2200" b="1" dirty="0">
                 <a:solidFill>
                   <a:srgbClr val="1E2761"/>
                 </a:solidFill>
-                <a:latin typeface="Calibri" pitchFamily="34" charset="0"/>
-                <a:ea typeface="Calibri" pitchFamily="34" charset="-122"/>
-                <a:cs typeface="Calibri" pitchFamily="34" charset="-120"/>
-              </a:rPr>
-              <a:t>R1 · add-tests (trivial)</a:t>
-            </a:r>
-            <a:endParaRPr lang="en-US" sz="1200" dirty="0"/>
-          </a:p>
-        </p:txBody>
-      </p:sp>
-      <p:sp>
-        <p:nvSpPr>
-          <p:cNvPr id="11" name="Text 9"/>
-          <p:cNvSpPr/>
-          <p:nvPr/>
-        </p:nvSpPr>
-        <p:spPr>
-          <a:xfrm>
-            <a:off x="3749040" y="2276856"/>
-            <a:ext cx="2377440" cy="411480"/>
-          </a:xfrm>
-          <a:prstGeom prst="rect">
-            <a:avLst/>
-          </a:prstGeom>
-          <a:noFill/>
-          <a:ln/>
-        </p:spPr>
-        <p:txBody>
-          <a:bodyPr wrap="square" rtlCol="0" anchor="ctr"/>
-          <a:lstStyle/>
-          <a:p>
-            <a:pPr algn="ctr" indent="0" marL="0">
-              <a:buNone/>
-            </a:pPr>
-            <a:r>
-              <a:rPr lang="en-US" sz="1150" dirty="0">
+                <a:latin typeface="Cambria" pitchFamily="34" charset="0"/>
+                <a:ea typeface="Cambria" pitchFamily="34" charset="-122"/>
+                <a:cs typeface="Cambria" pitchFamily="34" charset="-120"/>
+              </a:rPr>
+              <a:t>WorkHealthyAustralia</a:t>
+            </a:r>
+            <a:endParaRPr lang="en-US" sz="2200" dirty="0"/>
+          </a:p>
+        </p:txBody>
+      </p:sp>
+      <p:sp>
+        <p:nvSpPr>
+          <p:cNvPr id="9" name="Text 7"/>
+          <p:cNvSpPr/>
+          <p:nvPr/>
+        </p:nvSpPr>
+        <p:spPr>
+          <a:xfrm>
+            <a:off x="4023360" y="3858768"/>
+            <a:ext cx="7315200" cy="640080"/>
+          </a:xfrm>
+          <a:prstGeom prst="rect">
+            <a:avLst/>
+          </a:prstGeom>
+          <a:noFill/>
+          <a:ln/>
+        </p:spPr>
+        <p:txBody>
+          <a:bodyPr wrap="square" rtlCol="0" anchor="ctr"/>
+          <a:lstStyle/>
+          <a:p>
+            <a:pPr indent="0" marL="0">
+              <a:buNone/>
+            </a:pPr>
+            <a:r>
+              <a:rPr lang="en-US" sz="1600" dirty="0">
                 <a:solidFill>
                   <a:srgbClr val="1F2937"/>
                 </a:solidFill>
@@ -8651,104 +10210,26 @@
                 <a:ea typeface="Calibri" pitchFamily="34" charset="-122"/>
                 <a:cs typeface="Calibri" pitchFamily="34" charset="-120"/>
               </a:rPr>
-              <a:t>$0.63 · 6 tests</a:t>
-            </a:r>
-            <a:endParaRPr lang="en-US" sz="1150" dirty="0"/>
-          </a:p>
-        </p:txBody>
-      </p:sp>
-      <p:sp>
-        <p:nvSpPr>
-          <p:cNvPr id="12" name="Text 10"/>
-          <p:cNvSpPr/>
-          <p:nvPr/>
-        </p:nvSpPr>
-        <p:spPr>
-          <a:xfrm>
-            <a:off x="6309360" y="2276856"/>
-            <a:ext cx="2377440" cy="411480"/>
-          </a:xfrm>
-          <a:prstGeom prst="rect">
-            <a:avLst/>
-          </a:prstGeom>
-          <a:noFill/>
-          <a:ln/>
-        </p:spPr>
-        <p:txBody>
-          <a:bodyPr wrap="square" rtlCol="0" anchor="ctr"/>
-          <a:lstStyle/>
-          <a:p>
-            <a:pPr algn="ctr" indent="0" marL="0">
-              <a:buNone/>
-            </a:pPr>
-            <a:r>
-              <a:rPr lang="en-US" sz="1150" dirty="0">
-                <a:solidFill>
-                  <a:srgbClr val="1F2937"/>
-                </a:solidFill>
-                <a:latin typeface="Calibri" pitchFamily="34" charset="0"/>
-                <a:ea typeface="Calibri" pitchFamily="34" charset="-122"/>
-                <a:cs typeface="Calibri" pitchFamily="34" charset="-120"/>
-              </a:rPr>
-              <a:t>$0.62 · 7 tests</a:t>
-            </a:r>
-            <a:endParaRPr lang="en-US" sz="1150" dirty="0"/>
-          </a:p>
-        </p:txBody>
-      </p:sp>
-      <p:sp>
-        <p:nvSpPr>
-          <p:cNvPr id="13" name="Text 11"/>
-          <p:cNvSpPr/>
-          <p:nvPr/>
-        </p:nvSpPr>
-        <p:spPr>
-          <a:xfrm>
-            <a:off x="8869680" y="2276856"/>
-            <a:ext cx="2560320" cy="411480"/>
-          </a:xfrm>
-          <a:prstGeom prst="rect">
-            <a:avLst/>
-          </a:prstGeom>
-          <a:noFill/>
-          <a:ln/>
-        </p:spPr>
-        <p:txBody>
-          <a:bodyPr wrap="square" rtlCol="0" anchor="ctr"/>
-          <a:lstStyle/>
-          <a:p>
-            <a:pPr algn="ctr" indent="0" marL="0">
-              <a:buNone/>
-            </a:pPr>
-            <a:r>
-              <a:rPr lang="en-US" sz="1150" dirty="0">
-                <a:solidFill>
-                  <a:srgbClr val="1B5E20"/>
-                </a:solidFill>
-                <a:latin typeface="Calibri" pitchFamily="34" charset="0"/>
-                <a:ea typeface="Calibri" pitchFamily="34" charset="-122"/>
-                <a:cs typeface="Calibri" pitchFamily="34" charset="-120"/>
-              </a:rPr>
-              <a:t>$0.47 · 10 tests · 2.5× turns</a:t>
-            </a:r>
-            <a:endParaRPr lang="en-US" sz="1150" dirty="0"/>
-          </a:p>
-        </p:txBody>
-      </p:sp>
-      <p:sp>
-        <p:nvSpPr>
-          <p:cNvPr id="14" name="Shape 12"/>
-          <p:cNvSpPr/>
-          <p:nvPr/>
-        </p:nvSpPr>
-        <p:spPr>
-          <a:xfrm>
-            <a:off x="685800" y="2898648"/>
-            <a:ext cx="10835640" cy="658368"/>
+              <a:t>AU · healthcare — janet.care (personal healthcare AI-assistant) + occuspan.com · POC in 1 week</a:t>
+            </a:r>
+            <a:endParaRPr lang="en-US" sz="1600" dirty="0"/>
+          </a:p>
+        </p:txBody>
+      </p:sp>
+      <p:sp>
+        <p:nvSpPr>
+          <p:cNvPr id="10" name="Shape 8"/>
+          <p:cNvSpPr/>
+          <p:nvPr/>
+        </p:nvSpPr>
+        <p:spPr>
+          <a:xfrm>
+            <a:off x="685800" y="4754880"/>
+            <a:ext cx="10835640" cy="868680"/>
           </a:xfrm>
           <a:prstGeom prst="roundRect">
             <a:avLst>
-              <a:gd name="adj" fmla="val 13889"/>
+              <a:gd name="adj" fmla="val 10526"/>
             </a:avLst>
           </a:prstGeom>
           <a:solidFill>
@@ -8764,69 +10245,69 @@
       </p:sp>
       <p:sp>
         <p:nvSpPr>
-          <p:cNvPr id="15" name="Text 13"/>
-          <p:cNvSpPr/>
-          <p:nvPr/>
-        </p:nvSpPr>
-        <p:spPr>
-          <a:xfrm>
-            <a:off x="822960" y="3026664"/>
-            <a:ext cx="2834640" cy="411480"/>
-          </a:xfrm>
-          <a:prstGeom prst="rect">
-            <a:avLst/>
-          </a:prstGeom>
-          <a:noFill/>
-          <a:ln/>
-        </p:spPr>
-        <p:txBody>
-          <a:bodyPr wrap="square" rtlCol="0" anchor="ctr"/>
-          <a:lstStyle/>
-          <a:p>
-            <a:pPr indent="0" marL="0">
-              <a:buNone/>
-            </a:pPr>
-            <a:r>
-              <a:rPr lang="en-US" sz="1200" b="1" dirty="0">
+          <p:cNvPr id="11" name="Text 9"/>
+          <p:cNvSpPr/>
+          <p:nvPr/>
+        </p:nvSpPr>
+        <p:spPr>
+          <a:xfrm>
+            <a:off x="960120" y="4901184"/>
+            <a:ext cx="3383280" cy="640080"/>
+          </a:xfrm>
+          <a:prstGeom prst="rect">
+            <a:avLst/>
+          </a:prstGeom>
+          <a:noFill/>
+          <a:ln/>
+        </p:spPr>
+        <p:txBody>
+          <a:bodyPr wrap="square" rtlCol="0" anchor="ctr"/>
+          <a:lstStyle/>
+          <a:p>
+            <a:pPr indent="0" marL="0">
+              <a:buNone/>
+            </a:pPr>
+            <a:r>
+              <a:rPr lang="en-US" sz="2200" b="1" dirty="0">
                 <a:solidFill>
                   <a:srgbClr val="1E2761"/>
                 </a:solidFill>
-                <a:latin typeface="Calibri" pitchFamily="34" charset="0"/>
-                <a:ea typeface="Calibri" pitchFamily="34" charset="-122"/>
-                <a:cs typeface="Calibri" pitchFamily="34" charset="-120"/>
-              </a:rPr>
-              <a:t>R2 · DB + RLS</a:t>
-            </a:r>
-            <a:endParaRPr lang="en-US" sz="1200" dirty="0"/>
-          </a:p>
-        </p:txBody>
-      </p:sp>
-      <p:sp>
-        <p:nvSpPr>
-          <p:cNvPr id="16" name="Text 14"/>
-          <p:cNvSpPr/>
-          <p:nvPr/>
-        </p:nvSpPr>
-        <p:spPr>
-          <a:xfrm>
-            <a:off x="3749040" y="3026664"/>
-            <a:ext cx="2377440" cy="411480"/>
-          </a:xfrm>
-          <a:prstGeom prst="rect">
-            <a:avLst/>
-          </a:prstGeom>
-          <a:noFill/>
-          <a:ln/>
-        </p:spPr>
-        <p:txBody>
-          <a:bodyPr wrap="square" rtlCol="0" anchor="ctr"/>
-          <a:lstStyle/>
-          <a:p>
-            <a:pPr algn="ctr" indent="0" marL="0">
-              <a:buNone/>
-            </a:pPr>
-            <a:r>
-              <a:rPr lang="en-US" sz="1150" dirty="0">
+                <a:latin typeface="Cambria" pitchFamily="34" charset="0"/>
+                <a:ea typeface="Cambria" pitchFamily="34" charset="-122"/>
+                <a:cs typeface="Cambria" pitchFamily="34" charset="-120"/>
+              </a:rPr>
+              <a:t>DOXA</a:t>
+            </a:r>
+            <a:endParaRPr lang="en-US" sz="2200" dirty="0"/>
+          </a:p>
+        </p:txBody>
+      </p:sp>
+      <p:sp>
+        <p:nvSpPr>
+          <p:cNvPr id="12" name="Text 10"/>
+          <p:cNvSpPr/>
+          <p:nvPr/>
+        </p:nvSpPr>
+        <p:spPr>
+          <a:xfrm>
+            <a:off x="4023360" y="4864608"/>
+            <a:ext cx="7315200" cy="640080"/>
+          </a:xfrm>
+          <a:prstGeom prst="rect">
+            <a:avLst/>
+          </a:prstGeom>
+          <a:noFill/>
+          <a:ln/>
+        </p:spPr>
+        <p:txBody>
+          <a:bodyPr wrap="square" rtlCol="0" anchor="ctr"/>
+          <a:lstStyle/>
+          <a:p>
+            <a:pPr indent="0" marL="0">
+              <a:buNone/>
+            </a:pPr>
+            <a:r>
+              <a:rPr lang="en-US" sz="1600" dirty="0">
                 <a:solidFill>
                   <a:srgbClr val="1F2937"/>
                 </a:solidFill>
@@ -8834,112 +10315,73 @@
                 <a:ea typeface="Calibri" pitchFamily="34" charset="-122"/>
                 <a:cs typeface="Calibri" pitchFamily="34" charset="-120"/>
               </a:rPr>
-              <a:t>$0.22 · 11 tests</a:t>
-            </a:r>
-            <a:endParaRPr lang="en-US" sz="1150" dirty="0"/>
-          </a:p>
-        </p:txBody>
-      </p:sp>
-      <p:sp>
-        <p:nvSpPr>
-          <p:cNvPr id="17" name="Text 15"/>
-          <p:cNvSpPr/>
-          <p:nvPr/>
-        </p:nvSpPr>
-        <p:spPr>
-          <a:xfrm>
-            <a:off x="6309360" y="3026664"/>
-            <a:ext cx="2377440" cy="411480"/>
-          </a:xfrm>
-          <a:prstGeom prst="rect">
-            <a:avLst/>
-          </a:prstGeom>
-          <a:noFill/>
-          <a:ln/>
-        </p:spPr>
-        <p:txBody>
-          <a:bodyPr wrap="square" rtlCol="0" anchor="ctr"/>
-          <a:lstStyle/>
-          <a:p>
-            <a:pPr algn="ctr" indent="0" marL="0">
-              <a:buNone/>
-            </a:pPr>
-            <a:r>
-              <a:rPr lang="en-US" sz="1150" dirty="0">
-                <a:solidFill>
-                  <a:srgbClr val="1F2937"/>
-                </a:solidFill>
-                <a:latin typeface="Calibri" pitchFamily="34" charset="0"/>
-                <a:ea typeface="Calibri" pitchFamily="34" charset="-122"/>
-                <a:cs typeface="Calibri" pitchFamily="34" charset="-120"/>
-              </a:rPr>
-              <a:t>$0.27 · 11 tests</a:t>
-            </a:r>
-            <a:endParaRPr lang="en-US" sz="1150" dirty="0"/>
-          </a:p>
-        </p:txBody>
-      </p:sp>
-      <p:sp>
-        <p:nvSpPr>
-          <p:cNvPr id="18" name="Text 16"/>
-          <p:cNvSpPr/>
-          <p:nvPr/>
-        </p:nvSpPr>
-        <p:spPr>
-          <a:xfrm>
-            <a:off x="8869680" y="3026664"/>
-            <a:ext cx="2560320" cy="411480"/>
-          </a:xfrm>
-          <a:prstGeom prst="rect">
-            <a:avLst/>
-          </a:prstGeom>
-          <a:noFill/>
-          <a:ln/>
-        </p:spPr>
-        <p:txBody>
-          <a:bodyPr wrap="square" rtlCol="0" anchor="ctr"/>
-          <a:lstStyle/>
-          <a:p>
-            <a:pPr algn="ctr" indent="0" marL="0">
-              <a:buNone/>
-            </a:pPr>
-            <a:r>
-              <a:rPr lang="en-US" sz="1150" dirty="0">
-                <a:solidFill>
-                  <a:srgbClr val="1B5E20"/>
-                </a:solidFill>
-                <a:latin typeface="Calibri" pitchFamily="34" charset="0"/>
-                <a:ea typeface="Calibri" pitchFamily="34" charset="-122"/>
-                <a:cs typeface="Calibri" pitchFamily="34" charset="-120"/>
-              </a:rPr>
-              <a:t>$0.67 · 11 tests + plan/QA</a:t>
-            </a:r>
-            <a:endParaRPr lang="en-US" sz="1150" dirty="0"/>
-          </a:p>
-        </p:txBody>
-      </p:sp>
-      <p:sp>
-        <p:nvSpPr>
-          <p:cNvPr id="19" name="Shape 17"/>
-          <p:cNvSpPr/>
-          <p:nvPr/>
-        </p:nvSpPr>
-        <p:spPr>
-          <a:xfrm>
-            <a:off x="685800" y="3648456"/>
-            <a:ext cx="10835640" cy="658368"/>
+              <a:t>US · staffing — multiple projects under NDA · POC in 1 week</a:t>
+            </a:r>
+            <a:endParaRPr lang="en-US" sz="1600" dirty="0"/>
+          </a:p>
+        </p:txBody>
+      </p:sp>
+      <p:sp>
+        <p:nvSpPr>
+          <p:cNvPr id="13" name="Text 11"/>
+          <p:cNvSpPr/>
+          <p:nvPr/>
+        </p:nvSpPr>
+        <p:spPr>
+          <a:xfrm>
+            <a:off x="685800" y="5760720"/>
+            <a:ext cx="10835640" cy="365760"/>
+          </a:xfrm>
+          <a:prstGeom prst="rect">
+            <a:avLst/>
+          </a:prstGeom>
+          <a:noFill/>
+          <a:ln/>
+        </p:spPr>
+        <p:txBody>
+          <a:bodyPr wrap="square" rtlCol="0" anchor="ctr"/>
+          <a:lstStyle/>
+          <a:p>
+            <a:pPr indent="0" marL="0">
+              <a:buNone/>
+            </a:pPr>
+            <a:r>
+              <a:rPr lang="en-US" sz="1400" i="1" dirty="0">
+                <a:solidFill>
+                  <a:srgbClr val="6B7280"/>
+                </a:solidFill>
+                <a:latin typeface="Calibri" pitchFamily="34" charset="0"/>
+                <a:ea typeface="Calibri" pitchFamily="34" charset="-122"/>
+                <a:cs typeface="Calibri" pitchFamily="34" charset="-120"/>
+              </a:rPr>
+              <a:t>Both: non-technical founders, one engineer of support, one engineer of trust.</a:t>
+            </a:r>
+            <a:endParaRPr lang="en-US" sz="1400" dirty="0"/>
+          </a:p>
+        </p:txBody>
+      </p:sp>
+      <p:sp>
+        <p:nvSpPr>
+          <p:cNvPr id="14" name="Shape 12"/>
+          <p:cNvSpPr/>
+          <p:nvPr/>
+        </p:nvSpPr>
+        <p:spPr>
+          <a:xfrm>
+            <a:off x="685800" y="6172200"/>
+            <a:ext cx="1170432" cy="292608"/>
           </a:xfrm>
           <a:prstGeom prst="roundRect">
             <a:avLst>
-              <a:gd name="adj" fmla="val 13889"/>
+              <a:gd name="adj" fmla="val 50000"/>
             </a:avLst>
           </a:prstGeom>
           <a:solidFill>
-            <a:srgbClr val="F8FAFC"/>
+            <a:srgbClr val="B98A00"/>
           </a:solidFill>
-          <a:ln w="15875">
+          <a:ln w="12700">
             <a:solidFill>
-              <a:srgbClr val="D1D5DB"/>
+              <a:srgbClr val="B98A00"/>
             </a:solidFill>
             <a:prstDash val="solid"/>
           </a:ln>
@@ -8947,408 +10389,69 @@
       </p:sp>
       <p:sp>
         <p:nvSpPr>
-          <p:cNvPr id="20" name="Text 18"/>
-          <p:cNvSpPr/>
-          <p:nvPr/>
-        </p:nvSpPr>
-        <p:spPr>
-          <a:xfrm>
-            <a:off x="822960" y="3776472"/>
-            <a:ext cx="2834640" cy="411480"/>
-          </a:xfrm>
-          <a:prstGeom prst="rect">
-            <a:avLst/>
-          </a:prstGeom>
-          <a:noFill/>
-          <a:ln/>
-        </p:spPr>
-        <p:txBody>
-          <a:bodyPr wrap="square" rtlCol="0" anchor="ctr"/>
-          <a:lstStyle/>
-          <a:p>
-            <a:pPr indent="0" marL="0">
-              <a:buNone/>
-            </a:pPr>
-            <a:r>
-              <a:rPr lang="en-US" sz="1200" b="1" dirty="0">
-                <a:solidFill>
-                  <a:srgbClr val="1E2761"/>
-                </a:solidFill>
-                <a:latin typeface="Calibri" pitchFamily="34" charset="0"/>
-                <a:ea typeface="Calibri" pitchFamily="34" charset="-122"/>
-                <a:cs typeface="Calibri" pitchFamily="34" charset="-120"/>
-              </a:rPr>
-              <a:t>R4 · fragile refactor</a:t>
-            </a:r>
-            <a:endParaRPr lang="en-US" sz="1200" dirty="0"/>
-          </a:p>
-        </p:txBody>
-      </p:sp>
-      <p:sp>
-        <p:nvSpPr>
-          <p:cNvPr id="21" name="Text 19"/>
-          <p:cNvSpPr/>
-          <p:nvPr/>
-        </p:nvSpPr>
-        <p:spPr>
-          <a:xfrm>
-            <a:off x="3749040" y="3776472"/>
-            <a:ext cx="2377440" cy="411480"/>
-          </a:xfrm>
-          <a:prstGeom prst="rect">
-            <a:avLst/>
-          </a:prstGeom>
-          <a:noFill/>
-          <a:ln/>
-        </p:spPr>
-        <p:txBody>
-          <a:bodyPr wrap="square" rtlCol="0" anchor="ctr"/>
+          <p:cNvPr id="15" name="Text 13"/>
+          <p:cNvSpPr/>
+          <p:nvPr/>
+        </p:nvSpPr>
+        <p:spPr>
+          <a:xfrm>
+            <a:off x="685800" y="6144768"/>
+            <a:ext cx="1170432" cy="292608"/>
+          </a:xfrm>
+          <a:prstGeom prst="rect">
+            <a:avLst/>
+          </a:prstGeom>
+          <a:noFill/>
+          <a:ln/>
+        </p:spPr>
+        <p:txBody>
+          <a:bodyPr wrap="square" lIns="0" tIns="0" rIns="0" bIns="0" rtlCol="0" anchor="ctr"/>
           <a:lstStyle/>
           <a:p>
             <a:pPr algn="ctr" indent="0" marL="0">
               <a:buNone/>
             </a:pPr>
             <a:r>
-              <a:rPr lang="en-US" sz="1150" dirty="0">
-                <a:solidFill>
-                  <a:srgbClr val="1F2937"/>
-                </a:solidFill>
-                <a:latin typeface="Calibri" pitchFamily="34" charset="0"/>
-                <a:ea typeface="Calibri" pitchFamily="34" charset="-122"/>
-                <a:cs typeface="Calibri" pitchFamily="34" charset="-120"/>
-              </a:rPr>
-              <a:t>refused · restraint pass</a:t>
-            </a:r>
-            <a:endParaRPr lang="en-US" sz="1150" dirty="0"/>
-          </a:p>
-        </p:txBody>
-      </p:sp>
-      <p:sp>
-        <p:nvSpPr>
-          <p:cNvPr id="22" name="Text 20"/>
-          <p:cNvSpPr/>
-          <p:nvPr/>
-        </p:nvSpPr>
-        <p:spPr>
-          <a:xfrm>
-            <a:off x="6309360" y="3776472"/>
-            <a:ext cx="2377440" cy="411480"/>
-          </a:xfrm>
-          <a:prstGeom prst="rect">
-            <a:avLst/>
-          </a:prstGeom>
-          <a:noFill/>
-          <a:ln/>
-        </p:spPr>
-        <p:txBody>
-          <a:bodyPr wrap="square" rtlCol="0" anchor="ctr"/>
-          <a:lstStyle/>
-          <a:p>
-            <a:pPr algn="ctr" indent="0" marL="0">
-              <a:buNone/>
-            </a:pPr>
-            <a:r>
-              <a:rPr lang="en-US" sz="1150" dirty="0">
-                <a:solidFill>
-                  <a:srgbClr val="1F2937"/>
-                </a:solidFill>
-                <a:latin typeface="Calibri" pitchFamily="34" charset="0"/>
-                <a:ea typeface="Calibri" pitchFamily="34" charset="-122"/>
-                <a:cs typeface="Calibri" pitchFamily="34" charset="-120"/>
-              </a:rPr>
-              <a:t>—</a:t>
-            </a:r>
-            <a:endParaRPr lang="en-US" sz="1150" dirty="0"/>
-          </a:p>
-        </p:txBody>
-      </p:sp>
-      <p:sp>
-        <p:nvSpPr>
-          <p:cNvPr id="23" name="Text 21"/>
-          <p:cNvSpPr/>
-          <p:nvPr/>
-        </p:nvSpPr>
-        <p:spPr>
-          <a:xfrm>
-            <a:off x="8869680" y="3776472"/>
-            <a:ext cx="2560320" cy="411480"/>
-          </a:xfrm>
-          <a:prstGeom prst="rect">
-            <a:avLst/>
-          </a:prstGeom>
-          <a:noFill/>
-          <a:ln/>
-        </p:spPr>
-        <p:txBody>
-          <a:bodyPr wrap="square" rtlCol="0" anchor="ctr"/>
-          <a:lstStyle/>
-          <a:p>
-            <a:pPr algn="ctr" indent="0" marL="0">
-              <a:buNone/>
-            </a:pPr>
-            <a:r>
-              <a:rPr lang="en-US" sz="1150" dirty="0">
-                <a:solidFill>
-                  <a:srgbClr val="1B5E20"/>
-                </a:solidFill>
-                <a:latin typeface="Calibri" pitchFamily="34" charset="0"/>
-                <a:ea typeface="Calibri" pitchFamily="34" charset="-122"/>
-                <a:cs typeface="Calibri" pitchFamily="34" charset="-120"/>
-              </a:rPr>
-              <a:t>violated (guardrail advisory) · prod-correct when approved</a:t>
-            </a:r>
-            <a:endParaRPr lang="en-US" sz="1150" dirty="0"/>
-          </a:p>
-        </p:txBody>
-      </p:sp>
-      <p:sp>
-        <p:nvSpPr>
-          <p:cNvPr id="24" name="Shape 22"/>
-          <p:cNvSpPr/>
-          <p:nvPr/>
-        </p:nvSpPr>
-        <p:spPr>
-          <a:xfrm>
-            <a:off x="685800" y="4398264"/>
-            <a:ext cx="10835640" cy="658368"/>
-          </a:xfrm>
-          <a:prstGeom prst="roundRect">
-            <a:avLst>
-              <a:gd name="adj" fmla="val 13889"/>
-            </a:avLst>
-          </a:prstGeom>
-          <a:solidFill>
-            <a:srgbClr val="F8FAFC"/>
-          </a:solidFill>
-          <a:ln w="15875">
-            <a:solidFill>
-              <a:srgbClr val="D1D5DB"/>
-            </a:solidFill>
-            <a:prstDash val="solid"/>
-          </a:ln>
-        </p:spPr>
-      </p:sp>
-      <p:sp>
-        <p:nvSpPr>
-          <p:cNvPr id="25" name="Text 23"/>
-          <p:cNvSpPr/>
-          <p:nvPr/>
-        </p:nvSpPr>
-        <p:spPr>
-          <a:xfrm>
-            <a:off x="822960" y="4526280"/>
-            <a:ext cx="2834640" cy="411480"/>
-          </a:xfrm>
-          <a:prstGeom prst="rect">
-            <a:avLst/>
-          </a:prstGeom>
-          <a:noFill/>
-          <a:ln/>
-        </p:spPr>
-        <p:txBody>
-          <a:bodyPr wrap="square" rtlCol="0" anchor="ctr"/>
-          <a:lstStyle/>
-          <a:p>
-            <a:pPr indent="0" marL="0">
-              <a:buNone/>
-            </a:pPr>
-            <a:r>
-              <a:rPr lang="en-US" sz="1200" b="1" dirty="0">
-                <a:solidFill>
-                  <a:srgbClr val="1E2761"/>
-                </a:solidFill>
-                <a:latin typeface="Calibri" pitchFamily="34" charset="0"/>
-                <a:ea typeface="Calibri" pitchFamily="34" charset="-122"/>
-                <a:cs typeface="Calibri" pitchFamily="34" charset="-120"/>
-              </a:rPr>
-              <a:t>R3 · vertical FE+BE</a:t>
-            </a:r>
-            <a:endParaRPr lang="en-US" sz="1200" dirty="0"/>
-          </a:p>
-        </p:txBody>
-      </p:sp>
-      <p:sp>
-        <p:nvSpPr>
-          <p:cNvPr id="26" name="Text 24"/>
-          <p:cNvSpPr/>
-          <p:nvPr/>
-        </p:nvSpPr>
-        <p:spPr>
-          <a:xfrm>
-            <a:off x="3749040" y="4526280"/>
-            <a:ext cx="2377440" cy="411480"/>
-          </a:xfrm>
-          <a:prstGeom prst="rect">
-            <a:avLst/>
-          </a:prstGeom>
-          <a:noFill/>
-          <a:ln/>
-        </p:spPr>
-        <p:txBody>
-          <a:bodyPr wrap="square" rtlCol="0" anchor="ctr"/>
-          <a:lstStyle/>
-          <a:p>
-            <a:pPr algn="ctr" indent="0" marL="0">
-              <a:buNone/>
-            </a:pPr>
-            <a:r>
-              <a:rPr lang="en-US" sz="1150" dirty="0">
-                <a:solidFill>
-                  <a:srgbClr val="1F2937"/>
-                </a:solidFill>
-                <a:latin typeface="Calibri" pitchFamily="34" charset="0"/>
-                <a:ea typeface="Calibri" pitchFamily="34" charset="-122"/>
-                <a:cs typeface="Calibri" pitchFamily="34" charset="-120"/>
-              </a:rPr>
-              <a:t>$0.94 · 4 tests</a:t>
-            </a:r>
-            <a:endParaRPr lang="en-US" sz="1150" dirty="0"/>
-          </a:p>
-        </p:txBody>
-      </p:sp>
-      <p:sp>
-        <p:nvSpPr>
-          <p:cNvPr id="27" name="Text 25"/>
-          <p:cNvSpPr/>
-          <p:nvPr/>
-        </p:nvSpPr>
-        <p:spPr>
-          <a:xfrm>
-            <a:off x="6309360" y="4526280"/>
-            <a:ext cx="2377440" cy="411480"/>
-          </a:xfrm>
-          <a:prstGeom prst="rect">
-            <a:avLst/>
-          </a:prstGeom>
-          <a:noFill/>
-          <a:ln/>
-        </p:spPr>
-        <p:txBody>
-          <a:bodyPr wrap="square" rtlCol="0" anchor="ctr"/>
-          <a:lstStyle/>
-          <a:p>
-            <a:pPr algn="ctr" indent="0" marL="0">
-              <a:buNone/>
-            </a:pPr>
-            <a:r>
-              <a:rPr lang="en-US" sz="1150" dirty="0">
-                <a:solidFill>
-                  <a:srgbClr val="1F2937"/>
-                </a:solidFill>
-                <a:latin typeface="Calibri" pitchFamily="34" charset="0"/>
-                <a:ea typeface="Calibri" pitchFamily="34" charset="-122"/>
-                <a:cs typeface="Calibri" pitchFamily="34" charset="-120"/>
-              </a:rPr>
-              <a:t>—</a:t>
-            </a:r>
-            <a:endParaRPr lang="en-US" sz="1150" dirty="0"/>
-          </a:p>
-        </p:txBody>
-      </p:sp>
-      <p:sp>
-        <p:nvSpPr>
-          <p:cNvPr id="28" name="Text 26"/>
-          <p:cNvSpPr/>
-          <p:nvPr/>
-        </p:nvSpPr>
-        <p:spPr>
-          <a:xfrm>
-            <a:off x="8869680" y="4526280"/>
-            <a:ext cx="2560320" cy="411480"/>
-          </a:xfrm>
-          <a:prstGeom prst="rect">
-            <a:avLst/>
-          </a:prstGeom>
-          <a:noFill/>
-          <a:ln/>
-        </p:spPr>
-        <p:txBody>
-          <a:bodyPr wrap="square" rtlCol="0" anchor="ctr"/>
-          <a:lstStyle/>
-          <a:p>
-            <a:pPr algn="ctr" indent="0" marL="0">
-              <a:buNone/>
-            </a:pPr>
-            <a:r>
-              <a:rPr lang="en-US" sz="1150" dirty="0">
-                <a:solidFill>
-                  <a:srgbClr val="1B5E20"/>
-                </a:solidFill>
-                <a:latin typeface="Calibri" pitchFamily="34" charset="0"/>
-                <a:ea typeface="Calibri" pitchFamily="34" charset="-122"/>
-                <a:cs typeface="Calibri" pitchFamily="34" charset="-120"/>
-              </a:rPr>
-              <a:t>$0.98 · 4 tests + plan/tasks</a:t>
-            </a:r>
-            <a:endParaRPr lang="en-US" sz="1150" dirty="0"/>
-          </a:p>
-        </p:txBody>
-      </p:sp>
-      <p:sp>
-        <p:nvSpPr>
-          <p:cNvPr id="29" name="Text 27"/>
-          <p:cNvSpPr/>
-          <p:nvPr/>
-        </p:nvSpPr>
-        <p:spPr>
-          <a:xfrm>
-            <a:off x="685800" y="5486400"/>
-            <a:ext cx="10835640" cy="502920"/>
-          </a:xfrm>
-          <a:prstGeom prst="rect">
-            <a:avLst/>
-          </a:prstGeom>
-          <a:noFill/>
-          <a:ln/>
-        </p:spPr>
-        <p:txBody>
-          <a:bodyPr wrap="square" rtlCol="0" anchor="ctr"/>
-          <a:lstStyle/>
-          <a:p>
-            <a:pPr indent="0" marL="0">
-              <a:buNone/>
-            </a:pPr>
-            <a:r>
-              <a:rPr lang="en-US" sz="1400" b="1" dirty="0">
-                <a:solidFill>
-                  <a:srgbClr val="1E2761"/>
-                </a:solidFill>
-                <a:latin typeface="Calibri" pitchFamily="34" charset="0"/>
-                <a:ea typeface="Calibri" pitchFamily="34" charset="-122"/>
-                <a:cs typeface="Calibri" pitchFamily="34" charset="-120"/>
-              </a:rPr>
-              <a:t>Findings: passive ≈ bare (placebo) · activation tax scales with ceremony, benefit with risk · restraint is advisory, not structural · QA lane is the value on risky approved change.</a:t>
-            </a:r>
-            <a:endParaRPr lang="en-US" sz="1400" dirty="0"/>
-          </a:p>
-        </p:txBody>
-      </p:sp>
-      <p:sp>
-        <p:nvSpPr>
-          <p:cNvPr id="30" name="Text 28"/>
-          <p:cNvSpPr/>
-          <p:nvPr/>
-        </p:nvSpPr>
-        <p:spPr>
-          <a:xfrm>
-            <a:off x="685800" y="6080760"/>
-            <a:ext cx="10835640" cy="411480"/>
-          </a:xfrm>
-          <a:prstGeom prst="rect">
-            <a:avLst/>
-          </a:prstGeom>
-          <a:noFill/>
-          <a:ln/>
-        </p:spPr>
-        <p:txBody>
-          <a:bodyPr wrap="square" rtlCol="0" anchor="ctr"/>
-          <a:lstStyle/>
-          <a:p>
-            <a:pPr indent="0" marL="0">
-              <a:buNone/>
-            </a:pPr>
-            <a:r>
-              <a:rPr lang="en-US" sz="1400" i="1" dirty="0">
+              <a:rPr lang="en-US" sz="1100" b="1" dirty="0">
+                <a:solidFill>
+                  <a:srgbClr val="FFFFFF"/>
+                </a:solidFill>
+                <a:latin typeface="Calibri" pitchFamily="34" charset="0"/>
+                <a:ea typeface="Calibri" pitchFamily="34" charset="-122"/>
+                <a:cs typeface="Calibri" pitchFamily="34" charset="-120"/>
+              </a:rPr>
+              <a:t>CASE STUDY</a:t>
+            </a:r>
+            <a:endParaRPr lang="en-US" sz="1100" dirty="0"/>
+          </a:p>
+        </p:txBody>
+      </p:sp>
+      <p:sp>
+        <p:nvSpPr>
+          <p:cNvPr id="16" name="Text 14"/>
+          <p:cNvSpPr/>
+          <p:nvPr/>
+        </p:nvSpPr>
+        <p:spPr>
+          <a:xfrm>
+            <a:off x="2194560" y="6199632"/>
+            <a:ext cx="9326880" cy="320040"/>
+          </a:xfrm>
+          <a:prstGeom prst="rect">
+            <a:avLst/>
+          </a:prstGeom>
+          <a:noFill/>
+          <a:ln/>
+        </p:spPr>
+        <p:txBody>
+          <a:bodyPr wrap="square" rtlCol="0" anchor="ctr"/>
+          <a:lstStyle/>
+          <a:p>
+            <a:pPr indent="0" marL="0">
+              <a:buNone/>
+            </a:pPr>
+            <a:r>
+              <a:rPr lang="en-US" sz="1400" dirty="0">
                 <a:solidFill>
                   <a:srgbClr val="6B7280"/>
                 </a:solidFill>
@@ -9356,7 +10459,7 @@
                 <a:ea typeface="Calibri" pitchFamily="34" charset="-122"/>
                 <a:cs typeface="Calibri" pitchFamily="34" charset="-120"/>
               </a:rPr>
-              <a:t>Harness gap fixed via dev-agent-router (16→17 skills) · DeepSeek pin since R2 · world anchor: SWE-bench-style floor check pending.</a:t>
+              <a:t>Confounded: model mix drifted mid-build · no cost tracking · n = 2</a:t>
             </a:r>
             <a:endParaRPr lang="en-US" sz="1400" dirty="0"/>
           </a:p>

</xml_diff>

<commit_message>
deck: framework history — v1 origin slide (8 agents, 10 overnight cron routines, silent hooks, from talentedgeai/infinite-leverage commit tree) + v1-vs-v2 trade-off comparison slide; devops lane notice (demo guide + evidence slide); links slide gains v1 repo
</commit_message>
<xml_diff>
--- a/docs/slides/Agentic-SDLC-Tech-Audience.pptx
+++ b/docs/slides/Agentic-SDLC-Tech-Audience.pptx
@@ -20,9 +20,11 @@
     <p:sldId id="268" r:id="rId14"/>
     <p:sldId id="269" r:id="rId15"/>
     <p:sldId id="270" r:id="rId16"/>
+    <p:sldId id="271" r:id="rId17"/>
+    <p:sldId id="272" r:id="rId18"/>
   </p:sldIdLst>
   <p:notesMasterIdLst>
-    <p:notesMasterId r:id="rId17"/>
+    <p:notesMasterId r:id="rId19"/>
   </p:notesMasterIdLst>
   <p:sldSz cx="12192000" cy="6858000"/>
   <p:notesSz cx="6858000" cy="12192000"/>
@@ -1044,7 +1046,7 @@
           <a:p>
             <a:r>
               <a:rPr lang="en-US" dirty="0"/>
-              <a:t>Close on the gaps. That is the part we defend most.</a:t>
+              <a:t>The original pitch: an agent team that builds and markets, running overnight with no human. It worked — until the machine drifted.</a:t>
             </a:r>
             <a:endParaRPr lang="en-US" dirty="0"/>
           </a:p>
@@ -1068,6 +1070,182 @@
             <a:fld id="{F7021451-1387-4CA6-816F-3879F97B5CBC}" type="slidenum">
               <a:rPr lang="en-US"/>
               <a:t>15</a:t>
+            </a:fld>
+            <a:endParaRPr lang="en-US"/>
+          </a:p>
+        </p:txBody>
+      </p:sp>
+    </p:spTree>
+    <p:extLst>
+      <p:ext uri="{BB962C8B-B14F-4D97-AF65-F5344CB8AC3E}">
+        <p14:creationId xmlns:p14="http://schemas.microsoft.com/office/powerpoint/2010/main" val="1024086991"/>
+      </p:ext>
+    </p:extLst>
+  </p:cSld>
+  <p:clrMapOvr>
+    <a:masterClrMapping/>
+  </p:clrMapOvr>
+</p:notes>
+</file>
+
+<file path=ppt/notesSlides/notesSlide16.xml><?xml version="1.0" encoding="utf-8"?>
+<p:notes xmlns:a="http://schemas.openxmlformats.org/drawingml/2006/main" xmlns:r="http://schemas.openxmlformats.org/officeDocument/2006/relationships" xmlns:p="http://schemas.openxmlformats.org/presentationml/2006/main">
+  <p:cSld>
+    <p:spTree>
+      <p:nvGrpSpPr>
+        <p:cNvPr id="1" name=""/>
+        <p:cNvGrpSpPr/>
+        <p:nvPr/>
+      </p:nvGrpSpPr>
+      <p:grpSpPr>
+        <a:xfrm>
+          <a:off x="0" y="0"/>
+          <a:ext cx="0" cy="0"/>
+          <a:chOff x="0" y="0"/>
+          <a:chExt cx="0" cy="0"/>
+        </a:xfrm>
+      </p:grpSpPr>
+      <p:sp>
+        <p:nvSpPr>
+          <p:cNvPr id="2" name="Slide Image Placeholder 1"/>
+          <p:cNvSpPr>
+            <a:spLocks noGrp="1" noRot="1" noChangeAspect="1"/>
+          </p:cNvSpPr>
+          <p:nvPr>
+            <p:ph type="sldImg"/>
+          </p:nvPr>
+        </p:nvSpPr>
+        <p:spPr/>
+      </p:sp>
+      <p:sp>
+        <p:nvSpPr>
+          <p:cNvPr id="3" name="Notes Placeholder 2"/>
+          <p:cNvSpPr>
+            <a:spLocks noGrp="1"/>
+          </p:cNvSpPr>
+          <p:nvPr>
+            <p:ph type="body" idx="1"/>
+          </p:nvPr>
+        </p:nvSpPr>
+        <p:spPr/>
+        <p:txBody>
+          <a:bodyPr/>
+          <a:lstStyle/>
+          <a:p>
+            <a:r>
+              <a:rPr lang="en-US" dirty="0"/>
+              <a:t>The honest version of the story: v1 worked until it drifted. v2 gave up overnight autonomy for gates that hold.</a:t>
+            </a:r>
+            <a:endParaRPr lang="en-US" dirty="0"/>
+          </a:p>
+        </p:txBody>
+      </p:sp>
+      <p:sp>
+        <p:nvSpPr>
+          <p:cNvPr id="4" name="Slide Number Placeholder 3"/>
+          <p:cNvSpPr>
+            <a:spLocks noGrp="1"/>
+          </p:cNvSpPr>
+          <p:nvPr>
+            <p:ph type="sldNum" sz="quarter" idx="10"/>
+          </p:nvPr>
+        </p:nvSpPr>
+        <p:spPr/>
+        <p:txBody>
+          <a:bodyPr/>
+          <a:lstStyle/>
+          <a:p>
+            <a:fld id="{F7021451-1387-4CA6-816F-3879F97B5CBC}" type="slidenum">
+              <a:rPr lang="en-US"/>
+              <a:t>16</a:t>
+            </a:fld>
+            <a:endParaRPr lang="en-US"/>
+          </a:p>
+        </p:txBody>
+      </p:sp>
+    </p:spTree>
+    <p:extLst>
+      <p:ext uri="{BB962C8B-B14F-4D97-AF65-F5344CB8AC3E}">
+        <p14:creationId xmlns:p14="http://schemas.microsoft.com/office/powerpoint/2010/main" val="1024086991"/>
+      </p:ext>
+    </p:extLst>
+  </p:cSld>
+  <p:clrMapOvr>
+    <a:masterClrMapping/>
+  </p:clrMapOvr>
+</p:notes>
+</file>
+
+<file path=ppt/notesSlides/notesSlide17.xml><?xml version="1.0" encoding="utf-8"?>
+<p:notes xmlns:a="http://schemas.openxmlformats.org/drawingml/2006/main" xmlns:r="http://schemas.openxmlformats.org/officeDocument/2006/relationships" xmlns:p="http://schemas.openxmlformats.org/presentationml/2006/main">
+  <p:cSld>
+    <p:spTree>
+      <p:nvGrpSpPr>
+        <p:cNvPr id="1" name=""/>
+        <p:cNvGrpSpPr/>
+        <p:nvPr/>
+      </p:nvGrpSpPr>
+      <p:grpSpPr>
+        <a:xfrm>
+          <a:off x="0" y="0"/>
+          <a:ext cx="0" cy="0"/>
+          <a:chOff x="0" y="0"/>
+          <a:chExt cx="0" cy="0"/>
+        </a:xfrm>
+      </p:grpSpPr>
+      <p:sp>
+        <p:nvSpPr>
+          <p:cNvPr id="2" name="Slide Image Placeholder 1"/>
+          <p:cNvSpPr>
+            <a:spLocks noGrp="1" noRot="1" noChangeAspect="1"/>
+          </p:cNvSpPr>
+          <p:nvPr>
+            <p:ph type="sldImg"/>
+          </p:nvPr>
+        </p:nvSpPr>
+        <p:spPr/>
+      </p:sp>
+      <p:sp>
+        <p:nvSpPr>
+          <p:cNvPr id="3" name="Notes Placeholder 2"/>
+          <p:cNvSpPr>
+            <a:spLocks noGrp="1"/>
+          </p:cNvSpPr>
+          <p:nvPr>
+            <p:ph type="body" idx="1"/>
+          </p:nvPr>
+        </p:nvSpPr>
+        <p:spPr/>
+        <p:txBody>
+          <a:bodyPr/>
+          <a:lstStyle/>
+          <a:p>
+            <a:r>
+              <a:rPr lang="en-US" dirty="0"/>
+              <a:t>Close on the gaps. That is the part we defend most.</a:t>
+            </a:r>
+            <a:endParaRPr lang="en-US" dirty="0"/>
+          </a:p>
+        </p:txBody>
+      </p:sp>
+      <p:sp>
+        <p:nvSpPr>
+          <p:cNvPr id="4" name="Slide Number Placeholder 3"/>
+          <p:cNvSpPr>
+            <a:spLocks noGrp="1"/>
+          </p:cNvSpPr>
+          <p:nvPr>
+            <p:ph type="sldNum" sz="quarter" idx="10"/>
+          </p:nvPr>
+        </p:nvSpPr>
+        <p:spPr/>
+        <p:txBody>
+          <a:bodyPr/>
+          <a:lstStyle/>
+          <a:p>
+            <a:fld id="{F7021451-1387-4CA6-816F-3879F97B5CBC}" type="slidenum">
+              <a:rPr lang="en-US"/>
+              <a:t>17</a:t>
             </a:fld>
             <a:endParaRPr lang="en-US"/>
           </a:p>
@@ -5034,8 +5212,8 @@
         </p:nvSpPr>
         <p:spPr>
           <a:xfrm>
-            <a:off x="685800" y="6035040"/>
-            <a:ext cx="10835640" cy="411480"/>
+            <a:off x="685800" y="5943600"/>
+            <a:ext cx="10835640" cy="365760"/>
           </a:xfrm>
           <a:prstGeom prst="rect">
             <a:avLst/>
@@ -5062,6 +5240,45 @@
               <a:t>Deliverables are the difference: the framework arm left a traceability trail — and finished 4.2× faster.</a:t>
             </a:r>
             <a:endParaRPr lang="en-US" sz="1400" dirty="0"/>
+          </a:p>
+        </p:txBody>
+      </p:sp>
+      <p:sp>
+        <p:nvSpPr>
+          <p:cNvPr id="30" name="Text 28"/>
+          <p:cNvSpPr/>
+          <p:nvPr/>
+        </p:nvSpPr>
+        <p:spPr>
+          <a:xfrm>
+            <a:off x="685800" y="6291072"/>
+            <a:ext cx="10835640" cy="320040"/>
+          </a:xfrm>
+          <a:prstGeom prst="rect">
+            <a:avLst/>
+          </a:prstGeom>
+          <a:noFill/>
+          <a:ln/>
+        </p:spPr>
+        <p:txBody>
+          <a:bodyPr wrap="square" rtlCol="0" anchor="ctr"/>
+          <a:lstStyle/>
+          <a:p>
+            <a:pPr indent="0" marL="0">
+              <a:buNone/>
+            </a:pPr>
+            <a:r>
+              <a:rPr lang="en-US" sz="1200" i="1" dirty="0">
+                <a:solidFill>
+                  <a:srgbClr val="6B7280"/>
+                </a:solidFill>
+                <a:latin typeface="Calibri" pitchFamily="34" charset="0"/>
+                <a:ea typeface="Calibri" pitchFamily="34" charset="-122"/>
+                <a:cs typeface="Calibri" pitchFamily="34" charset="-120"/>
+              </a:rPr>
+              <a:t>Offline gates only — the devops lanes (CI · Vercel ops · 60s rollback) fire on live projects; a lab bench never exercises them.</a:t>
+            </a:r>
+            <a:endParaRPr lang="en-US" sz="1200" dirty="0"/>
           </a:p>
         </p:txBody>
       </p:sp>
@@ -6337,12 +6554,12 @@
         </p:nvSpPr>
         <p:spPr>
           <a:xfrm>
-            <a:off x="685800" y="2148840"/>
-            <a:ext cx="10835640" cy="457200"/>
+            <a:off x="685800" y="2057400"/>
+            <a:ext cx="10835640" cy="420624"/>
           </a:xfrm>
           <a:prstGeom prst="roundRect">
             <a:avLst>
-              <a:gd name="adj" fmla="val 20000"/>
+              <a:gd name="adj" fmla="val 21739"/>
             </a:avLst>
           </a:prstGeom>
           <a:solidFill>
@@ -6364,8 +6581,8 @@
         </p:nvSpPr>
         <p:spPr>
           <a:xfrm>
-            <a:off x="914400" y="2221992"/>
-            <a:ext cx="5486400" cy="320040"/>
+            <a:off x="914400" y="2112264"/>
+            <a:ext cx="5486400" cy="310896"/>
           </a:xfrm>
           <a:prstGeom prst="rect">
             <a:avLst/>
@@ -6381,7 +6598,7 @@
               <a:buNone/>
             </a:pPr>
             <a:r>
-              <a:rPr lang="en-US" sz="1400" b="1" dirty="0">
+              <a:rPr lang="en-US" sz="1300" b="1" dirty="0">
                 <a:solidFill>
                   <a:srgbClr val="1E2761"/>
                 </a:solidFill>
@@ -6391,7 +6608,7 @@
               </a:rPr>
               <a:t>Framework · plugin · bench kit · deck source</a:t>
             </a:r>
-            <a:endParaRPr lang="en-US" sz="1400" dirty="0"/>
+            <a:endParaRPr lang="en-US" sz="1300" dirty="0"/>
           </a:p>
         </p:txBody>
       </p:sp>
@@ -6403,8 +6620,8 @@
         </p:nvSpPr>
         <p:spPr>
           <a:xfrm>
-            <a:off x="6492240" y="2221992"/>
-            <a:ext cx="4846320" cy="320040"/>
+            <a:off x="6492240" y="2112264"/>
+            <a:ext cx="4846320" cy="310896"/>
           </a:xfrm>
           <a:prstGeom prst="rect">
             <a:avLst/>
@@ -6420,7 +6637,7 @@
               <a:buNone/>
             </a:pPr>
             <a:r>
-              <a:rPr lang="en-US" sz="1300" dirty="0">
+              <a:rPr lang="en-US" sz="1200" dirty="0">
                 <a:solidFill>
                   <a:srgbClr val="2563EB"/>
                 </a:solidFill>
@@ -6430,7 +6647,7 @@
               </a:rPr>
               <a:t>github.com/trac41799/claude-code-agentic-sdlc</a:t>
             </a:r>
-            <a:endParaRPr lang="en-US" sz="1300" dirty="0"/>
+            <a:endParaRPr lang="en-US" sz="1200" dirty="0"/>
           </a:p>
         </p:txBody>
       </p:sp>
@@ -6442,12 +6659,12 @@
         </p:nvSpPr>
         <p:spPr>
           <a:xfrm>
-            <a:off x="685800" y="2660904"/>
-            <a:ext cx="10835640" cy="457200"/>
+            <a:off x="685800" y="2514600"/>
+            <a:ext cx="10835640" cy="420624"/>
           </a:xfrm>
           <a:prstGeom prst="roundRect">
             <a:avLst>
-              <a:gd name="adj" fmla="val 20000"/>
+              <a:gd name="adj" fmla="val 21739"/>
             </a:avLst>
           </a:prstGeom>
           <a:solidFill>
@@ -6469,8 +6686,8 @@
         </p:nvSpPr>
         <p:spPr>
           <a:xfrm>
-            <a:off x="914400" y="2734056"/>
-            <a:ext cx="5486400" cy="320040"/>
+            <a:off x="914400" y="2569464"/>
+            <a:ext cx="5486400" cy="310896"/>
           </a:xfrm>
           <a:prstGeom prst="rect">
             <a:avLst/>
@@ -6486,7 +6703,7 @@
               <a:buNone/>
             </a:pPr>
             <a:r>
-              <a:rPr lang="en-US" sz="1400" b="1" dirty="0">
+              <a:rPr lang="en-US" sz="1300" b="1" dirty="0">
                 <a:solidFill>
                   <a:srgbClr val="1E2761"/>
                 </a:solidFill>
@@ -6496,7 +6713,7 @@
               </a:rPr>
               <a:t>Benchmark evidence — 12 runs, repro commands</a:t>
             </a:r>
-            <a:endParaRPr lang="en-US" sz="1400" dirty="0"/>
+            <a:endParaRPr lang="en-US" sz="1300" dirty="0"/>
           </a:p>
         </p:txBody>
       </p:sp>
@@ -6508,8 +6725,8 @@
         </p:nvSpPr>
         <p:spPr>
           <a:xfrm>
-            <a:off x="6492240" y="2734056"/>
-            <a:ext cx="4846320" cy="320040"/>
+            <a:off x="6492240" y="2569464"/>
+            <a:ext cx="4846320" cy="310896"/>
           </a:xfrm>
           <a:prstGeom prst="rect">
             <a:avLst/>
@@ -6525,7 +6742,7 @@
               <a:buNone/>
             </a:pPr>
             <a:r>
-              <a:rPr lang="en-US" sz="1300" dirty="0">
+              <a:rPr lang="en-US" sz="1200" dirty="0">
                 <a:solidFill>
                   <a:srgbClr val="2563EB"/>
                 </a:solidFill>
@@ -6535,7 +6752,7 @@
               </a:rPr>
               <a:t>github.com/trac41799/claude-code-agentic-sdlc/blob/main/docs/benchmarks/BENCHMARK-SUMMARY.md</a:t>
             </a:r>
-            <a:endParaRPr lang="en-US" sz="1300" dirty="0"/>
+            <a:endParaRPr lang="en-US" sz="1200" dirty="0"/>
           </a:p>
         </p:txBody>
       </p:sp>
@@ -6547,12 +6764,12 @@
         </p:nvSpPr>
         <p:spPr>
           <a:xfrm>
-            <a:off x="685800" y="3172968"/>
-            <a:ext cx="10835640" cy="457200"/>
+            <a:off x="685800" y="2971800"/>
+            <a:ext cx="10835640" cy="420624"/>
           </a:xfrm>
           <a:prstGeom prst="roundRect">
             <a:avLst>
-              <a:gd name="adj" fmla="val 20000"/>
+              <a:gd name="adj" fmla="val 21739"/>
             </a:avLst>
           </a:prstGeom>
           <a:solidFill>
@@ -6574,8 +6791,8 @@
         </p:nvSpPr>
         <p:spPr>
           <a:xfrm>
-            <a:off x="914400" y="3246120"/>
-            <a:ext cx="5486400" cy="320040"/>
+            <a:off x="914400" y="3026664"/>
+            <a:ext cx="5486400" cy="310896"/>
           </a:xfrm>
           <a:prstGeom prst="rect">
             <a:avLst/>
@@ -6591,7 +6808,7 @@
               <a:buNone/>
             </a:pPr>
             <a:r>
-              <a:rPr lang="en-US" sz="1400" b="1" dirty="0">
+              <a:rPr lang="en-US" sz="1300" b="1" dirty="0">
                 <a:solidFill>
                   <a:srgbClr val="1E2761"/>
                 </a:solidFill>
@@ -6601,7 +6818,7 @@
               </a:rPr>
               <a:t>Live demo run guide (≤10 min)</a:t>
             </a:r>
-            <a:endParaRPr lang="en-US" sz="1400" dirty="0"/>
+            <a:endParaRPr lang="en-US" sz="1300" dirty="0"/>
           </a:p>
         </p:txBody>
       </p:sp>
@@ -6613,8 +6830,8 @@
         </p:nvSpPr>
         <p:spPr>
           <a:xfrm>
-            <a:off x="6492240" y="3246120"/>
-            <a:ext cx="4846320" cy="320040"/>
+            <a:off x="6492240" y="3026664"/>
+            <a:ext cx="4846320" cy="310896"/>
           </a:xfrm>
           <a:prstGeom prst="rect">
             <a:avLst/>
@@ -6630,7 +6847,7 @@
               <a:buNone/>
             </a:pPr>
             <a:r>
-              <a:rPr lang="en-US" sz="1300" dirty="0">
+              <a:rPr lang="en-US" sz="1200" dirty="0">
                 <a:solidFill>
                   <a:srgbClr val="2563EB"/>
                 </a:solidFill>
@@ -6640,7 +6857,7 @@
               </a:rPr>
               <a:t>github.com/trac41799/claude-code-agentic-sdlc/blob/main/docs/demo/live-demo-guide.md</a:t>
             </a:r>
-            <a:endParaRPr lang="en-US" sz="1300" dirty="0"/>
+            <a:endParaRPr lang="en-US" sz="1200" dirty="0"/>
           </a:p>
         </p:txBody>
       </p:sp>
@@ -6652,12 +6869,12 @@
         </p:nvSpPr>
         <p:spPr>
           <a:xfrm>
-            <a:off x="685800" y="3685032"/>
-            <a:ext cx="10835640" cy="457200"/>
+            <a:off x="685800" y="3429000"/>
+            <a:ext cx="10835640" cy="420624"/>
           </a:xfrm>
           <a:prstGeom prst="roundRect">
             <a:avLst>
-              <a:gd name="adj" fmla="val 20000"/>
+              <a:gd name="adj" fmla="val 21739"/>
             </a:avLst>
           </a:prstGeom>
           <a:solidFill>
@@ -6679,8 +6896,8 @@
         </p:nvSpPr>
         <p:spPr>
           <a:xfrm>
-            <a:off x="914400" y="3758184"/>
-            <a:ext cx="5486400" cy="320040"/>
+            <a:off x="914400" y="3483864"/>
+            <a:ext cx="5486400" cy="310896"/>
           </a:xfrm>
           <a:prstGeom prst="rect">
             <a:avLst/>
@@ -6696,7 +6913,7 @@
               <a:buNone/>
             </a:pPr>
             <a:r>
-              <a:rPr lang="en-US" sz="1400" b="1" dirty="0">
+              <a:rPr lang="en-US" sz="1300" b="1" dirty="0">
                 <a:solidFill>
                   <a:srgbClr val="1E2761"/>
                 </a:solidFill>
@@ -6706,7 +6923,7 @@
               </a:rPr>
               <a:t>Client setup — 5 prompts for non-technical founders</a:t>
             </a:r>
-            <a:endParaRPr lang="en-US" sz="1400" dirty="0"/>
+            <a:endParaRPr lang="en-US" sz="1300" dirty="0"/>
           </a:p>
         </p:txBody>
       </p:sp>
@@ -6718,8 +6935,8 @@
         </p:nvSpPr>
         <p:spPr>
           <a:xfrm>
-            <a:off x="6492240" y="3758184"/>
-            <a:ext cx="4846320" cy="320040"/>
+            <a:off x="6492240" y="3483864"/>
+            <a:ext cx="4846320" cy="310896"/>
           </a:xfrm>
           <a:prstGeom prst="rect">
             <a:avLst/>
@@ -6735,7 +6952,7 @@
               <a:buNone/>
             </a:pPr>
             <a:r>
-              <a:rPr lang="en-US" sz="1300" dirty="0">
+              <a:rPr lang="en-US" sz="1200" dirty="0">
                 <a:solidFill>
                   <a:srgbClr val="2563EB"/>
                 </a:solidFill>
@@ -6745,7 +6962,7 @@
               </a:rPr>
               <a:t>github.com/trac41799/claude-code-agentic-sdlc/blob/main/docs/guide/CLIENT-SETUP.md</a:t>
             </a:r>
-            <a:endParaRPr lang="en-US" sz="1300" dirty="0"/>
+            <a:endParaRPr lang="en-US" sz="1200" dirty="0"/>
           </a:p>
         </p:txBody>
       </p:sp>
@@ -6757,12 +6974,12 @@
         </p:nvSpPr>
         <p:spPr>
           <a:xfrm>
-            <a:off x="685800" y="4197096"/>
-            <a:ext cx="10835640" cy="457200"/>
+            <a:off x="685800" y="3886200"/>
+            <a:ext cx="10835640" cy="420624"/>
           </a:xfrm>
           <a:prstGeom prst="roundRect">
             <a:avLst>
-              <a:gd name="adj" fmla="val 20000"/>
+              <a:gd name="adj" fmla="val 21739"/>
             </a:avLst>
           </a:prstGeom>
           <a:solidFill>
@@ -6784,8 +7001,8 @@
         </p:nvSpPr>
         <p:spPr>
           <a:xfrm>
-            <a:off x="914400" y="4270248"/>
-            <a:ext cx="5486400" cy="320040"/>
+            <a:off x="914400" y="3941064"/>
+            <a:ext cx="5486400" cy="310896"/>
           </a:xfrm>
           <a:prstGeom prst="rect">
             <a:avLst/>
@@ -6801,7 +7018,7 @@
               <a:buNone/>
             </a:pPr>
             <a:r>
-              <a:rPr lang="en-US" sz="1400" b="1" dirty="0">
+              <a:rPr lang="en-US" sz="1300" b="1" dirty="0">
                 <a:solidFill>
                   <a:srgbClr val="1E2761"/>
                 </a:solidFill>
@@ -6811,7 +7028,7 @@
               </a:rPr>
               <a:t>Benchmark product — FE (froam)</a:t>
             </a:r>
-            <a:endParaRPr lang="en-US" sz="1400" dirty="0"/>
+            <a:endParaRPr lang="en-US" sz="1300" dirty="0"/>
           </a:p>
         </p:txBody>
       </p:sp>
@@ -6823,8 +7040,8 @@
         </p:nvSpPr>
         <p:spPr>
           <a:xfrm>
-            <a:off x="6492240" y="4270248"/>
-            <a:ext cx="4846320" cy="320040"/>
+            <a:off x="6492240" y="3941064"/>
+            <a:ext cx="4846320" cy="310896"/>
           </a:xfrm>
           <a:prstGeom prst="rect">
             <a:avLst/>
@@ -6840,7 +7057,7 @@
               <a:buNone/>
             </a:pPr>
             <a:r>
-              <a:rPr lang="en-US" sz="1300" dirty="0">
+              <a:rPr lang="en-US" sz="1200" dirty="0">
                 <a:solidFill>
                   <a:srgbClr val="2563EB"/>
                 </a:solidFill>
@@ -6850,7 +7067,7 @@
               </a:rPr>
               <a:t>github.com/trac41799/froam-journey-platform-fe</a:t>
             </a:r>
-            <a:endParaRPr lang="en-US" sz="1300" dirty="0"/>
+            <a:endParaRPr lang="en-US" sz="1200" dirty="0"/>
           </a:p>
         </p:txBody>
       </p:sp>
@@ -6862,12 +7079,12 @@
         </p:nvSpPr>
         <p:spPr>
           <a:xfrm>
-            <a:off x="685800" y="4709160"/>
-            <a:ext cx="10835640" cy="457200"/>
+            <a:off x="685800" y="4343400"/>
+            <a:ext cx="10835640" cy="420624"/>
           </a:xfrm>
           <a:prstGeom prst="roundRect">
             <a:avLst>
-              <a:gd name="adj" fmla="val 20000"/>
+              <a:gd name="adj" fmla="val 21739"/>
             </a:avLst>
           </a:prstGeom>
           <a:solidFill>
@@ -6889,8 +7106,8 @@
         </p:nvSpPr>
         <p:spPr>
           <a:xfrm>
-            <a:off x="914400" y="4782312"/>
-            <a:ext cx="5486400" cy="320040"/>
+            <a:off x="914400" y="4398264"/>
+            <a:ext cx="5486400" cy="310896"/>
           </a:xfrm>
           <a:prstGeom prst="rect">
             <a:avLst/>
@@ -6906,7 +7123,7 @@
               <a:buNone/>
             </a:pPr>
             <a:r>
-              <a:rPr lang="en-US" sz="1400" b="1" dirty="0">
+              <a:rPr lang="en-US" sz="1300" b="1" dirty="0">
                 <a:solidFill>
                   <a:srgbClr val="1E2761"/>
                 </a:solidFill>
@@ -6916,7 +7133,7 @@
               </a:rPr>
               <a:t>Benchmark product — BE (froam)</a:t>
             </a:r>
-            <a:endParaRPr lang="en-US" sz="1400" dirty="0"/>
+            <a:endParaRPr lang="en-US" sz="1300" dirty="0"/>
           </a:p>
         </p:txBody>
       </p:sp>
@@ -6928,8 +7145,8 @@
         </p:nvSpPr>
         <p:spPr>
           <a:xfrm>
-            <a:off x="6492240" y="4782312"/>
-            <a:ext cx="4846320" cy="320040"/>
+            <a:off x="6492240" y="4398264"/>
+            <a:ext cx="4846320" cy="310896"/>
           </a:xfrm>
           <a:prstGeom prst="rect">
             <a:avLst/>
@@ -6945,7 +7162,7 @@
               <a:buNone/>
             </a:pPr>
             <a:r>
-              <a:rPr lang="en-US" sz="1300" dirty="0">
+              <a:rPr lang="en-US" sz="1200" dirty="0">
                 <a:solidFill>
                   <a:srgbClr val="2563EB"/>
                 </a:solidFill>
@@ -6955,7 +7172,7 @@
               </a:rPr>
               <a:t>github.com/trac41799/travelbuddy-agentic-be</a:t>
             </a:r>
-            <a:endParaRPr lang="en-US" sz="1300" dirty="0"/>
+            <a:endParaRPr lang="en-US" sz="1200" dirty="0"/>
           </a:p>
         </p:txBody>
       </p:sp>
@@ -6967,12 +7184,12 @@
         </p:nvSpPr>
         <p:spPr>
           <a:xfrm>
-            <a:off x="685800" y="5221224"/>
-            <a:ext cx="10835640" cy="457200"/>
+            <a:off x="685800" y="4800600"/>
+            <a:ext cx="10835640" cy="420624"/>
           </a:xfrm>
           <a:prstGeom prst="roundRect">
             <a:avLst>
-              <a:gd name="adj" fmla="val 20000"/>
+              <a:gd name="adj" fmla="val 21739"/>
             </a:avLst>
           </a:prstGeom>
           <a:solidFill>
@@ -6994,8 +7211,8 @@
         </p:nvSpPr>
         <p:spPr>
           <a:xfrm>
-            <a:off x="914400" y="5294376"/>
-            <a:ext cx="5486400" cy="320040"/>
+            <a:off x="914400" y="4855464"/>
+            <a:ext cx="5486400" cy="310896"/>
           </a:xfrm>
           <a:prstGeom prst="rect">
             <a:avLst/>
@@ -7011,7 +7228,7 @@
               <a:buNone/>
             </a:pPr>
             <a:r>
-              <a:rPr lang="en-US" sz="1400" b="1" dirty="0">
+              <a:rPr lang="en-US" sz="1300" b="1" dirty="0">
                 <a:solidFill>
                   <a:srgbClr val="1E2761"/>
                 </a:solidFill>
@@ -7019,9 +7236,9 @@
                 <a:ea typeface="Calibri" pitchFamily="34" charset="-122"/>
                 <a:cs typeface="Calibri" pitchFamily="34" charset="-120"/>
               </a:rPr>
-              <a:t>Client cases</a:t>
-            </a:r>
-            <a:endParaRPr lang="en-US" sz="1400" dirty="0"/>
+              <a:t>v1 (Infinite Leverage) — public history, commit tree</a:t>
+            </a:r>
+            <a:endParaRPr lang="en-US" sz="1300" dirty="0"/>
           </a:p>
         </p:txBody>
       </p:sp>
@@ -7033,8 +7250,8 @@
         </p:nvSpPr>
         <p:spPr>
           <a:xfrm>
-            <a:off x="6492240" y="5294376"/>
-            <a:ext cx="4846320" cy="320040"/>
+            <a:off x="6492240" y="4855464"/>
+            <a:ext cx="4846320" cy="310896"/>
           </a:xfrm>
           <a:prstGeom prst="rect">
             <a:avLst/>
@@ -7050,7 +7267,7 @@
               <a:buNone/>
             </a:pPr>
             <a:r>
-              <a:rPr lang="en-US" sz="1300" dirty="0">
+              <a:rPr lang="en-US" sz="1200" dirty="0">
                 <a:solidFill>
                   <a:srgbClr val="2563EB"/>
                 </a:solidFill>
@@ -7058,9 +7275,9 @@
                 <a:ea typeface="Courier New" pitchFamily="34" charset="-122"/>
                 <a:cs typeface="Courier New" pitchFamily="34" charset="-120"/>
               </a:rPr>
-              <a:t>janet.care · occuspan.com</a:t>
-            </a:r>
-            <a:endParaRPr lang="en-US" sz="1300" dirty="0"/>
+              <a:t>github.com/talentedgeai/infinite-leverage</a:t>
+            </a:r>
+            <a:endParaRPr lang="en-US" sz="1200" dirty="0"/>
           </a:p>
         </p:txBody>
       </p:sp>
@@ -7072,12 +7289,12 @@
         </p:nvSpPr>
         <p:spPr>
           <a:xfrm>
-            <a:off x="685800" y="5733288"/>
-            <a:ext cx="10835640" cy="457200"/>
+            <a:off x="685800" y="5257800"/>
+            <a:ext cx="10835640" cy="420624"/>
           </a:xfrm>
           <a:prstGeom prst="roundRect">
             <a:avLst>
-              <a:gd name="adj" fmla="val 20000"/>
+              <a:gd name="adj" fmla="val 21739"/>
             </a:avLst>
           </a:prstGeom>
           <a:solidFill>
@@ -7099,8 +7316,8 @@
         </p:nvSpPr>
         <p:spPr>
           <a:xfrm>
-            <a:off x="914400" y="5806440"/>
-            <a:ext cx="5486400" cy="320040"/>
+            <a:off x="914400" y="5312664"/>
+            <a:ext cx="5486400" cy="310896"/>
           </a:xfrm>
           <a:prstGeom prst="rect">
             <a:avLst/>
@@ -7116,7 +7333,7 @@
               <a:buNone/>
             </a:pPr>
             <a:r>
-              <a:rPr lang="en-US" sz="1400" b="1" dirty="0">
+              <a:rPr lang="en-US" sz="1300" b="1" dirty="0">
                 <a:solidFill>
                   <a:srgbClr val="1E2761"/>
                 </a:solidFill>
@@ -7124,9 +7341,9 @@
                 <a:ea typeface="Calibri" pitchFamily="34" charset="-122"/>
                 <a:cs typeface="Calibri" pitchFamily="34" charset="-120"/>
               </a:rPr>
-              <a:t>Tool stack</a:t>
-            </a:r>
-            <a:endParaRPr lang="en-US" sz="1400" dirty="0"/>
+              <a:t>Client cases</a:t>
+            </a:r>
+            <a:endParaRPr lang="en-US" sz="1300" dirty="0"/>
           </a:p>
         </p:txBody>
       </p:sp>
@@ -7138,8 +7355,8 @@
         </p:nvSpPr>
         <p:spPr>
           <a:xfrm>
-            <a:off x="6492240" y="5806440"/>
-            <a:ext cx="4846320" cy="320040"/>
+            <a:off x="6492240" y="5312664"/>
+            <a:ext cx="4846320" cy="310896"/>
           </a:xfrm>
           <a:prstGeom prst="rect">
             <a:avLst/>
@@ -7155,7 +7372,7 @@
               <a:buNone/>
             </a:pPr>
             <a:r>
-              <a:rPr lang="en-US" sz="1300" dirty="0">
+              <a:rPr lang="en-US" sz="1200" dirty="0">
                 <a:solidFill>
                   <a:srgbClr val="2563EB"/>
                 </a:solidFill>
@@ -7163,22 +7380,127 @@
                 <a:ea typeface="Courier New" pitchFamily="34" charset="-122"/>
                 <a:cs typeface="Courier New" pitchFamily="34" charset="-120"/>
               </a:rPr>
+              <a:t>janet.care · occuspan.com</a:t>
+            </a:r>
+            <a:endParaRPr lang="en-US" sz="1200" dirty="0"/>
+          </a:p>
+        </p:txBody>
+      </p:sp>
+      <p:sp>
+        <p:nvSpPr>
+          <p:cNvPr id="29" name="Shape 27"/>
+          <p:cNvSpPr/>
+          <p:nvPr/>
+        </p:nvSpPr>
+        <p:spPr>
+          <a:xfrm>
+            <a:off x="685800" y="5715000"/>
+            <a:ext cx="10835640" cy="420624"/>
+          </a:xfrm>
+          <a:prstGeom prst="roundRect">
+            <a:avLst>
+              <a:gd name="adj" fmla="val 21739"/>
+            </a:avLst>
+          </a:prstGeom>
+          <a:solidFill>
+            <a:srgbClr val="F8FAFC"/>
+          </a:solidFill>
+          <a:ln w="15875">
+            <a:solidFill>
+              <a:srgbClr val="D1D5DB"/>
+            </a:solidFill>
+            <a:prstDash val="solid"/>
+          </a:ln>
+        </p:spPr>
+      </p:sp>
+      <p:sp>
+        <p:nvSpPr>
+          <p:cNvPr id="30" name="Text 28"/>
+          <p:cNvSpPr/>
+          <p:nvPr/>
+        </p:nvSpPr>
+        <p:spPr>
+          <a:xfrm>
+            <a:off x="914400" y="5769864"/>
+            <a:ext cx="5486400" cy="310896"/>
+          </a:xfrm>
+          <a:prstGeom prst="rect">
+            <a:avLst/>
+          </a:prstGeom>
+          <a:noFill/>
+          <a:ln/>
+        </p:spPr>
+        <p:txBody>
+          <a:bodyPr wrap="square" lIns="0" tIns="0" rIns="0" bIns="0" rtlCol="0" anchor="ctr"/>
+          <a:lstStyle/>
+          <a:p>
+            <a:pPr indent="0" marL="0">
+              <a:buNone/>
+            </a:pPr>
+            <a:r>
+              <a:rPr lang="en-US" sz="1300" b="1" dirty="0">
+                <a:solidFill>
+                  <a:srgbClr val="1E2761"/>
+                </a:solidFill>
+                <a:latin typeface="Calibri" pitchFamily="34" charset="0"/>
+                <a:ea typeface="Calibri" pitchFamily="34" charset="-122"/>
+                <a:cs typeface="Calibri" pitchFamily="34" charset="-120"/>
+              </a:rPr>
+              <a:t>Tool stack</a:t>
+            </a:r>
+            <a:endParaRPr lang="en-US" sz="1300" dirty="0"/>
+          </a:p>
+        </p:txBody>
+      </p:sp>
+      <p:sp>
+        <p:nvSpPr>
+          <p:cNvPr id="31" name="Text 29"/>
+          <p:cNvSpPr/>
+          <p:nvPr/>
+        </p:nvSpPr>
+        <p:spPr>
+          <a:xfrm>
+            <a:off x="6492240" y="5769864"/>
+            <a:ext cx="4846320" cy="310896"/>
+          </a:xfrm>
+          <a:prstGeom prst="rect">
+            <a:avLst/>
+          </a:prstGeom>
+          <a:noFill/>
+          <a:ln/>
+        </p:spPr>
+        <p:txBody>
+          <a:bodyPr wrap="square" lIns="0" tIns="0" rIns="0" bIns="0" rtlCol="0" anchor="ctr"/>
+          <a:lstStyle/>
+          <a:p>
+            <a:pPr algn="r" indent="0" marL="0">
+              <a:buNone/>
+            </a:pPr>
+            <a:r>
+              <a:rPr lang="en-US" sz="1200" dirty="0">
+                <a:solidFill>
+                  <a:srgbClr val="2563EB"/>
+                </a:solidFill>
+                <a:latin typeface="Courier New" pitchFamily="34" charset="0"/>
+                <a:ea typeface="Courier New" pitchFamily="34" charset="-122"/>
+                <a:cs typeface="Courier New" pitchFamily="34" charset="-120"/>
+              </a:rPr>
               <a:t>claude.com · github.com · vercel.com · supabase.com</a:t>
             </a:r>
-            <a:endParaRPr lang="en-US" sz="1300" dirty="0"/>
-          </a:p>
-        </p:txBody>
-      </p:sp>
-      <p:sp>
-        <p:nvSpPr>
-          <p:cNvPr id="29" name="Text 27"/>
-          <p:cNvSpPr/>
-          <p:nvPr/>
-        </p:nvSpPr>
-        <p:spPr>
-          <a:xfrm>
-            <a:off x="685800" y="6126480"/>
-            <a:ext cx="10835640" cy="411480"/>
+            <a:endParaRPr lang="en-US" sz="1200" dirty="0"/>
+          </a:p>
+        </p:txBody>
+      </p:sp>
+      <p:sp>
+        <p:nvSpPr>
+          <p:cNvPr id="32" name="Text 30"/>
+          <p:cNvSpPr/>
+          <p:nvPr/>
+        </p:nvSpPr>
+        <p:spPr>
+          <a:xfrm>
+            <a:off x="685800" y="6172200"/>
+            <a:ext cx="10835640" cy="365760"/>
           </a:xfrm>
           <a:prstGeom prst="rect">
             <a:avLst/>
@@ -7219,6 +7541,2512 @@
 <file path=ppt/slides/slide15.xml><?xml version="1.0" encoding="utf-8"?>
 <p:sld xmlns:a="http://schemas.openxmlformats.org/drawingml/2006/main" xmlns:r="http://schemas.openxmlformats.org/officeDocument/2006/relationships" xmlns:p="http://schemas.openxmlformats.org/presentationml/2006/main">
   <p:cSld name="Slide 15">
+    <p:bg>
+      <p:bgPr>
+        <a:solidFill>
+          <a:srgbClr val="FFFFFF"/>
+        </a:solidFill>
+      </p:bgPr>
+    </p:bg>
+    <p:spTree>
+      <p:nvGrpSpPr>
+        <p:cNvPr id="1" name=""/>
+        <p:cNvGrpSpPr/>
+        <p:nvPr/>
+      </p:nvGrpSpPr>
+      <p:grpSpPr>
+        <a:xfrm>
+          <a:off x="0" y="0"/>
+          <a:ext cx="0" cy="0"/>
+          <a:chOff x="0" y="0"/>
+          <a:chExt cx="0" cy="0"/>
+        </a:xfrm>
+      </p:grpSpPr>
+      <p:sp>
+        <p:nvSpPr>
+          <p:cNvPr id="2" name="Text 0"/>
+          <p:cNvSpPr/>
+          <p:nvPr/>
+        </p:nvSpPr>
+        <p:spPr>
+          <a:xfrm>
+            <a:off x="502920" y="256032"/>
+            <a:ext cx="10972800" cy="292608"/>
+          </a:xfrm>
+          <a:prstGeom prst="rect">
+            <a:avLst/>
+          </a:prstGeom>
+          <a:noFill/>
+          <a:ln/>
+        </p:spPr>
+        <p:txBody>
+          <a:bodyPr wrap="square" rtlCol="0" anchor="ctr"/>
+          <a:lstStyle/>
+          <a:p>
+            <a:pPr indent="0" marL="0">
+              <a:buNone/>
+            </a:pPr>
+            <a:r>
+              <a:rPr lang="en-US" sz="1300" b="1" spc="200" kern="0" dirty="0">
+                <a:solidFill>
+                  <a:srgbClr val="B98A00"/>
+                </a:solidFill>
+                <a:latin typeface="Calibri" pitchFamily="34" charset="0"/>
+                <a:ea typeface="Calibri" pitchFamily="34" charset="-122"/>
+                <a:cs typeface="Calibri" pitchFamily="34" charset="-120"/>
+              </a:rPr>
+              <a:t>HISTORY</a:t>
+            </a:r>
+            <a:endParaRPr lang="en-US" sz="1300" dirty="0"/>
+          </a:p>
+        </p:txBody>
+      </p:sp>
+      <p:sp>
+        <p:nvSpPr>
+          <p:cNvPr id="3" name="Text 1"/>
+          <p:cNvSpPr/>
+          <p:nvPr/>
+        </p:nvSpPr>
+        <p:spPr>
+          <a:xfrm>
+            <a:off x="502920" y="548640"/>
+            <a:ext cx="11155680" cy="822960"/>
+          </a:xfrm>
+          <a:prstGeom prst="rect">
+            <a:avLst/>
+          </a:prstGeom>
+          <a:noFill/>
+          <a:ln/>
+        </p:spPr>
+        <p:txBody>
+          <a:bodyPr wrap="square" rtlCol="0" anchor="ctr"/>
+          <a:lstStyle/>
+          <a:p>
+            <a:pPr indent="0" marL="0">
+              <a:buNone/>
+            </a:pPr>
+            <a:r>
+              <a:rPr lang="en-US" sz="4400" b="1" dirty="0">
+                <a:solidFill>
+                  <a:srgbClr val="1E2761"/>
+                </a:solidFill>
+                <a:latin typeface="Cambria" pitchFamily="34" charset="0"/>
+                <a:ea typeface="Cambria" pitchFamily="34" charset="-122"/>
+                <a:cs typeface="Cambria" pitchFamily="34" charset="-120"/>
+              </a:rPr>
+              <a:t>v1 — the fully automated agent-team</a:t>
+            </a:r>
+            <a:endParaRPr lang="en-US" sz="4400" dirty="0"/>
+          </a:p>
+        </p:txBody>
+      </p:sp>
+      <p:sp>
+        <p:nvSpPr>
+          <p:cNvPr id="4" name="Text 2"/>
+          <p:cNvSpPr/>
+          <p:nvPr/>
+        </p:nvSpPr>
+        <p:spPr>
+          <a:xfrm>
+            <a:off x="502920" y="1371600"/>
+            <a:ext cx="11155680" cy="457200"/>
+          </a:xfrm>
+          <a:prstGeom prst="rect">
+            <a:avLst/>
+          </a:prstGeom>
+          <a:noFill/>
+          <a:ln/>
+        </p:spPr>
+        <p:txBody>
+          <a:bodyPr wrap="square" rtlCol="0" anchor="ctr"/>
+          <a:lstStyle/>
+          <a:p>
+            <a:pPr indent="0" marL="0">
+              <a:buNone/>
+            </a:pPr>
+            <a:r>
+              <a:rPr lang="en-US" sz="2000" dirty="0">
+                <a:solidFill>
+                  <a:srgbClr val="6B7280"/>
+                </a:solidFill>
+                <a:latin typeface="Calibri" pitchFamily="34" charset="0"/>
+                <a:ea typeface="Calibri" pitchFamily="34" charset="-122"/>
+                <a:cs typeface="Calibri" pitchFamily="34" charset="-120"/>
+              </a:rPr>
+              <a:t>“Infinite Leverage” (2026) · reconstructed from the public commit tree.</a:t>
+            </a:r>
+            <a:endParaRPr lang="en-US" sz="2000" dirty="0"/>
+          </a:p>
+        </p:txBody>
+      </p:sp>
+      <p:sp>
+        <p:nvSpPr>
+          <p:cNvPr id="5" name="Shape 3"/>
+          <p:cNvSpPr/>
+          <p:nvPr/>
+        </p:nvSpPr>
+        <p:spPr>
+          <a:xfrm>
+            <a:off x="685800" y="2103120"/>
+            <a:ext cx="5349240" cy="3429000"/>
+          </a:xfrm>
+          <a:prstGeom prst="roundRect">
+            <a:avLst>
+              <a:gd name="adj" fmla="val 2667"/>
+            </a:avLst>
+          </a:prstGeom>
+          <a:solidFill>
+            <a:srgbClr val="FBF3E2"/>
+          </a:solidFill>
+          <a:ln w="15875">
+            <a:solidFill>
+              <a:srgbClr val="B98A00"/>
+            </a:solidFill>
+            <a:prstDash val="solid"/>
+          </a:ln>
+        </p:spPr>
+      </p:sp>
+      <p:sp>
+        <p:nvSpPr>
+          <p:cNvPr id="6" name="Text 4"/>
+          <p:cNvSpPr/>
+          <p:nvPr/>
+        </p:nvSpPr>
+        <p:spPr>
+          <a:xfrm>
+            <a:off x="960120" y="2286000"/>
+            <a:ext cx="4800600" cy="365760"/>
+          </a:xfrm>
+          <a:prstGeom prst="rect">
+            <a:avLst/>
+          </a:prstGeom>
+          <a:noFill/>
+          <a:ln/>
+        </p:spPr>
+        <p:txBody>
+          <a:bodyPr wrap="square" rtlCol="0" anchor="ctr"/>
+          <a:lstStyle/>
+          <a:p>
+            <a:pPr indent="0" marL="0">
+              <a:buNone/>
+            </a:pPr>
+            <a:r>
+              <a:rPr lang="en-US" sz="1700" b="1" dirty="0">
+                <a:solidFill>
+                  <a:srgbClr val="7A5C00"/>
+                </a:solidFill>
+                <a:latin typeface="Calibri" pitchFamily="34" charset="0"/>
+                <a:ea typeface="Calibri" pitchFamily="34" charset="-122"/>
+                <a:cs typeface="Calibri" pitchFamily="34" charset="-120"/>
+              </a:rPr>
+              <a:t>THE ORIGINAL SCOPE</a:t>
+            </a:r>
+            <a:endParaRPr lang="en-US" sz="1700" dirty="0"/>
+          </a:p>
+        </p:txBody>
+      </p:sp>
+      <p:sp>
+        <p:nvSpPr>
+          <p:cNvPr id="7" name="Text 5"/>
+          <p:cNvSpPr/>
+          <p:nvPr/>
+        </p:nvSpPr>
+        <p:spPr>
+          <a:xfrm>
+            <a:off x="960120" y="2743200"/>
+            <a:ext cx="4846320" cy="274320"/>
+          </a:xfrm>
+          <a:prstGeom prst="rect">
+            <a:avLst/>
+          </a:prstGeom>
+          <a:noFill/>
+          <a:ln/>
+        </p:spPr>
+        <p:txBody>
+          <a:bodyPr wrap="square" lIns="0" tIns="0" rIns="0" bIns="0" rtlCol="0" anchor="ctr"/>
+          <a:lstStyle/>
+          <a:p>
+            <a:pPr indent="0" marL="0">
+              <a:buNone/>
+            </a:pPr>
+            <a:r>
+              <a:rPr lang="en-US" sz="1200" dirty="0">
+                <a:solidFill>
+                  <a:srgbClr val="4A3A00"/>
+                </a:solidFill>
+                <a:latin typeface="Courier New" pitchFamily="34" charset="0"/>
+                <a:ea typeface="Courier New" pitchFamily="34" charset="-122"/>
+                <a:cs typeface="Courier New" pitchFamily="34" charset="-120"/>
+              </a:rPr>
+              <a:t>8 agents — dev team + marketing team</a:t>
+            </a:r>
+            <a:endParaRPr lang="en-US" sz="1200" dirty="0"/>
+          </a:p>
+        </p:txBody>
+      </p:sp>
+      <p:sp>
+        <p:nvSpPr>
+          <p:cNvPr id="8" name="Text 6"/>
+          <p:cNvSpPr/>
+          <p:nvPr/>
+        </p:nvSpPr>
+        <p:spPr>
+          <a:xfrm>
+            <a:off x="960120" y="3035808"/>
+            <a:ext cx="4846320" cy="274320"/>
+          </a:xfrm>
+          <a:prstGeom prst="rect">
+            <a:avLst/>
+          </a:prstGeom>
+          <a:noFill/>
+          <a:ln/>
+        </p:spPr>
+        <p:txBody>
+          <a:bodyPr wrap="square" lIns="0" tIns="0" rIns="0" bIns="0" rtlCol="0" anchor="ctr"/>
+          <a:lstStyle/>
+          <a:p>
+            <a:pPr indent="0" marL="0">
+              <a:buNone/>
+            </a:pPr>
+            <a:r>
+              <a:rPr lang="en-US" sz="1200" dirty="0">
+                <a:solidFill>
+                  <a:srgbClr val="4A3A00"/>
+                </a:solidFill>
+                <a:latin typeface="Courier New" pitchFamily="34" charset="0"/>
+                <a:ea typeface="Courier New" pitchFamily="34" charset="-122"/>
+                <a:cs typeface="Courier New" pitchFamily="34" charset="-120"/>
+              </a:rPr>
+              <a:t>  product-manager · developer · devops · qa</a:t>
+            </a:r>
+            <a:endParaRPr lang="en-US" sz="1200" dirty="0"/>
+          </a:p>
+        </p:txBody>
+      </p:sp>
+      <p:sp>
+        <p:nvSpPr>
+          <p:cNvPr id="9" name="Text 7"/>
+          <p:cNvSpPr/>
+          <p:nvPr/>
+        </p:nvSpPr>
+        <p:spPr>
+          <a:xfrm>
+            <a:off x="960120" y="3328416"/>
+            <a:ext cx="4846320" cy="274320"/>
+          </a:xfrm>
+          <a:prstGeom prst="rect">
+            <a:avLst/>
+          </a:prstGeom>
+          <a:noFill/>
+          <a:ln/>
+        </p:spPr>
+        <p:txBody>
+          <a:bodyPr wrap="square" lIns="0" tIns="0" rIns="0" bIns="0" rtlCol="0" anchor="ctr"/>
+          <a:lstStyle/>
+          <a:p>
+            <a:pPr indent="0" marL="0">
+              <a:buNone/>
+            </a:pPr>
+            <a:r>
+              <a:rPr lang="en-US" sz="1200" dirty="0">
+                <a:solidFill>
+                  <a:srgbClr val="4A3A00"/>
+                </a:solidFill>
+                <a:latin typeface="Courier New" pitchFamily="34" charset="0"/>
+                <a:ea typeface="Courier New" pitchFamily="34" charset="-122"/>
+                <a:cs typeface="Courier New" pitchFamily="34" charset="-120"/>
+              </a:rPr>
+              <a:t>  web-publisher · writer · designer · email-marketer</a:t>
+            </a:r>
+            <a:endParaRPr lang="en-US" sz="1200" dirty="0"/>
+          </a:p>
+        </p:txBody>
+      </p:sp>
+      <p:sp>
+        <p:nvSpPr>
+          <p:cNvPr id="10" name="Text 8"/>
+          <p:cNvSpPr/>
+          <p:nvPr/>
+        </p:nvSpPr>
+        <p:spPr>
+          <a:xfrm>
+            <a:off x="960120" y="3621024"/>
+            <a:ext cx="4846320" cy="274320"/>
+          </a:xfrm>
+          <a:prstGeom prst="rect">
+            <a:avLst/>
+          </a:prstGeom>
+          <a:noFill/>
+          <a:ln/>
+        </p:spPr>
+        <p:txBody>
+          <a:bodyPr wrap="square" lIns="0" tIns="0" rIns="0" bIns="0" rtlCol="0" anchor="ctr"/>
+          <a:lstStyle/>
+          <a:p>
+            <a:pPr indent="0" marL="0">
+              <a:buNone/>
+            </a:pPr>
+            <a:r>
+              <a:rPr lang="en-US" sz="1200" dirty="0">
+                <a:solidFill>
+                  <a:srgbClr val="4A3A00"/>
+                </a:solidFill>
+                <a:latin typeface="Courier New" pitchFamily="34" charset="0"/>
+                <a:ea typeface="Courier New" pitchFamily="34" charset="-122"/>
+                <a:cs typeface="Courier New" pitchFamily="34" charset="-120"/>
+              </a:rPr>
+              <a:t>  (+ marketing-strategist via create-agent)</a:t>
+            </a:r>
+            <a:endParaRPr lang="en-US" sz="1200" dirty="0"/>
+          </a:p>
+        </p:txBody>
+      </p:sp>
+      <p:sp>
+        <p:nvSpPr>
+          <p:cNvPr id="11" name="Text 9"/>
+          <p:cNvSpPr/>
+          <p:nvPr/>
+        </p:nvSpPr>
+        <p:spPr>
+          <a:xfrm>
+            <a:off x="960120" y="3913632"/>
+            <a:ext cx="4846320" cy="274320"/>
+          </a:xfrm>
+          <a:prstGeom prst="rect">
+            <a:avLst/>
+          </a:prstGeom>
+          <a:noFill/>
+          <a:ln/>
+        </p:spPr>
+        <p:txBody>
+          <a:bodyPr wrap="square" lIns="0" tIns="0" rIns="0" bIns="0" rtlCol="0" anchor="ctr"/>
+          <a:lstStyle/>
+          <a:p>
+            <a:pPr indent="0" marL="0">
+              <a:buNone/>
+            </a:pPr>
+            <a:r>
+              <a:rPr lang="en-US" sz="1200" dirty="0">
+                <a:solidFill>
+                  <a:srgbClr val="4A3A00"/>
+                </a:solidFill>
+                <a:latin typeface="Courier New" pitchFamily="34" charset="0"/>
+                <a:ea typeface="Courier New" pitchFamily="34" charset="-122"/>
+                <a:cs typeface="Courier New" pitchFamily="34" charset="-120"/>
+              </a:rPr>
+              <a:t>Global install — ~/.claude/ agents, hooks,</a:t>
+            </a:r>
+            <a:endParaRPr lang="en-US" sz="1200" dirty="0"/>
+          </a:p>
+        </p:txBody>
+      </p:sp>
+      <p:sp>
+        <p:nvSpPr>
+          <p:cNvPr id="12" name="Text 10"/>
+          <p:cNvSpPr/>
+          <p:nvPr/>
+        </p:nvSpPr>
+        <p:spPr>
+          <a:xfrm>
+            <a:off x="960120" y="4206240"/>
+            <a:ext cx="4846320" cy="274320"/>
+          </a:xfrm>
+          <a:prstGeom prst="rect">
+            <a:avLst/>
+          </a:prstGeom>
+          <a:noFill/>
+          <a:ln/>
+        </p:spPr>
+        <p:txBody>
+          <a:bodyPr wrap="square" lIns="0" tIns="0" rIns="0" bIns="0" rtlCol="0" anchor="ctr"/>
+          <a:lstStyle/>
+          <a:p>
+            <a:pPr indent="0" marL="0">
+              <a:buNone/>
+            </a:pPr>
+            <a:r>
+              <a:rPr lang="en-US" sz="1200" dirty="0">
+                <a:solidFill>
+                  <a:srgbClr val="4A3A00"/>
+                </a:solidFill>
+                <a:latin typeface="Courier New" pitchFamily="34" charset="0"/>
+                <a:ea typeface="Courier New" pitchFamily="34" charset="-122"/>
+                <a:cs typeface="Courier New" pitchFamily="34" charset="-120"/>
+              </a:rPr>
+              <a:t>  skills, scheduled-tasks via init/onboard/patch</a:t>
+            </a:r>
+            <a:endParaRPr lang="en-US" sz="1200" dirty="0"/>
+          </a:p>
+        </p:txBody>
+      </p:sp>
+      <p:sp>
+        <p:nvSpPr>
+          <p:cNvPr id="13" name="Text 11"/>
+          <p:cNvSpPr/>
+          <p:nvPr/>
+        </p:nvSpPr>
+        <p:spPr>
+          <a:xfrm>
+            <a:off x="960120" y="4498848"/>
+            <a:ext cx="4846320" cy="274320"/>
+          </a:xfrm>
+          <a:prstGeom prst="rect">
+            <a:avLst/>
+          </a:prstGeom>
+          <a:noFill/>
+          <a:ln/>
+        </p:spPr>
+        <p:txBody>
+          <a:bodyPr wrap="square" lIns="0" tIns="0" rIns="0" bIns="0" rtlCol="0" anchor="ctr"/>
+          <a:lstStyle/>
+          <a:p>
+            <a:pPr indent="0" marL="0">
+              <a:buNone/>
+            </a:pPr>
+            <a:r>
+              <a:rPr lang="en-US" sz="1200" dirty="0">
+                <a:solidFill>
+                  <a:srgbClr val="4A3A00"/>
+                </a:solidFill>
+                <a:latin typeface="Courier New" pitchFamily="34" charset="0"/>
+                <a:ea typeface="Courier New" pitchFamily="34" charset="-122"/>
+                <a:cs typeface="Courier New" pitchFamily="34" charset="-120"/>
+              </a:rPr>
+              <a:t>62 workflow skills, zipped per agent</a:t>
+            </a:r>
+            <a:endParaRPr lang="en-US" sz="1200" dirty="0"/>
+          </a:p>
+        </p:txBody>
+      </p:sp>
+      <p:sp>
+        <p:nvSpPr>
+          <p:cNvPr id="14" name="Text 12"/>
+          <p:cNvSpPr/>
+          <p:nvPr/>
+        </p:nvSpPr>
+        <p:spPr>
+          <a:xfrm>
+            <a:off x="960120" y="4791456"/>
+            <a:ext cx="4846320" cy="274320"/>
+          </a:xfrm>
+          <a:prstGeom prst="rect">
+            <a:avLst/>
+          </a:prstGeom>
+          <a:noFill/>
+          <a:ln/>
+        </p:spPr>
+        <p:txBody>
+          <a:bodyPr wrap="square" lIns="0" tIns="0" rIns="0" bIns="0" rtlCol="0" anchor="ctr"/>
+          <a:lstStyle/>
+          <a:p>
+            <a:pPr indent="0" marL="0">
+              <a:buNone/>
+            </a:pPr>
+            <a:r>
+              <a:rPr lang="en-US" sz="1200" dirty="0">
+                <a:solidFill>
+                  <a:srgbClr val="4A3A00"/>
+                </a:solidFill>
+                <a:latin typeface="Courier New" pitchFamily="34" charset="0"/>
+                <a:ea typeface="Courier New" pitchFamily="34" charset="-122"/>
+                <a:cs typeface="Courier New" pitchFamily="34" charset="-120"/>
+              </a:rPr>
+              <a:t>Settings: Bash(*) grant · acceptEdits default</a:t>
+            </a:r>
+            <a:endParaRPr lang="en-US" sz="1200" dirty="0"/>
+          </a:p>
+        </p:txBody>
+      </p:sp>
+      <p:sp>
+        <p:nvSpPr>
+          <p:cNvPr id="15" name="Shape 13"/>
+          <p:cNvSpPr/>
+          <p:nvPr/>
+        </p:nvSpPr>
+        <p:spPr>
+          <a:xfrm>
+            <a:off x="6263640" y="2103120"/>
+            <a:ext cx="5257800" cy="3429000"/>
+          </a:xfrm>
+          <a:prstGeom prst="roundRect">
+            <a:avLst>
+              <a:gd name="adj" fmla="val 2667"/>
+            </a:avLst>
+          </a:prstGeom>
+          <a:solidFill>
+            <a:srgbClr val="EAF0FB"/>
+          </a:solidFill>
+          <a:ln w="15875">
+            <a:solidFill>
+              <a:srgbClr val="5A6B9E"/>
+            </a:solidFill>
+            <a:prstDash val="solid"/>
+          </a:ln>
+        </p:spPr>
+      </p:sp>
+      <p:sp>
+        <p:nvSpPr>
+          <p:cNvPr id="16" name="Text 14"/>
+          <p:cNvSpPr/>
+          <p:nvPr/>
+        </p:nvSpPr>
+        <p:spPr>
+          <a:xfrm>
+            <a:off x="6537960" y="2286000"/>
+            <a:ext cx="4709160" cy="365760"/>
+          </a:xfrm>
+          <a:prstGeom prst="rect">
+            <a:avLst/>
+          </a:prstGeom>
+          <a:noFill/>
+          <a:ln/>
+        </p:spPr>
+        <p:txBody>
+          <a:bodyPr wrap="square" rtlCol="0" anchor="ctr"/>
+          <a:lstStyle/>
+          <a:p>
+            <a:pPr indent="0" marL="0">
+              <a:buNone/>
+            </a:pPr>
+            <a:r>
+              <a:rPr lang="en-US" sz="1700" b="1" dirty="0">
+                <a:solidFill>
+                  <a:srgbClr val="1E2761"/>
+                </a:solidFill>
+                <a:latin typeface="Calibri" pitchFamily="34" charset="0"/>
+                <a:ea typeface="Calibri" pitchFamily="34" charset="-122"/>
+                <a:cs typeface="Calibri" pitchFamily="34" charset="-120"/>
+              </a:rPr>
+              <a:t>ROUTINES — NO HUMAN IN THE LOOP</a:t>
+            </a:r>
+            <a:endParaRPr lang="en-US" sz="1700" dirty="0"/>
+          </a:p>
+        </p:txBody>
+      </p:sp>
+      <p:sp>
+        <p:nvSpPr>
+          <p:cNvPr id="17" name="Text 15"/>
+          <p:cNvSpPr/>
+          <p:nvPr/>
+        </p:nvSpPr>
+        <p:spPr>
+          <a:xfrm>
+            <a:off x="6537960" y="2743200"/>
+            <a:ext cx="4800600" cy="246888"/>
+          </a:xfrm>
+          <a:prstGeom prst="rect">
+            <a:avLst/>
+          </a:prstGeom>
+          <a:noFill/>
+          <a:ln/>
+        </p:spPr>
+        <p:txBody>
+          <a:bodyPr wrap="square" lIns="0" tIns="0" rIns="0" bIns="0" rtlCol="0" anchor="ctr"/>
+          <a:lstStyle/>
+          <a:p>
+            <a:pPr indent="0" marL="0">
+              <a:buNone/>
+            </a:pPr>
+            <a:r>
+              <a:rPr lang="en-US" sz="1100" dirty="0">
+                <a:solidFill>
+                  <a:srgbClr val="1F2937"/>
+                </a:solidFill>
+                <a:latin typeface="Courier New" pitchFamily="34" charset="0"/>
+                <a:ea typeface="Courier New" pitchFamily="34" charset="-122"/>
+                <a:cs typeface="Courier New" pitchFamily="34" charset="-120"/>
+              </a:rPr>
+              <a:t>pm-daily-plan         weekdays 07:03  auto-approve</a:t>
+            </a:r>
+            <a:endParaRPr lang="en-US" sz="1100" dirty="0"/>
+          </a:p>
+        </p:txBody>
+      </p:sp>
+      <p:sp>
+        <p:nvSpPr>
+          <p:cNvPr id="18" name="Text 16"/>
+          <p:cNvSpPr/>
+          <p:nvPr/>
+        </p:nvSpPr>
+        <p:spPr>
+          <a:xfrm>
+            <a:off x="6537960" y="3008376"/>
+            <a:ext cx="4800600" cy="246888"/>
+          </a:xfrm>
+          <a:prstGeom prst="rect">
+            <a:avLst/>
+          </a:prstGeom>
+          <a:noFill/>
+          <a:ln/>
+        </p:spPr>
+        <p:txBody>
+          <a:bodyPr wrap="square" lIns="0" tIns="0" rIns="0" bIns="0" rtlCol="0" anchor="ctr"/>
+          <a:lstStyle/>
+          <a:p>
+            <a:pPr indent="0" marL="0">
+              <a:buNone/>
+            </a:pPr>
+            <a:r>
+              <a:rPr lang="en-US" sz="1100" dirty="0">
+                <a:solidFill>
+                  <a:srgbClr val="1F2937"/>
+                </a:solidFill>
+                <a:latin typeface="Courier New" pitchFamily="34" charset="0"/>
+                <a:ea typeface="Courier New" pitchFamily="34" charset="-122"/>
+                <a:cs typeface="Courier New" pitchFamily="34" charset="-120"/>
+              </a:rPr>
+              <a:t>pm-standup-compile    weekdays 18:07  + PR</a:t>
+            </a:r>
+            <a:endParaRPr lang="en-US" sz="1100" dirty="0"/>
+          </a:p>
+        </p:txBody>
+      </p:sp>
+      <p:sp>
+        <p:nvSpPr>
+          <p:cNvPr id="19" name="Text 17"/>
+          <p:cNvSpPr/>
+          <p:nvPr/>
+        </p:nvSpPr>
+        <p:spPr>
+          <a:xfrm>
+            <a:off x="6537960" y="3273552"/>
+            <a:ext cx="4800600" cy="246888"/>
+          </a:xfrm>
+          <a:prstGeom prst="rect">
+            <a:avLst/>
+          </a:prstGeom>
+          <a:noFill/>
+          <a:ln/>
+        </p:spPr>
+        <p:txBody>
+          <a:bodyPr wrap="square" lIns="0" tIns="0" rIns="0" bIns="0" rtlCol="0" anchor="ctr"/>
+          <a:lstStyle/>
+          <a:p>
+            <a:pPr indent="0" marL="0">
+              <a:buNone/>
+            </a:pPr>
+            <a:r>
+              <a:rPr lang="en-US" sz="1100" dirty="0">
+                <a:solidFill>
+                  <a:srgbClr val="1F2937"/>
+                </a:solidFill>
+                <a:latin typeface="Courier New" pitchFamily="34" charset="0"/>
+                <a:ea typeface="Courier New" pitchFamily="34" charset="-122"/>
+                <a:cs typeface="Courier New" pitchFamily="34" charset="-120"/>
+              </a:rPr>
+              <a:t>pm-eod-summary        weekdays 18:37</a:t>
+            </a:r>
+            <a:endParaRPr lang="en-US" sz="1100" dirty="0"/>
+          </a:p>
+        </p:txBody>
+      </p:sp>
+      <p:sp>
+        <p:nvSpPr>
+          <p:cNvPr id="20" name="Text 18"/>
+          <p:cNvSpPr/>
+          <p:nvPr/>
+        </p:nvSpPr>
+        <p:spPr>
+          <a:xfrm>
+            <a:off x="6537960" y="3538728"/>
+            <a:ext cx="4800600" cy="246888"/>
+          </a:xfrm>
+          <a:prstGeom prst="rect">
+            <a:avLst/>
+          </a:prstGeom>
+          <a:noFill/>
+          <a:ln/>
+        </p:spPr>
+        <p:txBody>
+          <a:bodyPr wrap="square" lIns="0" tIns="0" rIns="0" bIns="0" rtlCol="0" anchor="ctr"/>
+          <a:lstStyle/>
+          <a:p>
+            <a:pPr indent="0" marL="0">
+              <a:buNone/>
+            </a:pPr>
+            <a:r>
+              <a:rPr lang="en-US" sz="1100" dirty="0">
+                <a:solidFill>
+                  <a:srgbClr val="1F2937"/>
+                </a:solidFill>
+                <a:latin typeface="Courier New" pitchFamily="34" charset="0"/>
+                <a:ea typeface="Courier New" pitchFamily="34" charset="-122"/>
+                <a:cs typeface="Courier New" pitchFamily="34" charset="-120"/>
+              </a:rPr>
+              <a:t>pm-weekly-rag         Fridays 17:07   + PR</a:t>
+            </a:r>
+            <a:endParaRPr lang="en-US" sz="1100" dirty="0"/>
+          </a:p>
+        </p:txBody>
+      </p:sp>
+      <p:sp>
+        <p:nvSpPr>
+          <p:cNvPr id="21" name="Text 19"/>
+          <p:cNvSpPr/>
+          <p:nvPr/>
+        </p:nvSpPr>
+        <p:spPr>
+          <a:xfrm>
+            <a:off x="6537960" y="3803904"/>
+            <a:ext cx="4800600" cy="246888"/>
+          </a:xfrm>
+          <a:prstGeom prst="rect">
+            <a:avLst/>
+          </a:prstGeom>
+          <a:noFill/>
+          <a:ln/>
+        </p:spPr>
+        <p:txBody>
+          <a:bodyPr wrap="square" lIns="0" tIns="0" rIns="0" bIns="0" rtlCol="0" anchor="ctr"/>
+          <a:lstStyle/>
+          <a:p>
+            <a:pPr indent="0" marL="0">
+              <a:buNone/>
+            </a:pPr>
+            <a:r>
+              <a:rPr lang="en-US" sz="1100" dirty="0">
+                <a:solidFill>
+                  <a:srgbClr val="1F2937"/>
+                </a:solidFill>
+                <a:latin typeface="Courier New" pitchFamily="34" charset="0"/>
+                <a:ea typeface="Courier New" pitchFamily="34" charset="-122"/>
+                <a:cs typeface="Courier New" pitchFamily="34" charset="-120"/>
+              </a:rPr>
+              <a:t>writer-weekly         Mondays 09:03   brief → blog.md</a:t>
+            </a:r>
+            <a:endParaRPr lang="en-US" sz="1100" dirty="0"/>
+          </a:p>
+        </p:txBody>
+      </p:sp>
+      <p:sp>
+        <p:nvSpPr>
+          <p:cNvPr id="22" name="Text 20"/>
+          <p:cNvSpPr/>
+          <p:nvPr/>
+        </p:nvSpPr>
+        <p:spPr>
+          <a:xfrm>
+            <a:off x="6537960" y="4069080"/>
+            <a:ext cx="4800600" cy="246888"/>
+          </a:xfrm>
+          <a:prstGeom prst="rect">
+            <a:avLst/>
+          </a:prstGeom>
+          <a:noFill/>
+          <a:ln/>
+        </p:spPr>
+        <p:txBody>
+          <a:bodyPr wrap="square" lIns="0" tIns="0" rIns="0" bIns="0" rtlCol="0" anchor="ctr"/>
+          <a:lstStyle/>
+          <a:p>
+            <a:pPr indent="0" marL="0">
+              <a:buNone/>
+            </a:pPr>
+            <a:r>
+              <a:rPr lang="en-US" sz="1100" dirty="0">
+                <a:solidFill>
+                  <a:srgbClr val="1F2937"/>
+                </a:solidFill>
+                <a:latin typeface="Courier New" pitchFamily="34" charset="0"/>
+                <a:ea typeface="Courier New" pitchFamily="34" charset="-122"/>
+                <a:cs typeface="Courier New" pitchFamily="34" charset="-120"/>
+              </a:rPr>
+              <a:t>designer-weekly       Tuesdays 09:03  blog → hero.webp</a:t>
+            </a:r>
+            <a:endParaRPr lang="en-US" sz="1100" dirty="0"/>
+          </a:p>
+        </p:txBody>
+      </p:sp>
+      <p:sp>
+        <p:nvSpPr>
+          <p:cNvPr id="23" name="Text 21"/>
+          <p:cNvSpPr/>
+          <p:nvPr/>
+        </p:nvSpPr>
+        <p:spPr>
+          <a:xfrm>
+            <a:off x="6537960" y="4334256"/>
+            <a:ext cx="4800600" cy="246888"/>
+          </a:xfrm>
+          <a:prstGeom prst="rect">
+            <a:avLst/>
+          </a:prstGeom>
+          <a:noFill/>
+          <a:ln/>
+        </p:spPr>
+        <p:txBody>
+          <a:bodyPr wrap="square" lIns="0" tIns="0" rIns="0" bIns="0" rtlCol="0" anchor="ctr"/>
+          <a:lstStyle/>
+          <a:p>
+            <a:pPr indent="0" marL="0">
+              <a:buNone/>
+            </a:pPr>
+            <a:r>
+              <a:rPr lang="en-US" sz="1100" dirty="0">
+                <a:solidFill>
+                  <a:srgbClr val="1F2937"/>
+                </a:solidFill>
+                <a:latin typeface="Courier New" pitchFamily="34" charset="0"/>
+                <a:ea typeface="Courier New" pitchFamily="34" charset="-122"/>
+                <a:cs typeface="Courier New" pitchFamily="34" charset="-120"/>
+              </a:rPr>
+              <a:t>web-publisher-weekly  Wednesdays 09:03 build + index</a:t>
+            </a:r>
+            <a:endParaRPr lang="en-US" sz="1100" dirty="0"/>
+          </a:p>
+        </p:txBody>
+      </p:sp>
+      <p:sp>
+        <p:nvSpPr>
+          <p:cNvPr id="24" name="Text 22"/>
+          <p:cNvSpPr/>
+          <p:nvPr/>
+        </p:nvSpPr>
+        <p:spPr>
+          <a:xfrm>
+            <a:off x="6537960" y="4599432"/>
+            <a:ext cx="4800600" cy="246888"/>
+          </a:xfrm>
+          <a:prstGeom prst="rect">
+            <a:avLst/>
+          </a:prstGeom>
+          <a:noFill/>
+          <a:ln/>
+        </p:spPr>
+        <p:txBody>
+          <a:bodyPr wrap="square" lIns="0" tIns="0" rIns="0" bIns="0" rtlCol="0" anchor="ctr"/>
+          <a:lstStyle/>
+          <a:p>
+            <a:pPr indent="0" marL="0">
+              <a:buNone/>
+            </a:pPr>
+            <a:r>
+              <a:rPr lang="en-US" sz="1100" dirty="0">
+                <a:solidFill>
+                  <a:srgbClr val="1F2937"/>
+                </a:solidFill>
+                <a:latin typeface="Courier New" pitchFamily="34" charset="0"/>
+                <a:ea typeface="Courier New" pitchFamily="34" charset="-122"/>
+                <a:cs typeface="Courier New" pitchFamily="34" charset="-120"/>
+              </a:rPr>
+              <a:t>email-marketer-weekly Thursdays 10:03 newsletter</a:t>
+            </a:r>
+            <a:endParaRPr lang="en-US" sz="1100" dirty="0"/>
+          </a:p>
+        </p:txBody>
+      </p:sp>
+      <p:sp>
+        <p:nvSpPr>
+          <p:cNvPr id="25" name="Text 23"/>
+          <p:cNvSpPr/>
+          <p:nvPr/>
+        </p:nvSpPr>
+        <p:spPr>
+          <a:xfrm>
+            <a:off x="6537960" y="4864608"/>
+            <a:ext cx="4800600" cy="246888"/>
+          </a:xfrm>
+          <a:prstGeom prst="rect">
+            <a:avLst/>
+          </a:prstGeom>
+          <a:noFill/>
+          <a:ln/>
+        </p:spPr>
+        <p:txBody>
+          <a:bodyPr wrap="square" lIns="0" tIns="0" rIns="0" bIns="0" rtlCol="0" anchor="ctr"/>
+          <a:lstStyle/>
+          <a:p>
+            <a:pPr indent="0" marL="0">
+              <a:buNone/>
+            </a:pPr>
+            <a:r>
+              <a:rPr lang="en-US" sz="1100" dirty="0">
+                <a:solidFill>
+                  <a:srgbClr val="1F2937"/>
+                </a:solidFill>
+                <a:latin typeface="Courier New" pitchFamily="34" charset="0"/>
+                <a:ea typeface="Courier New" pitchFamily="34" charset="-122"/>
+                <a:cs typeface="Courier New" pitchFamily="34" charset="-120"/>
+              </a:rPr>
+              <a:t>devops-daily health   daily 06:00</a:t>
+            </a:r>
+            <a:endParaRPr lang="en-US" sz="1100" dirty="0"/>
+          </a:p>
+        </p:txBody>
+      </p:sp>
+      <p:sp>
+        <p:nvSpPr>
+          <p:cNvPr id="26" name="Text 24"/>
+          <p:cNvSpPr/>
+          <p:nvPr/>
+        </p:nvSpPr>
+        <p:spPr>
+          <a:xfrm>
+            <a:off x="6537960" y="5166360"/>
+            <a:ext cx="4800600" cy="502920"/>
+          </a:xfrm>
+          <a:prstGeom prst="rect">
+            <a:avLst/>
+          </a:prstGeom>
+          <a:noFill/>
+          <a:ln/>
+        </p:spPr>
+        <p:txBody>
+          <a:bodyPr wrap="square" rtlCol="0" anchor="ctr"/>
+          <a:lstStyle/>
+          <a:p>
+            <a:pPr indent="0" marL="0">
+              <a:buNone/>
+            </a:pPr>
+            <a:r>
+              <a:rPr lang="en-US" sz="1150" i="1" dirty="0">
+                <a:solidFill>
+                  <a:srgbClr val="6B7280"/>
+                </a:solidFill>
+                <a:latin typeface="Calibri" pitchFamily="34" charset="0"/>
+                <a:ea typeface="Calibri" pitchFamily="34" charset="-122"/>
+                <a:cs typeface="Calibri" pitchFamily="34" charset="-120"/>
+              </a:rPr>
+              <a:t>10 durable CronCreate routines → RemoteTrigger (cloud-persistent) · + hooks: pre-bash · prompt-submit · SessionStart/End · usage-context.py · telemetry → gh → Supabase · SessionStart auto-update</a:t>
+            </a:r>
+            <a:endParaRPr lang="en-US" sz="1150" dirty="0"/>
+          </a:p>
+        </p:txBody>
+      </p:sp>
+      <p:sp>
+        <p:nvSpPr>
+          <p:cNvPr id="27" name="Shape 25"/>
+          <p:cNvSpPr/>
+          <p:nvPr/>
+        </p:nvSpPr>
+        <p:spPr>
+          <a:xfrm>
+            <a:off x="685800" y="5760720"/>
+            <a:ext cx="987552" cy="292608"/>
+          </a:xfrm>
+          <a:prstGeom prst="roundRect">
+            <a:avLst>
+              <a:gd name="adj" fmla="val 50000"/>
+            </a:avLst>
+          </a:prstGeom>
+          <a:solidFill>
+            <a:srgbClr val="2E7D32"/>
+          </a:solidFill>
+          <a:ln w="12700">
+            <a:solidFill>
+              <a:srgbClr val="2E7D32"/>
+            </a:solidFill>
+            <a:prstDash val="solid"/>
+          </a:ln>
+        </p:spPr>
+      </p:sp>
+      <p:sp>
+        <p:nvSpPr>
+          <p:cNvPr id="28" name="Text 26"/>
+          <p:cNvSpPr/>
+          <p:nvPr/>
+        </p:nvSpPr>
+        <p:spPr>
+          <a:xfrm>
+            <a:off x="685800" y="5733288"/>
+            <a:ext cx="987552" cy="292608"/>
+          </a:xfrm>
+          <a:prstGeom prst="rect">
+            <a:avLst/>
+          </a:prstGeom>
+          <a:noFill/>
+          <a:ln/>
+        </p:spPr>
+        <p:txBody>
+          <a:bodyPr wrap="square" lIns="0" tIns="0" rIns="0" bIns="0" rtlCol="0" anchor="ctr"/>
+          <a:lstStyle/>
+          <a:p>
+            <a:pPr algn="ctr" indent="0" marL="0">
+              <a:buNone/>
+            </a:pPr>
+            <a:r>
+              <a:rPr lang="en-US" sz="1100" b="1" dirty="0">
+                <a:solidFill>
+                  <a:srgbClr val="FFFFFF"/>
+                </a:solidFill>
+                <a:latin typeface="Calibri" pitchFamily="34" charset="0"/>
+                <a:ea typeface="Calibri" pitchFamily="34" charset="-122"/>
+                <a:cs typeface="Calibri" pitchFamily="34" charset="-120"/>
+              </a:rPr>
+              <a:t>VERIFIED</a:t>
+            </a:r>
+            <a:endParaRPr lang="en-US" sz="1100" dirty="0"/>
+          </a:p>
+        </p:txBody>
+      </p:sp>
+      <p:sp>
+        <p:nvSpPr>
+          <p:cNvPr id="29" name="Text 27"/>
+          <p:cNvSpPr/>
+          <p:nvPr/>
+        </p:nvSpPr>
+        <p:spPr>
+          <a:xfrm>
+            <a:off x="2286000" y="5788152"/>
+            <a:ext cx="9235440" cy="365760"/>
+          </a:xfrm>
+          <a:prstGeom prst="rect">
+            <a:avLst/>
+          </a:prstGeom>
+          <a:noFill/>
+          <a:ln/>
+        </p:spPr>
+        <p:txBody>
+          <a:bodyPr wrap="square" rtlCol="0" anchor="ctr"/>
+          <a:lstStyle/>
+          <a:p>
+            <a:pPr indent="0" marL="0">
+              <a:buNone/>
+            </a:pPr>
+            <a:r>
+              <a:rPr lang="en-US" sz="1200" i="1" dirty="0">
+                <a:solidFill>
+                  <a:srgbClr val="6B7280"/>
+                </a:solidFill>
+                <a:latin typeface="Calibri" pitchFamily="34" charset="0"/>
+                <a:ea typeface="Calibri" pitchFamily="34" charset="-122"/>
+                <a:cs typeface="Calibri" pitchFamily="34" charset="-120"/>
+              </a:rPr>
+              <a:t>Commit trail: 5c89076 “8 scheduled task templates using CronCreate” (durable=true · auto-expire 7 days) · 9291df3 · b753023 · a218b79 hooks · fff7a9a telemetry · e2d5d67 8 agent templates.</a:t>
+            </a:r>
+            <a:endParaRPr lang="en-US" sz="1200" dirty="0"/>
+          </a:p>
+        </p:txBody>
+      </p:sp>
+    </p:spTree>
+  </p:cSld>
+  <p:clrMapOvr>
+    <a:masterClrMapping/>
+  </p:clrMapOvr>
+</p:sld>
+</file>
+
+<file path=ppt/slides/slide16.xml><?xml version="1.0" encoding="utf-8"?>
+<p:sld xmlns:a="http://schemas.openxmlformats.org/drawingml/2006/main" xmlns:r="http://schemas.openxmlformats.org/officeDocument/2006/relationships" xmlns:p="http://schemas.openxmlformats.org/presentationml/2006/main">
+  <p:cSld name="Slide 16">
+    <p:bg>
+      <p:bgPr>
+        <a:solidFill>
+          <a:srgbClr val="FFFFFF"/>
+        </a:solidFill>
+      </p:bgPr>
+    </p:bg>
+    <p:spTree>
+      <p:nvGrpSpPr>
+        <p:cNvPr id="1" name=""/>
+        <p:cNvGrpSpPr/>
+        <p:nvPr/>
+      </p:nvGrpSpPr>
+      <p:grpSpPr>
+        <a:xfrm>
+          <a:off x="0" y="0"/>
+          <a:ext cx="0" cy="0"/>
+          <a:chOff x="0" y="0"/>
+          <a:chExt cx="0" cy="0"/>
+        </a:xfrm>
+      </p:grpSpPr>
+      <p:sp>
+        <p:nvSpPr>
+          <p:cNvPr id="2" name="Text 0"/>
+          <p:cNvSpPr/>
+          <p:nvPr/>
+        </p:nvSpPr>
+        <p:spPr>
+          <a:xfrm>
+            <a:off x="502920" y="256032"/>
+            <a:ext cx="10972800" cy="292608"/>
+          </a:xfrm>
+          <a:prstGeom prst="rect">
+            <a:avLst/>
+          </a:prstGeom>
+          <a:noFill/>
+          <a:ln/>
+        </p:spPr>
+        <p:txBody>
+          <a:bodyPr wrap="square" rtlCol="0" anchor="ctr"/>
+          <a:lstStyle/>
+          <a:p>
+            <a:pPr indent="0" marL="0">
+              <a:buNone/>
+            </a:pPr>
+            <a:r>
+              <a:rPr lang="en-US" sz="1300" b="1" spc="200" kern="0" dirty="0">
+                <a:solidFill>
+                  <a:srgbClr val="B98A00"/>
+                </a:solidFill>
+                <a:latin typeface="Calibri" pitchFamily="34" charset="0"/>
+                <a:ea typeface="Calibri" pitchFamily="34" charset="-122"/>
+                <a:cs typeface="Calibri" pitchFamily="34" charset="-120"/>
+              </a:rPr>
+              <a:t>HISTORY</a:t>
+            </a:r>
+            <a:endParaRPr lang="en-US" sz="1300" dirty="0"/>
+          </a:p>
+        </p:txBody>
+      </p:sp>
+      <p:sp>
+        <p:nvSpPr>
+          <p:cNvPr id="3" name="Text 1"/>
+          <p:cNvSpPr/>
+          <p:nvPr/>
+        </p:nvSpPr>
+        <p:spPr>
+          <a:xfrm>
+            <a:off x="502920" y="548640"/>
+            <a:ext cx="11155680" cy="822960"/>
+          </a:xfrm>
+          <a:prstGeom prst="rect">
+            <a:avLst/>
+          </a:prstGeom>
+          <a:noFill/>
+          <a:ln/>
+        </p:spPr>
+        <p:txBody>
+          <a:bodyPr wrap="square" rtlCol="0" anchor="ctr"/>
+          <a:lstStyle/>
+          <a:p>
+            <a:pPr indent="0" marL="0">
+              <a:buNone/>
+            </a:pPr>
+            <a:r>
+              <a:rPr lang="en-US" sz="4400" b="1" dirty="0">
+                <a:solidFill>
+                  <a:srgbClr val="1E2761"/>
+                </a:solidFill>
+                <a:latin typeface="Cambria" pitchFamily="34" charset="0"/>
+                <a:ea typeface="Cambria" pitchFamily="34" charset="-122"/>
+                <a:cs typeface="Cambria" pitchFamily="34" charset="-120"/>
+              </a:rPr>
+              <a:t>v1 → v2: what changed, and why</a:t>
+            </a:r>
+            <a:endParaRPr lang="en-US" sz="4400" dirty="0"/>
+          </a:p>
+        </p:txBody>
+      </p:sp>
+      <p:sp>
+        <p:nvSpPr>
+          <p:cNvPr id="4" name="Text 2"/>
+          <p:cNvSpPr/>
+          <p:nvPr/>
+        </p:nvSpPr>
+        <p:spPr>
+          <a:xfrm>
+            <a:off x="502920" y="1371600"/>
+            <a:ext cx="11155680" cy="457200"/>
+          </a:xfrm>
+          <a:prstGeom prst="rect">
+            <a:avLst/>
+          </a:prstGeom>
+          <a:noFill/>
+          <a:ln/>
+        </p:spPr>
+        <p:txBody>
+          <a:bodyPr wrap="square" rtlCol="0" anchor="ctr"/>
+          <a:lstStyle/>
+          <a:p>
+            <a:pPr indent="0" marL="0">
+              <a:buNone/>
+            </a:pPr>
+            <a:r>
+              <a:rPr lang="en-US" sz="2000" dirty="0">
+                <a:solidFill>
+                  <a:srgbClr val="6B7280"/>
+                </a:solidFill>
+                <a:latin typeface="Calibri" pitchFamily="34" charset="0"/>
+                <a:ea typeface="Calibri" pitchFamily="34" charset="-122"/>
+                <a:cs typeface="Calibri" pitchFamily="34" charset="-120"/>
+              </a:rPr>
+              <a:t>Same goal — leverage. Different trust model.</a:t>
+            </a:r>
+            <a:endParaRPr lang="en-US" sz="2000" dirty="0"/>
+          </a:p>
+        </p:txBody>
+      </p:sp>
+      <p:sp>
+        <p:nvSpPr>
+          <p:cNvPr id="5" name="Text 3"/>
+          <p:cNvSpPr/>
+          <p:nvPr/>
+        </p:nvSpPr>
+        <p:spPr>
+          <a:xfrm>
+            <a:off x="868680" y="1874520"/>
+            <a:ext cx="1828800" cy="274320"/>
+          </a:xfrm>
+          <a:prstGeom prst="rect">
+            <a:avLst/>
+          </a:prstGeom>
+          <a:noFill/>
+          <a:ln/>
+        </p:spPr>
+        <p:txBody>
+          <a:bodyPr wrap="square" rtlCol="0" anchor="ctr"/>
+          <a:lstStyle/>
+          <a:p>
+            <a:pPr indent="0" marL="0">
+              <a:buNone/>
+            </a:pPr>
+            <a:r>
+              <a:rPr lang="en-US" sz="1100" b="1" dirty="0">
+                <a:solidFill>
+                  <a:srgbClr val="6B7280"/>
+                </a:solidFill>
+                <a:latin typeface="Calibri" pitchFamily="34" charset="0"/>
+                <a:ea typeface="Calibri" pitchFamily="34" charset="-122"/>
+                <a:cs typeface="Calibri" pitchFamily="34" charset="-120"/>
+              </a:rPr>
+              <a:t>DIMENSION</a:t>
+            </a:r>
+            <a:endParaRPr lang="en-US" sz="1100" dirty="0"/>
+          </a:p>
+        </p:txBody>
+      </p:sp>
+      <p:sp>
+        <p:nvSpPr>
+          <p:cNvPr id="6" name="Text 4"/>
+          <p:cNvSpPr/>
+          <p:nvPr/>
+        </p:nvSpPr>
+        <p:spPr>
+          <a:xfrm>
+            <a:off x="2788920" y="1874520"/>
+            <a:ext cx="4114800" cy="274320"/>
+          </a:xfrm>
+          <a:prstGeom prst="rect">
+            <a:avLst/>
+          </a:prstGeom>
+          <a:noFill/>
+          <a:ln/>
+        </p:spPr>
+        <p:txBody>
+          <a:bodyPr wrap="square" rtlCol="0" anchor="ctr"/>
+          <a:lstStyle/>
+          <a:p>
+            <a:pPr algn="ctr" indent="0" marL="0">
+              <a:buNone/>
+            </a:pPr>
+            <a:r>
+              <a:rPr lang="en-US" sz="1100" b="1" dirty="0">
+                <a:solidFill>
+                  <a:srgbClr val="B91C1C"/>
+                </a:solidFill>
+                <a:latin typeface="Calibri" pitchFamily="34" charset="0"/>
+                <a:ea typeface="Calibri" pitchFamily="34" charset="-122"/>
+                <a:cs typeface="Calibri" pitchFamily="34" charset="-120"/>
+              </a:rPr>
+              <a:t>V1 · INFINITE LEVERAGE</a:t>
+            </a:r>
+            <a:endParaRPr lang="en-US" sz="1100" dirty="0"/>
+          </a:p>
+        </p:txBody>
+      </p:sp>
+      <p:sp>
+        <p:nvSpPr>
+          <p:cNvPr id="7" name="Text 5"/>
+          <p:cNvSpPr/>
+          <p:nvPr/>
+        </p:nvSpPr>
+        <p:spPr>
+          <a:xfrm>
+            <a:off x="6995160" y="1874520"/>
+            <a:ext cx="4754880" cy="274320"/>
+          </a:xfrm>
+          <a:prstGeom prst="rect">
+            <a:avLst/>
+          </a:prstGeom>
+          <a:noFill/>
+          <a:ln/>
+        </p:spPr>
+        <p:txBody>
+          <a:bodyPr wrap="square" rtlCol="0" anchor="ctr"/>
+          <a:lstStyle/>
+          <a:p>
+            <a:pPr algn="ctr" indent="0" marL="0">
+              <a:buNone/>
+            </a:pPr>
+            <a:r>
+              <a:rPr lang="en-US" sz="1100" b="1" dirty="0">
+                <a:solidFill>
+                  <a:srgbClr val="1B5E20"/>
+                </a:solidFill>
+                <a:latin typeface="Calibri" pitchFamily="34" charset="0"/>
+                <a:ea typeface="Calibri" pitchFamily="34" charset="-122"/>
+                <a:cs typeface="Calibri" pitchFamily="34" charset="-120"/>
+              </a:rPr>
+              <a:t>V2 · AGENTIC SDLC</a:t>
+            </a:r>
+            <a:endParaRPr lang="en-US" sz="1100" dirty="0"/>
+          </a:p>
+        </p:txBody>
+      </p:sp>
+      <p:sp>
+        <p:nvSpPr>
+          <p:cNvPr id="8" name="Shape 6"/>
+          <p:cNvSpPr/>
+          <p:nvPr/>
+        </p:nvSpPr>
+        <p:spPr>
+          <a:xfrm>
+            <a:off x="685800" y="2084832"/>
+            <a:ext cx="10835640" cy="457200"/>
+          </a:xfrm>
+          <a:prstGeom prst="roundRect">
+            <a:avLst>
+              <a:gd name="adj" fmla="val 20000"/>
+            </a:avLst>
+          </a:prstGeom>
+          <a:solidFill>
+            <a:srgbClr val="F8FAFC"/>
+          </a:solidFill>
+          <a:ln w="15875">
+            <a:solidFill>
+              <a:srgbClr val="D1D5DB"/>
+            </a:solidFill>
+            <a:prstDash val="solid"/>
+          </a:ln>
+        </p:spPr>
+      </p:sp>
+      <p:sp>
+        <p:nvSpPr>
+          <p:cNvPr id="9" name="Text 7"/>
+          <p:cNvSpPr/>
+          <p:nvPr/>
+        </p:nvSpPr>
+        <p:spPr>
+          <a:xfrm>
+            <a:off x="868680" y="2157984"/>
+            <a:ext cx="1828800" cy="310896"/>
+          </a:xfrm>
+          <a:prstGeom prst="rect">
+            <a:avLst/>
+          </a:prstGeom>
+          <a:noFill/>
+          <a:ln/>
+        </p:spPr>
+        <p:txBody>
+          <a:bodyPr wrap="square" lIns="0" tIns="0" rIns="0" bIns="0" rtlCol="0" anchor="ctr"/>
+          <a:lstStyle/>
+          <a:p>
+            <a:pPr indent="0" marL="0">
+              <a:buNone/>
+            </a:pPr>
+            <a:r>
+              <a:rPr lang="en-US" sz="1200" b="1" dirty="0">
+                <a:solidFill>
+                  <a:srgbClr val="1E2761"/>
+                </a:solidFill>
+                <a:latin typeface="Calibri" pitchFamily="34" charset="0"/>
+                <a:ea typeface="Calibri" pitchFamily="34" charset="-122"/>
+                <a:cs typeface="Calibri" pitchFamily="34" charset="-120"/>
+              </a:rPr>
+              <a:t>Install surface</a:t>
+            </a:r>
+            <a:endParaRPr lang="en-US" sz="1200" dirty="0"/>
+          </a:p>
+        </p:txBody>
+      </p:sp>
+      <p:sp>
+        <p:nvSpPr>
+          <p:cNvPr id="10" name="Text 8"/>
+          <p:cNvSpPr/>
+          <p:nvPr/>
+        </p:nvSpPr>
+        <p:spPr>
+          <a:xfrm>
+            <a:off x="2788920" y="2157984"/>
+            <a:ext cx="4114800" cy="310896"/>
+          </a:xfrm>
+          <a:prstGeom prst="rect">
+            <a:avLst/>
+          </a:prstGeom>
+          <a:noFill/>
+          <a:ln/>
+        </p:spPr>
+        <p:txBody>
+          <a:bodyPr wrap="square" lIns="0" tIns="0" rIns="0" bIns="0" rtlCol="0" anchor="ctr"/>
+          <a:lstStyle/>
+          <a:p>
+            <a:pPr indent="0" marL="0">
+              <a:buNone/>
+            </a:pPr>
+            <a:r>
+              <a:rPr lang="en-US" sz="1150" dirty="0">
+                <a:solidFill>
+                  <a:srgbClr val="B91C1C"/>
+                </a:solidFill>
+                <a:latin typeface="Calibri" pitchFamily="34" charset="0"/>
+                <a:ea typeface="Calibri" pitchFamily="34" charset="-122"/>
+                <a:cs typeface="Calibri" pitchFamily="34" charset="-120"/>
+              </a:rPr>
+              <a:t>~/.claude/ global — zip + patch</a:t>
+            </a:r>
+            <a:endParaRPr lang="en-US" sz="1150" dirty="0"/>
+          </a:p>
+        </p:txBody>
+      </p:sp>
+      <p:sp>
+        <p:nvSpPr>
+          <p:cNvPr id="11" name="Text 9"/>
+          <p:cNvSpPr/>
+          <p:nvPr/>
+        </p:nvSpPr>
+        <p:spPr>
+          <a:xfrm>
+            <a:off x="6995160" y="2157984"/>
+            <a:ext cx="4434840" cy="310896"/>
+          </a:xfrm>
+          <a:prstGeom prst="rect">
+            <a:avLst/>
+          </a:prstGeom>
+          <a:noFill/>
+          <a:ln/>
+        </p:spPr>
+        <p:txBody>
+          <a:bodyPr wrap="square" lIns="0" tIns="0" rIns="0" bIns="0" rtlCol="0" anchor="ctr"/>
+          <a:lstStyle/>
+          <a:p>
+            <a:pPr indent="0" marL="0">
+              <a:buNone/>
+            </a:pPr>
+            <a:r>
+              <a:rPr lang="en-US" sz="1150" dirty="0">
+                <a:solidFill>
+                  <a:srgbClr val="1B5E20"/>
+                </a:solidFill>
+                <a:latin typeface="Calibri" pitchFamily="34" charset="0"/>
+                <a:ea typeface="Calibri" pitchFamily="34" charset="-122"/>
+                <a:cs typeface="Calibri" pitchFamily="34" charset="-120"/>
+              </a:rPr>
+              <a:t>marketplace plugin · per-project .claude/</a:t>
+            </a:r>
+            <a:endParaRPr lang="en-US" sz="1150" dirty="0"/>
+          </a:p>
+        </p:txBody>
+      </p:sp>
+      <p:sp>
+        <p:nvSpPr>
+          <p:cNvPr id="12" name="Shape 10"/>
+          <p:cNvSpPr/>
+          <p:nvPr/>
+        </p:nvSpPr>
+        <p:spPr>
+          <a:xfrm>
+            <a:off x="685800" y="2578608"/>
+            <a:ext cx="10835640" cy="457200"/>
+          </a:xfrm>
+          <a:prstGeom prst="roundRect">
+            <a:avLst>
+              <a:gd name="adj" fmla="val 20000"/>
+            </a:avLst>
+          </a:prstGeom>
+          <a:solidFill>
+            <a:srgbClr val="F8FAFC"/>
+          </a:solidFill>
+          <a:ln w="15875">
+            <a:solidFill>
+              <a:srgbClr val="D1D5DB"/>
+            </a:solidFill>
+            <a:prstDash val="solid"/>
+          </a:ln>
+        </p:spPr>
+      </p:sp>
+      <p:sp>
+        <p:nvSpPr>
+          <p:cNvPr id="13" name="Text 11"/>
+          <p:cNvSpPr/>
+          <p:nvPr/>
+        </p:nvSpPr>
+        <p:spPr>
+          <a:xfrm>
+            <a:off x="868680" y="2651760"/>
+            <a:ext cx="1828800" cy="310896"/>
+          </a:xfrm>
+          <a:prstGeom prst="rect">
+            <a:avLst/>
+          </a:prstGeom>
+          <a:noFill/>
+          <a:ln/>
+        </p:spPr>
+        <p:txBody>
+          <a:bodyPr wrap="square" lIns="0" tIns="0" rIns="0" bIns="0" rtlCol="0" anchor="ctr"/>
+          <a:lstStyle/>
+          <a:p>
+            <a:pPr indent="0" marL="0">
+              <a:buNone/>
+            </a:pPr>
+            <a:r>
+              <a:rPr lang="en-US" sz="1200" b="1" dirty="0">
+                <a:solidFill>
+                  <a:srgbClr val="1E2761"/>
+                </a:solidFill>
+                <a:latin typeface="Calibri" pitchFamily="34" charset="0"/>
+                <a:ea typeface="Calibri" pitchFamily="34" charset="-122"/>
+                <a:cs typeface="Calibri" pitchFamily="34" charset="-120"/>
+              </a:rPr>
+              <a:t>Automation</a:t>
+            </a:r>
+            <a:endParaRPr lang="en-US" sz="1200" dirty="0"/>
+          </a:p>
+        </p:txBody>
+      </p:sp>
+      <p:sp>
+        <p:nvSpPr>
+          <p:cNvPr id="14" name="Text 12"/>
+          <p:cNvSpPr/>
+          <p:nvPr/>
+        </p:nvSpPr>
+        <p:spPr>
+          <a:xfrm>
+            <a:off x="2788920" y="2651760"/>
+            <a:ext cx="4114800" cy="310896"/>
+          </a:xfrm>
+          <a:prstGeom prst="rect">
+            <a:avLst/>
+          </a:prstGeom>
+          <a:noFill/>
+          <a:ln/>
+        </p:spPr>
+        <p:txBody>
+          <a:bodyPr wrap="square" lIns="0" tIns="0" rIns="0" bIns="0" rtlCol="0" anchor="ctr"/>
+          <a:lstStyle/>
+          <a:p>
+            <a:pPr indent="0" marL="0">
+              <a:buNone/>
+            </a:pPr>
+            <a:r>
+              <a:rPr lang="en-US" sz="1150" dirty="0">
+                <a:solidFill>
+                  <a:srgbClr val="B91C1C"/>
+                </a:solidFill>
+                <a:latin typeface="Calibri" pitchFamily="34" charset="0"/>
+                <a:ea typeface="Calibri" pitchFamily="34" charset="-122"/>
+                <a:cs typeface="Calibri" pitchFamily="34" charset="-120"/>
+              </a:rPr>
+              <a:t>10 cron routines · auto-approve · overnight</a:t>
+            </a:r>
+            <a:endParaRPr lang="en-US" sz="1150" dirty="0"/>
+          </a:p>
+        </p:txBody>
+      </p:sp>
+      <p:sp>
+        <p:nvSpPr>
+          <p:cNvPr id="15" name="Text 13"/>
+          <p:cNvSpPr/>
+          <p:nvPr/>
+        </p:nvSpPr>
+        <p:spPr>
+          <a:xfrm>
+            <a:off x="6995160" y="2651760"/>
+            <a:ext cx="4434840" cy="310896"/>
+          </a:xfrm>
+          <a:prstGeom prst="rect">
+            <a:avLst/>
+          </a:prstGeom>
+          <a:noFill/>
+          <a:ln/>
+        </p:spPr>
+        <p:txBody>
+          <a:bodyPr wrap="square" lIns="0" tIns="0" rIns="0" bIns="0" rtlCol="0" anchor="ctr"/>
+          <a:lstStyle/>
+          <a:p>
+            <a:pPr indent="0" marL="0">
+              <a:buNone/>
+            </a:pPr>
+            <a:r>
+              <a:rPr lang="en-US" sz="1150" dirty="0">
+                <a:solidFill>
+                  <a:srgbClr val="1B5E20"/>
+                </a:solidFill>
+                <a:latin typeface="Calibri" pitchFamily="34" charset="0"/>
+                <a:ea typeface="Calibri" pitchFamily="34" charset="-122"/>
+                <a:cs typeface="Calibri" pitchFamily="34" charset="-120"/>
+              </a:rPr>
+              <a:t>none — every gate is a human decision</a:t>
+            </a:r>
+            <a:endParaRPr lang="en-US" sz="1150" dirty="0"/>
+          </a:p>
+        </p:txBody>
+      </p:sp>
+      <p:sp>
+        <p:nvSpPr>
+          <p:cNvPr id="16" name="Shape 14"/>
+          <p:cNvSpPr/>
+          <p:nvPr/>
+        </p:nvSpPr>
+        <p:spPr>
+          <a:xfrm>
+            <a:off x="685800" y="3072384"/>
+            <a:ext cx="10835640" cy="457200"/>
+          </a:xfrm>
+          <a:prstGeom prst="roundRect">
+            <a:avLst>
+              <a:gd name="adj" fmla="val 20000"/>
+            </a:avLst>
+          </a:prstGeom>
+          <a:solidFill>
+            <a:srgbClr val="F8FAFC"/>
+          </a:solidFill>
+          <a:ln w="15875">
+            <a:solidFill>
+              <a:srgbClr val="D1D5DB"/>
+            </a:solidFill>
+            <a:prstDash val="solid"/>
+          </a:ln>
+        </p:spPr>
+      </p:sp>
+      <p:sp>
+        <p:nvSpPr>
+          <p:cNvPr id="17" name="Text 15"/>
+          <p:cNvSpPr/>
+          <p:nvPr/>
+        </p:nvSpPr>
+        <p:spPr>
+          <a:xfrm>
+            <a:off x="868680" y="3145536"/>
+            <a:ext cx="1828800" cy="310896"/>
+          </a:xfrm>
+          <a:prstGeom prst="rect">
+            <a:avLst/>
+          </a:prstGeom>
+          <a:noFill/>
+          <a:ln/>
+        </p:spPr>
+        <p:txBody>
+          <a:bodyPr wrap="square" lIns="0" tIns="0" rIns="0" bIns="0" rtlCol="0" anchor="ctr"/>
+          <a:lstStyle/>
+          <a:p>
+            <a:pPr indent="0" marL="0">
+              <a:buNone/>
+            </a:pPr>
+            <a:r>
+              <a:rPr lang="en-US" sz="1200" b="1" dirty="0">
+                <a:solidFill>
+                  <a:srgbClr val="1E2761"/>
+                </a:solidFill>
+                <a:latin typeface="Calibri" pitchFamily="34" charset="0"/>
+                <a:ea typeface="Calibri" pitchFamily="34" charset="-122"/>
+                <a:cs typeface="Calibri" pitchFamily="34" charset="-120"/>
+              </a:rPr>
+              <a:t>Hooks</a:t>
+            </a:r>
+            <a:endParaRPr lang="en-US" sz="1200" dirty="0"/>
+          </a:p>
+        </p:txBody>
+      </p:sp>
+      <p:sp>
+        <p:nvSpPr>
+          <p:cNvPr id="18" name="Text 16"/>
+          <p:cNvSpPr/>
+          <p:nvPr/>
+        </p:nvSpPr>
+        <p:spPr>
+          <a:xfrm>
+            <a:off x="2788920" y="3145536"/>
+            <a:ext cx="4114800" cy="310896"/>
+          </a:xfrm>
+          <a:prstGeom prst="rect">
+            <a:avLst/>
+          </a:prstGeom>
+          <a:noFill/>
+          <a:ln/>
+        </p:spPr>
+        <p:txBody>
+          <a:bodyPr wrap="square" lIns="0" tIns="0" rIns="0" bIns="0" rtlCol="0" anchor="ctr"/>
+          <a:lstStyle/>
+          <a:p>
+            <a:pPr indent="0" marL="0">
+              <a:buNone/>
+            </a:pPr>
+            <a:r>
+              <a:rPr lang="en-US" sz="1150" dirty="0">
+                <a:solidFill>
+                  <a:srgbClr val="B91C1C"/>
+                </a:solidFill>
+                <a:latin typeface="Calibri" pitchFamily="34" charset="0"/>
+                <a:ea typeface="Calibri" pitchFamily="34" charset="-122"/>
+                <a:cs typeface="Calibri" pitchFamily="34" charset="-120"/>
+              </a:rPr>
+              <a:t>6+ silent session/tool hooks</a:t>
+            </a:r>
+            <a:endParaRPr lang="en-US" sz="1150" dirty="0"/>
+          </a:p>
+        </p:txBody>
+      </p:sp>
+      <p:sp>
+        <p:nvSpPr>
+          <p:cNvPr id="19" name="Text 17"/>
+          <p:cNvSpPr/>
+          <p:nvPr/>
+        </p:nvSpPr>
+        <p:spPr>
+          <a:xfrm>
+            <a:off x="6995160" y="3145536"/>
+            <a:ext cx="4434840" cy="310896"/>
+          </a:xfrm>
+          <a:prstGeom prst="rect">
+            <a:avLst/>
+          </a:prstGeom>
+          <a:noFill/>
+          <a:ln/>
+        </p:spPr>
+        <p:txBody>
+          <a:bodyPr wrap="square" lIns="0" tIns="0" rIns="0" bIns="0" rtlCol="0" anchor="ctr"/>
+          <a:lstStyle/>
+          <a:p>
+            <a:pPr indent="0" marL="0">
+              <a:buNone/>
+            </a:pPr>
+            <a:r>
+              <a:rPr lang="en-US" sz="1150" dirty="0">
+                <a:solidFill>
+                  <a:srgbClr val="1B5E20"/>
+                </a:solidFill>
+                <a:latin typeface="Calibri" pitchFamily="34" charset="0"/>
+                <a:ea typeface="Calibri" pitchFamily="34" charset="-122"/>
+                <a:cs typeface="Calibri" pitchFamily="34" charset="-120"/>
+              </a:rPr>
+              <a:t>zero in public — guardrails/pre-commit are project-scoped, on request</a:t>
+            </a:r>
+            <a:endParaRPr lang="en-US" sz="1150" dirty="0"/>
+          </a:p>
+        </p:txBody>
+      </p:sp>
+      <p:sp>
+        <p:nvSpPr>
+          <p:cNvPr id="20" name="Shape 18"/>
+          <p:cNvSpPr/>
+          <p:nvPr/>
+        </p:nvSpPr>
+        <p:spPr>
+          <a:xfrm>
+            <a:off x="685800" y="3566160"/>
+            <a:ext cx="10835640" cy="457200"/>
+          </a:xfrm>
+          <a:prstGeom prst="roundRect">
+            <a:avLst>
+              <a:gd name="adj" fmla="val 20000"/>
+            </a:avLst>
+          </a:prstGeom>
+          <a:solidFill>
+            <a:srgbClr val="F8FAFC"/>
+          </a:solidFill>
+          <a:ln w="15875">
+            <a:solidFill>
+              <a:srgbClr val="D1D5DB"/>
+            </a:solidFill>
+            <a:prstDash val="solid"/>
+          </a:ln>
+        </p:spPr>
+      </p:sp>
+      <p:sp>
+        <p:nvSpPr>
+          <p:cNvPr id="21" name="Text 19"/>
+          <p:cNvSpPr/>
+          <p:nvPr/>
+        </p:nvSpPr>
+        <p:spPr>
+          <a:xfrm>
+            <a:off x="868680" y="3639312"/>
+            <a:ext cx="1828800" cy="310896"/>
+          </a:xfrm>
+          <a:prstGeom prst="rect">
+            <a:avLst/>
+          </a:prstGeom>
+          <a:noFill/>
+          <a:ln/>
+        </p:spPr>
+        <p:txBody>
+          <a:bodyPr wrap="square" lIns="0" tIns="0" rIns="0" bIns="0" rtlCol="0" anchor="ctr"/>
+          <a:lstStyle/>
+          <a:p>
+            <a:pPr indent="0" marL="0">
+              <a:buNone/>
+            </a:pPr>
+            <a:r>
+              <a:rPr lang="en-US" sz="1200" b="1" dirty="0">
+                <a:solidFill>
+                  <a:srgbClr val="1E2761"/>
+                </a:solidFill>
+                <a:latin typeface="Calibri" pitchFamily="34" charset="0"/>
+                <a:ea typeface="Calibri" pitchFamily="34" charset="-122"/>
+                <a:cs typeface="Calibri" pitchFamily="34" charset="-120"/>
+              </a:rPr>
+              <a:t>Permissions</a:t>
+            </a:r>
+            <a:endParaRPr lang="en-US" sz="1200" dirty="0"/>
+          </a:p>
+        </p:txBody>
+      </p:sp>
+      <p:sp>
+        <p:nvSpPr>
+          <p:cNvPr id="22" name="Text 20"/>
+          <p:cNvSpPr/>
+          <p:nvPr/>
+        </p:nvSpPr>
+        <p:spPr>
+          <a:xfrm>
+            <a:off x="2788920" y="3639312"/>
+            <a:ext cx="4114800" cy="310896"/>
+          </a:xfrm>
+          <a:prstGeom prst="rect">
+            <a:avLst/>
+          </a:prstGeom>
+          <a:noFill/>
+          <a:ln/>
+        </p:spPr>
+        <p:txBody>
+          <a:bodyPr wrap="square" lIns="0" tIns="0" rIns="0" bIns="0" rtlCol="0" anchor="ctr"/>
+          <a:lstStyle/>
+          <a:p>
+            <a:pPr indent="0" marL="0">
+              <a:buNone/>
+            </a:pPr>
+            <a:r>
+              <a:rPr lang="en-US" sz="1150" dirty="0">
+                <a:solidFill>
+                  <a:srgbClr val="B91C1C"/>
+                </a:solidFill>
+                <a:latin typeface="Calibri" pitchFamily="34" charset="0"/>
+                <a:ea typeface="Calibri" pitchFamily="34" charset="-122"/>
+                <a:cs typeface="Calibri" pitchFamily="34" charset="-120"/>
+              </a:rPr>
+              <a:t>Bash(*) grant · acceptEdits default</a:t>
+            </a:r>
+            <a:endParaRPr lang="en-US" sz="1150" dirty="0"/>
+          </a:p>
+        </p:txBody>
+      </p:sp>
+      <p:sp>
+        <p:nvSpPr>
+          <p:cNvPr id="23" name="Text 21"/>
+          <p:cNvSpPr/>
+          <p:nvPr/>
+        </p:nvSpPr>
+        <p:spPr>
+          <a:xfrm>
+            <a:off x="6995160" y="3639312"/>
+            <a:ext cx="4434840" cy="310896"/>
+          </a:xfrm>
+          <a:prstGeom prst="rect">
+            <a:avLst/>
+          </a:prstGeom>
+          <a:noFill/>
+          <a:ln/>
+        </p:spPr>
+        <p:txBody>
+          <a:bodyPr wrap="square" lIns="0" tIns="0" rIns="0" bIns="0" rtlCol="0" anchor="ctr"/>
+          <a:lstStyle/>
+          <a:p>
+            <a:pPr indent="0" marL="0">
+              <a:buNone/>
+            </a:pPr>
+            <a:r>
+              <a:rPr lang="en-US" sz="1150" dirty="0">
+                <a:solidFill>
+                  <a:srgbClr val="1B5E20"/>
+                </a:solidFill>
+                <a:latin typeface="Calibri" pitchFamily="34" charset="0"/>
+                <a:ea typeface="Calibri" pitchFamily="34" charset="-122"/>
+                <a:cs typeface="Calibri" pitchFamily="34" charset="-120"/>
+              </a:rPr>
+              <a:t>never touches permissions</a:t>
+            </a:r>
+            <a:endParaRPr lang="en-US" sz="1150" dirty="0"/>
+          </a:p>
+        </p:txBody>
+      </p:sp>
+      <p:sp>
+        <p:nvSpPr>
+          <p:cNvPr id="24" name="Shape 22"/>
+          <p:cNvSpPr/>
+          <p:nvPr/>
+        </p:nvSpPr>
+        <p:spPr>
+          <a:xfrm>
+            <a:off x="685800" y="4059936"/>
+            <a:ext cx="10835640" cy="457200"/>
+          </a:xfrm>
+          <a:prstGeom prst="roundRect">
+            <a:avLst>
+              <a:gd name="adj" fmla="val 20000"/>
+            </a:avLst>
+          </a:prstGeom>
+          <a:solidFill>
+            <a:srgbClr val="F8FAFC"/>
+          </a:solidFill>
+          <a:ln w="15875">
+            <a:solidFill>
+              <a:srgbClr val="D1D5DB"/>
+            </a:solidFill>
+            <a:prstDash val="solid"/>
+          </a:ln>
+        </p:spPr>
+      </p:sp>
+      <p:sp>
+        <p:nvSpPr>
+          <p:cNvPr id="25" name="Text 23"/>
+          <p:cNvSpPr/>
+          <p:nvPr/>
+        </p:nvSpPr>
+        <p:spPr>
+          <a:xfrm>
+            <a:off x="868680" y="4133088"/>
+            <a:ext cx="1828800" cy="310896"/>
+          </a:xfrm>
+          <a:prstGeom prst="rect">
+            <a:avLst/>
+          </a:prstGeom>
+          <a:noFill/>
+          <a:ln/>
+        </p:spPr>
+        <p:txBody>
+          <a:bodyPr wrap="square" lIns="0" tIns="0" rIns="0" bIns="0" rtlCol="0" anchor="ctr"/>
+          <a:lstStyle/>
+          <a:p>
+            <a:pPr indent="0" marL="0">
+              <a:buNone/>
+            </a:pPr>
+            <a:r>
+              <a:rPr lang="en-US" sz="1200" b="1" dirty="0">
+                <a:solidFill>
+                  <a:srgbClr val="1E2761"/>
+                </a:solidFill>
+                <a:latin typeface="Calibri" pitchFamily="34" charset="0"/>
+                <a:ea typeface="Calibri" pitchFamily="34" charset="-122"/>
+                <a:cs typeface="Calibri" pitchFamily="34" charset="-120"/>
+              </a:rPr>
+              <a:t>Agents &amp; lanes</a:t>
+            </a:r>
+            <a:endParaRPr lang="en-US" sz="1200" dirty="0"/>
+          </a:p>
+        </p:txBody>
+      </p:sp>
+      <p:sp>
+        <p:nvSpPr>
+          <p:cNvPr id="26" name="Text 24"/>
+          <p:cNvSpPr/>
+          <p:nvPr/>
+        </p:nvSpPr>
+        <p:spPr>
+          <a:xfrm>
+            <a:off x="2788920" y="4133088"/>
+            <a:ext cx="4114800" cy="310896"/>
+          </a:xfrm>
+          <a:prstGeom prst="rect">
+            <a:avLst/>
+          </a:prstGeom>
+          <a:noFill/>
+          <a:ln/>
+        </p:spPr>
+        <p:txBody>
+          <a:bodyPr wrap="square" lIns="0" tIns="0" rIns="0" bIns="0" rtlCol="0" anchor="ctr"/>
+          <a:lstStyle/>
+          <a:p>
+            <a:pPr indent="0" marL="0">
+              <a:buNone/>
+            </a:pPr>
+            <a:r>
+              <a:rPr lang="en-US" sz="1150" dirty="0">
+                <a:solidFill>
+                  <a:srgbClr val="B91C1C"/>
+                </a:solidFill>
+                <a:latin typeface="Calibri" pitchFamily="34" charset="0"/>
+                <a:ea typeface="Calibri" pitchFamily="34" charset="-122"/>
+                <a:cs typeface="Calibri" pitchFamily="34" charset="-120"/>
+              </a:rPr>
+              <a:t>8–9 — dev + marketing (writer/designer/email)</a:t>
+            </a:r>
+            <a:endParaRPr lang="en-US" sz="1150" dirty="0"/>
+          </a:p>
+        </p:txBody>
+      </p:sp>
+      <p:sp>
+        <p:nvSpPr>
+          <p:cNvPr id="27" name="Text 25"/>
+          <p:cNvSpPr/>
+          <p:nvPr/>
+        </p:nvSpPr>
+        <p:spPr>
+          <a:xfrm>
+            <a:off x="6995160" y="4133088"/>
+            <a:ext cx="4434840" cy="310896"/>
+          </a:xfrm>
+          <a:prstGeom prst="rect">
+            <a:avLst/>
+          </a:prstGeom>
+          <a:noFill/>
+          <a:ln/>
+        </p:spPr>
+        <p:txBody>
+          <a:bodyPr wrap="square" lIns="0" tIns="0" rIns="0" bIns="0" rtlCol="0" anchor="ctr"/>
+          <a:lstStyle/>
+          <a:p>
+            <a:pPr indent="0" marL="0">
+              <a:buNone/>
+            </a:pPr>
+            <a:r>
+              <a:rPr lang="en-US" sz="1150" dirty="0">
+                <a:solidFill>
+                  <a:srgbClr val="1B5E20"/>
+                </a:solidFill>
+                <a:latin typeface="Calibri" pitchFamily="34" charset="0"/>
+                <a:ea typeface="Calibri" pitchFamily="34" charset="-122"/>
+                <a:cs typeface="Calibri" pitchFamily="34" charset="-120"/>
+              </a:rPr>
+              <a:t>4 — engineering only; publishing folded into developer</a:t>
+            </a:r>
+            <a:endParaRPr lang="en-US" sz="1150" dirty="0"/>
+          </a:p>
+        </p:txBody>
+      </p:sp>
+      <p:sp>
+        <p:nvSpPr>
+          <p:cNvPr id="28" name="Shape 26"/>
+          <p:cNvSpPr/>
+          <p:nvPr/>
+        </p:nvSpPr>
+        <p:spPr>
+          <a:xfrm>
+            <a:off x="685800" y="4553712"/>
+            <a:ext cx="10835640" cy="457200"/>
+          </a:xfrm>
+          <a:prstGeom prst="roundRect">
+            <a:avLst>
+              <a:gd name="adj" fmla="val 20000"/>
+            </a:avLst>
+          </a:prstGeom>
+          <a:solidFill>
+            <a:srgbClr val="F8FAFC"/>
+          </a:solidFill>
+          <a:ln w="15875">
+            <a:solidFill>
+              <a:srgbClr val="D1D5DB"/>
+            </a:solidFill>
+            <a:prstDash val="solid"/>
+          </a:ln>
+        </p:spPr>
+      </p:sp>
+      <p:sp>
+        <p:nvSpPr>
+          <p:cNvPr id="29" name="Text 27"/>
+          <p:cNvSpPr/>
+          <p:nvPr/>
+        </p:nvSpPr>
+        <p:spPr>
+          <a:xfrm>
+            <a:off x="868680" y="4626864"/>
+            <a:ext cx="1828800" cy="310896"/>
+          </a:xfrm>
+          <a:prstGeom prst="rect">
+            <a:avLst/>
+          </a:prstGeom>
+          <a:noFill/>
+          <a:ln/>
+        </p:spPr>
+        <p:txBody>
+          <a:bodyPr wrap="square" lIns="0" tIns="0" rIns="0" bIns="0" rtlCol="0" anchor="ctr"/>
+          <a:lstStyle/>
+          <a:p>
+            <a:pPr indent="0" marL="0">
+              <a:buNone/>
+            </a:pPr>
+            <a:r>
+              <a:rPr lang="en-US" sz="1200" b="1" dirty="0">
+                <a:solidFill>
+                  <a:srgbClr val="1E2761"/>
+                </a:solidFill>
+                <a:latin typeface="Calibri" pitchFamily="34" charset="0"/>
+                <a:ea typeface="Calibri" pitchFamily="34" charset="-122"/>
+                <a:cs typeface="Calibri" pitchFamily="34" charset="-120"/>
+              </a:rPr>
+              <a:t>Telemetry</a:t>
+            </a:r>
+            <a:endParaRPr lang="en-US" sz="1200" dirty="0"/>
+          </a:p>
+        </p:txBody>
+      </p:sp>
+      <p:sp>
+        <p:nvSpPr>
+          <p:cNvPr id="30" name="Text 28"/>
+          <p:cNvSpPr/>
+          <p:nvPr/>
+        </p:nvSpPr>
+        <p:spPr>
+          <a:xfrm>
+            <a:off x="2788920" y="4626864"/>
+            <a:ext cx="4114800" cy="310896"/>
+          </a:xfrm>
+          <a:prstGeom prst="rect">
+            <a:avLst/>
+          </a:prstGeom>
+          <a:noFill/>
+          <a:ln/>
+        </p:spPr>
+        <p:txBody>
+          <a:bodyPr wrap="square" lIns="0" tIns="0" rIns="0" bIns="0" rtlCol="0" anchor="ctr"/>
+          <a:lstStyle/>
+          <a:p>
+            <a:pPr indent="0" marL="0">
+              <a:buNone/>
+            </a:pPr>
+            <a:r>
+              <a:rPr lang="en-US" sz="1150" dirty="0">
+                <a:solidFill>
+                  <a:srgbClr val="B91C1C"/>
+                </a:solidFill>
+                <a:latin typeface="Calibri" pitchFamily="34" charset="0"/>
+                <a:ea typeface="Calibri" pitchFamily="34" charset="-122"/>
+                <a:cs typeface="Calibri" pitchFamily="34" charset="-120"/>
+              </a:rPr>
+              <a:t>in-product · auto-delivered · human-hours</a:t>
+            </a:r>
+            <a:endParaRPr lang="en-US" sz="1150" dirty="0"/>
+          </a:p>
+        </p:txBody>
+      </p:sp>
+      <p:sp>
+        <p:nvSpPr>
+          <p:cNvPr id="31" name="Text 29"/>
+          <p:cNvSpPr/>
+          <p:nvPr/>
+        </p:nvSpPr>
+        <p:spPr>
+          <a:xfrm>
+            <a:off x="6995160" y="4626864"/>
+            <a:ext cx="4434840" cy="310896"/>
+          </a:xfrm>
+          <a:prstGeom prst="rect">
+            <a:avLst/>
+          </a:prstGeom>
+          <a:noFill/>
+          <a:ln/>
+        </p:spPr>
+        <p:txBody>
+          <a:bodyPr wrap="square" lIns="0" tIns="0" rIns="0" bIns="0" rtlCol="0" anchor="ctr"/>
+          <a:lstStyle/>
+          <a:p>
+            <a:pPr indent="0" marL="0">
+              <a:buNone/>
+            </a:pPr>
+            <a:r>
+              <a:rPr lang="en-US" sz="1150" dirty="0">
+                <a:solidFill>
+                  <a:srgbClr val="1B5E20"/>
+                </a:solidFill>
+                <a:latin typeface="Calibri" pitchFamily="34" charset="0"/>
+                <a:ea typeface="Calibri" pitchFamily="34" charset="-122"/>
+                <a:cs typeface="Calibri" pitchFamily="34" charset="-120"/>
+              </a:rPr>
+              <a:t>split to a private plugin</a:t>
+            </a:r>
+            <a:endParaRPr lang="en-US" sz="1150" dirty="0"/>
+          </a:p>
+        </p:txBody>
+      </p:sp>
+      <p:sp>
+        <p:nvSpPr>
+          <p:cNvPr id="32" name="Shape 30"/>
+          <p:cNvSpPr/>
+          <p:nvPr/>
+        </p:nvSpPr>
+        <p:spPr>
+          <a:xfrm>
+            <a:off x="685800" y="5047488"/>
+            <a:ext cx="10835640" cy="457200"/>
+          </a:xfrm>
+          <a:prstGeom prst="roundRect">
+            <a:avLst>
+              <a:gd name="adj" fmla="val 20000"/>
+            </a:avLst>
+          </a:prstGeom>
+          <a:solidFill>
+            <a:srgbClr val="F8FAFC"/>
+          </a:solidFill>
+          <a:ln w="15875">
+            <a:solidFill>
+              <a:srgbClr val="D1D5DB"/>
+            </a:solidFill>
+            <a:prstDash val="solid"/>
+          </a:ln>
+        </p:spPr>
+      </p:sp>
+      <p:sp>
+        <p:nvSpPr>
+          <p:cNvPr id="33" name="Text 31"/>
+          <p:cNvSpPr/>
+          <p:nvPr/>
+        </p:nvSpPr>
+        <p:spPr>
+          <a:xfrm>
+            <a:off x="868680" y="5120640"/>
+            <a:ext cx="1828800" cy="310896"/>
+          </a:xfrm>
+          <a:prstGeom prst="rect">
+            <a:avLst/>
+          </a:prstGeom>
+          <a:noFill/>
+          <a:ln/>
+        </p:spPr>
+        <p:txBody>
+          <a:bodyPr wrap="square" lIns="0" tIns="0" rIns="0" bIns="0" rtlCol="0" anchor="ctr"/>
+          <a:lstStyle/>
+          <a:p>
+            <a:pPr indent="0" marL="0">
+              <a:buNone/>
+            </a:pPr>
+            <a:r>
+              <a:rPr lang="en-US" sz="1200" b="1" dirty="0">
+                <a:solidFill>
+                  <a:srgbClr val="1E2761"/>
+                </a:solidFill>
+                <a:latin typeface="Calibri" pitchFamily="34" charset="0"/>
+                <a:ea typeface="Calibri" pitchFamily="34" charset="-122"/>
+                <a:cs typeface="Calibri" pitchFamily="34" charset="-120"/>
+              </a:rPr>
+              <a:t>Updates</a:t>
+            </a:r>
+            <a:endParaRPr lang="en-US" sz="1200" dirty="0"/>
+          </a:p>
+        </p:txBody>
+      </p:sp>
+      <p:sp>
+        <p:nvSpPr>
+          <p:cNvPr id="34" name="Text 32"/>
+          <p:cNvSpPr/>
+          <p:nvPr/>
+        </p:nvSpPr>
+        <p:spPr>
+          <a:xfrm>
+            <a:off x="2788920" y="5120640"/>
+            <a:ext cx="4114800" cy="310896"/>
+          </a:xfrm>
+          <a:prstGeom prst="rect">
+            <a:avLst/>
+          </a:prstGeom>
+          <a:noFill/>
+          <a:ln/>
+        </p:spPr>
+        <p:txBody>
+          <a:bodyPr wrap="square" lIns="0" tIns="0" rIns="0" bIns="0" rtlCol="0" anchor="ctr"/>
+          <a:lstStyle/>
+          <a:p>
+            <a:pPr indent="0" marL="0">
+              <a:buNone/>
+            </a:pPr>
+            <a:r>
+              <a:rPr lang="en-US" sz="1150" dirty="0">
+                <a:solidFill>
+                  <a:srgbClr val="B91C1C"/>
+                </a:solidFill>
+                <a:latin typeface="Calibri" pitchFamily="34" charset="0"/>
+                <a:ea typeface="Calibri" pitchFamily="34" charset="-122"/>
+                <a:cs typeface="Calibri" pitchFamily="34" charset="-120"/>
+              </a:rPr>
+              <a:t>zip/patch + SessionStart auto-update</a:t>
+            </a:r>
+            <a:endParaRPr lang="en-US" sz="1150" dirty="0"/>
+          </a:p>
+        </p:txBody>
+      </p:sp>
+      <p:sp>
+        <p:nvSpPr>
+          <p:cNvPr id="35" name="Text 33"/>
+          <p:cNvSpPr/>
+          <p:nvPr/>
+        </p:nvSpPr>
+        <p:spPr>
+          <a:xfrm>
+            <a:off x="6995160" y="5120640"/>
+            <a:ext cx="4434840" cy="310896"/>
+          </a:xfrm>
+          <a:prstGeom prst="rect">
+            <a:avLst/>
+          </a:prstGeom>
+          <a:noFill/>
+          <a:ln/>
+        </p:spPr>
+        <p:txBody>
+          <a:bodyPr wrap="square" lIns="0" tIns="0" rIns="0" bIns="0" rtlCol="0" anchor="ctr"/>
+          <a:lstStyle/>
+          <a:p>
+            <a:pPr indent="0" marL="0">
+              <a:buNone/>
+            </a:pPr>
+            <a:r>
+              <a:rPr lang="en-US" sz="1150" dirty="0">
+                <a:solidFill>
+                  <a:srgbClr val="1B5E20"/>
+                </a:solidFill>
+                <a:latin typeface="Calibri" pitchFamily="34" charset="0"/>
+                <a:ea typeface="Calibri" pitchFamily="34" charset="-122"/>
+                <a:cs typeface="Calibri" pitchFamily="34" charset="-120"/>
+              </a:rPr>
+              <a:t>marketplace · lockstep · doctor diffs versions</a:t>
+            </a:r>
+            <a:endParaRPr lang="en-US" sz="1150" dirty="0"/>
+          </a:p>
+        </p:txBody>
+      </p:sp>
+      <p:sp>
+        <p:nvSpPr>
+          <p:cNvPr id="36" name="Text 34"/>
+          <p:cNvSpPr/>
+          <p:nvPr/>
+        </p:nvSpPr>
+        <p:spPr>
+          <a:xfrm>
+            <a:off x="685800" y="5623560"/>
+            <a:ext cx="8686800" cy="502920"/>
+          </a:xfrm>
+          <a:prstGeom prst="rect">
+            <a:avLst/>
+          </a:prstGeom>
+          <a:noFill/>
+          <a:ln/>
+        </p:spPr>
+        <p:txBody>
+          <a:bodyPr wrap="square" rtlCol="0" anchor="ctr"/>
+          <a:lstStyle/>
+          <a:p>
+            <a:pPr indent="0" marL="0">
+              <a:buNone/>
+            </a:pPr>
+            <a:r>
+              <a:rPr lang="en-US" sz="1300" b="1" dirty="0">
+                <a:solidFill>
+                  <a:srgbClr val="1E2761"/>
+                </a:solidFill>
+                <a:latin typeface="Calibri" pitchFamily="34" charset="0"/>
+                <a:ea typeface="Calibri" pitchFamily="34" charset="-122"/>
+                <a:cs typeface="Calibri" pitchFamily="34" charset="-120"/>
+              </a:rPr>
+              <a:t>V1 trade-off: autonomy + overnight output — paid in machine drift, silent cost, frozen updates (2.5 months).  V2 trade-off: repeatability + trust — paid in no overnight automation, no marketing lanes.</a:t>
+            </a:r>
+            <a:endParaRPr lang="en-US" sz="1300" dirty="0"/>
+          </a:p>
+        </p:txBody>
+      </p:sp>
+      <p:sp>
+        <p:nvSpPr>
+          <p:cNvPr id="37" name="Shape 35"/>
+          <p:cNvSpPr/>
+          <p:nvPr/>
+        </p:nvSpPr>
+        <p:spPr>
+          <a:xfrm>
+            <a:off x="9738360" y="5687568"/>
+            <a:ext cx="987552" cy="292608"/>
+          </a:xfrm>
+          <a:prstGeom prst="roundRect">
+            <a:avLst>
+              <a:gd name="adj" fmla="val 50000"/>
+            </a:avLst>
+          </a:prstGeom>
+          <a:solidFill>
+            <a:srgbClr val="2E7D32"/>
+          </a:solidFill>
+          <a:ln w="12700">
+            <a:solidFill>
+              <a:srgbClr val="2E7D32"/>
+            </a:solidFill>
+            <a:prstDash val="solid"/>
+          </a:ln>
+        </p:spPr>
+      </p:sp>
+      <p:sp>
+        <p:nvSpPr>
+          <p:cNvPr id="38" name="Text 36"/>
+          <p:cNvSpPr/>
+          <p:nvPr/>
+        </p:nvSpPr>
+        <p:spPr>
+          <a:xfrm>
+            <a:off x="9738360" y="5660136"/>
+            <a:ext cx="987552" cy="292608"/>
+          </a:xfrm>
+          <a:prstGeom prst="rect">
+            <a:avLst/>
+          </a:prstGeom>
+          <a:noFill/>
+          <a:ln/>
+        </p:spPr>
+        <p:txBody>
+          <a:bodyPr wrap="square" lIns="0" tIns="0" rIns="0" bIns="0" rtlCol="0" anchor="ctr"/>
+          <a:lstStyle/>
+          <a:p>
+            <a:pPr algn="ctr" indent="0" marL="0">
+              <a:buNone/>
+            </a:pPr>
+            <a:r>
+              <a:rPr lang="en-US" sz="1100" b="1" dirty="0">
+                <a:solidFill>
+                  <a:srgbClr val="FFFFFF"/>
+                </a:solidFill>
+                <a:latin typeface="Calibri" pitchFamily="34" charset="0"/>
+                <a:ea typeface="Calibri" pitchFamily="34" charset="-122"/>
+                <a:cs typeface="Calibri" pitchFamily="34" charset="-120"/>
+              </a:rPr>
+              <a:t>VERIFIED</a:t>
+            </a:r>
+            <a:endParaRPr lang="en-US" sz="1100" dirty="0"/>
+          </a:p>
+        </p:txBody>
+      </p:sp>
+      <p:sp>
+        <p:nvSpPr>
+          <p:cNvPr id="39" name="Text 37"/>
+          <p:cNvSpPr/>
+          <p:nvPr/>
+        </p:nvSpPr>
+        <p:spPr>
+          <a:xfrm>
+            <a:off x="685800" y="6199632"/>
+            <a:ext cx="10835640" cy="365760"/>
+          </a:xfrm>
+          <a:prstGeom prst="rect">
+            <a:avLst/>
+          </a:prstGeom>
+          <a:noFill/>
+          <a:ln/>
+        </p:spPr>
+        <p:txBody>
+          <a:bodyPr wrap="square" rtlCol="0" anchor="ctr"/>
+          <a:lstStyle/>
+          <a:p>
+            <a:pPr indent="0" marL="0">
+              <a:buNone/>
+            </a:pPr>
+            <a:r>
+              <a:rPr lang="en-US" sz="1150" i="1" dirty="0">
+                <a:solidFill>
+                  <a:srgbClr val="6B7280"/>
+                </a:solidFill>
+                <a:latin typeface="Calibri" pitchFamily="34" charset="0"/>
+                <a:ea typeface="Calibri" pitchFamily="34" charset="-122"/>
+                <a:cs typeface="Calibri" pitchFamily="34" charset="-120"/>
+              </a:rPr>
+              <a:t>Why v1 fails: global state drifts · routines rot silently (7-day cron expiry, nobody re-registers) · auto-approve + Bash(*) erode trust · zip/patch froze fixes · telemetry-in-product privacy surface · marketing lanes unmeasured.</a:t>
+            </a:r>
+            <a:endParaRPr lang="en-US" sz="1150" dirty="0"/>
+          </a:p>
+        </p:txBody>
+      </p:sp>
+    </p:spTree>
+  </p:cSld>
+  <p:clrMapOvr>
+    <a:masterClrMapping/>
+  </p:clrMapOvr>
+</p:sld>
+</file>
+
+<file path=ppt/slides/slide17.xml><?xml version="1.0" encoding="utf-8"?>
+<p:sld xmlns:a="http://schemas.openxmlformats.org/drawingml/2006/main" xmlns:r="http://schemas.openxmlformats.org/officeDocument/2006/relationships" xmlns:p="http://schemas.openxmlformats.org/presentationml/2006/main">
+  <p:cSld name="Slide 17">
     <p:bg>
       <p:bgPr>
         <a:solidFill>

</xml_diff>

<commit_message>
deck: gap-analysis slide (measured gaps COST/GUARDRAILS/BENCH/DEVOPS/HUMAN-HOUR + deliberate exclusions + focus list) + docs/slides/GAP-ANALYSIS.md + refreshed close slide focus list; 19 slides
</commit_message>
<xml_diff>
--- a/docs/slides/Agentic-SDLC-Tech-Audience.pptx
+++ b/docs/slides/Agentic-SDLC-Tech-Audience.pptx
@@ -23,9 +23,10 @@
     <p:sldId id="271" r:id="rId17"/>
     <p:sldId id="272" r:id="rId18"/>
     <p:sldId id="273" r:id="rId19"/>
+    <p:sldId id="274" r:id="rId20"/>
   </p:sldIdLst>
   <p:notesMasterIdLst>
-    <p:notesMasterId r:id="rId20"/>
+    <p:notesMasterId r:id="rId21"/>
   </p:notesMasterIdLst>
   <p:sldSz cx="12192000" cy="6858000"/>
   <p:notesSz cx="6858000" cy="12192000"/>
@@ -1311,7 +1312,7 @@
           <a:p>
             <a:r>
               <a:rPr lang="en-US" dirty="0"/>
-              <a:t>Close on the gaps. That is the part we defend most.</a:t>
+              <a:t>Say the cost gap out loud BEFORE they ask — the wrong-model probe is the proof we don't hide. Exclusions: read the v1 lesson slide before they suggest 'just enable hooks'.</a:t>
             </a:r>
             <a:endParaRPr lang="en-US" dirty="0"/>
           </a:p>
@@ -1335,6 +1336,94 @@
             <a:fld id="{F7021451-1387-4CA6-816F-3879F97B5CBC}" type="slidenum">
               <a:rPr lang="en-US"/>
               <a:t>18</a:t>
+            </a:fld>
+            <a:endParaRPr lang="en-US"/>
+          </a:p>
+        </p:txBody>
+      </p:sp>
+    </p:spTree>
+    <p:extLst>
+      <p:ext uri="{BB962C8B-B14F-4D97-AF65-F5344CB8AC3E}">
+        <p14:creationId xmlns:p14="http://schemas.microsoft.com/office/powerpoint/2010/main" val="1024086991"/>
+      </p:ext>
+    </p:extLst>
+  </p:cSld>
+  <p:clrMapOvr>
+    <a:masterClrMapping/>
+  </p:clrMapOvr>
+</p:notes>
+</file>
+
+<file path=ppt/notesSlides/notesSlide19.xml><?xml version="1.0" encoding="utf-8"?>
+<p:notes xmlns:a="http://schemas.openxmlformats.org/drawingml/2006/main" xmlns:r="http://schemas.openxmlformats.org/officeDocument/2006/relationships" xmlns:p="http://schemas.openxmlformats.org/presentationml/2006/main">
+  <p:cSld>
+    <p:spTree>
+      <p:nvGrpSpPr>
+        <p:cNvPr id="1" name=""/>
+        <p:cNvGrpSpPr/>
+        <p:nvPr/>
+      </p:nvGrpSpPr>
+      <p:grpSpPr>
+        <a:xfrm>
+          <a:off x="0" y="0"/>
+          <a:ext cx="0" cy="0"/>
+          <a:chOff x="0" y="0"/>
+          <a:chExt cx="0" cy="0"/>
+        </a:xfrm>
+      </p:grpSpPr>
+      <p:sp>
+        <p:nvSpPr>
+          <p:cNvPr id="2" name="Slide Image Placeholder 1"/>
+          <p:cNvSpPr>
+            <a:spLocks noGrp="1" noRot="1" noChangeAspect="1"/>
+          </p:cNvSpPr>
+          <p:nvPr>
+            <p:ph type="sldImg"/>
+          </p:nvPr>
+        </p:nvSpPr>
+        <p:spPr/>
+      </p:sp>
+      <p:sp>
+        <p:nvSpPr>
+          <p:cNvPr id="3" name="Notes Placeholder 2"/>
+          <p:cNvSpPr>
+            <a:spLocks noGrp="1"/>
+          </p:cNvSpPr>
+          <p:nvPr>
+            <p:ph type="body" idx="1"/>
+          </p:nvPr>
+        </p:nvSpPr>
+        <p:spPr/>
+        <p:txBody>
+          <a:bodyPr/>
+          <a:lstStyle/>
+          <a:p>
+            <a:r>
+              <a:rPr lang="en-US" dirty="0"/>
+              <a:t>Close on the gaps. That is the part we defend most.</a:t>
+            </a:r>
+            <a:endParaRPr lang="en-US" dirty="0"/>
+          </a:p>
+        </p:txBody>
+      </p:sp>
+      <p:sp>
+        <p:nvSpPr>
+          <p:cNvPr id="4" name="Slide Number Placeholder 3"/>
+          <p:cNvSpPr>
+            <a:spLocks noGrp="1"/>
+          </p:cNvSpPr>
+          <p:nvPr>
+            <p:ph type="sldNum" sz="quarter" idx="10"/>
+          </p:nvPr>
+        </p:nvSpPr>
+        <p:spPr/>
+        <p:txBody>
+          <a:bodyPr/>
+          <a:lstStyle/>
+          <a:p>
+            <a:fld id="{F7021451-1387-4CA6-816F-3879F97B5CBC}" type="slidenum">
+              <a:rPr lang="en-US"/>
+              <a:t>19</a:t>
             </a:fld>
             <a:endParaRPr lang="en-US"/>
           </a:p>
@@ -11209,6 +11298,1094 @@
     <p:bg>
       <p:bgPr>
         <a:solidFill>
+          <a:srgbClr val="FFFFFF"/>
+        </a:solidFill>
+      </p:bgPr>
+    </p:bg>
+    <p:spTree>
+      <p:nvGrpSpPr>
+        <p:cNvPr id="1" name=""/>
+        <p:cNvGrpSpPr/>
+        <p:nvPr/>
+      </p:nvGrpSpPr>
+      <p:grpSpPr>
+        <a:xfrm>
+          <a:off x="0" y="0"/>
+          <a:ext cx="0" cy="0"/>
+          <a:chOff x="0" y="0"/>
+          <a:chExt cx="0" cy="0"/>
+        </a:xfrm>
+      </p:grpSpPr>
+      <p:sp>
+        <p:nvSpPr>
+          <p:cNvPr id="2" name="Text 0"/>
+          <p:cNvSpPr/>
+          <p:nvPr/>
+        </p:nvSpPr>
+        <p:spPr>
+          <a:xfrm>
+            <a:off x="502920" y="256032"/>
+            <a:ext cx="10972800" cy="292608"/>
+          </a:xfrm>
+          <a:prstGeom prst="rect">
+            <a:avLst/>
+          </a:prstGeom>
+          <a:noFill/>
+          <a:ln/>
+        </p:spPr>
+        <p:txBody>
+          <a:bodyPr wrap="square" rtlCol="0" anchor="ctr"/>
+          <a:lstStyle/>
+          <a:p>
+            <a:pPr indent="0" marL="0">
+              <a:buNone/>
+            </a:pPr>
+            <a:r>
+              <a:rPr lang="en-US" sz="1300" b="1" spc="200" kern="0" dirty="0">
+                <a:solidFill>
+                  <a:srgbClr val="B98A00"/>
+                </a:solidFill>
+                <a:latin typeface="Calibri" pitchFamily="34" charset="0"/>
+                <a:ea typeface="Calibri" pitchFamily="34" charset="-122"/>
+                <a:cs typeface="Calibri" pitchFamily="34" charset="-120"/>
+              </a:rPr>
+              <a:t>HONEST YARDSTICKS</a:t>
+            </a:r>
+            <a:endParaRPr lang="en-US" sz="1300" dirty="0"/>
+          </a:p>
+        </p:txBody>
+      </p:sp>
+      <p:sp>
+        <p:nvSpPr>
+          <p:cNvPr id="3" name="Text 1"/>
+          <p:cNvSpPr/>
+          <p:nvPr/>
+        </p:nvSpPr>
+        <p:spPr>
+          <a:xfrm>
+            <a:off x="502920" y="548640"/>
+            <a:ext cx="11155680" cy="822960"/>
+          </a:xfrm>
+          <a:prstGeom prst="rect">
+            <a:avLst/>
+          </a:prstGeom>
+          <a:noFill/>
+          <a:ln/>
+        </p:spPr>
+        <p:txBody>
+          <a:bodyPr wrap="square" rtlCol="0" anchor="ctr"/>
+          <a:lstStyle/>
+          <a:p>
+            <a:pPr indent="0" marL="0">
+              <a:buNone/>
+            </a:pPr>
+            <a:r>
+              <a:rPr lang="en-US" sz="4400" b="1" dirty="0">
+                <a:solidFill>
+                  <a:srgbClr val="1E2761"/>
+                </a:solidFill>
+                <a:latin typeface="Cambria" pitchFamily="34" charset="0"/>
+                <a:ea typeface="Cambria" pitchFamily="34" charset="-122"/>
+                <a:cs typeface="Cambria" pitchFamily="34" charset="-120"/>
+              </a:rPr>
+              <a:t>What we know we lack</a:t>
+            </a:r>
+            <a:endParaRPr lang="en-US" sz="4400" dirty="0"/>
+          </a:p>
+        </p:txBody>
+      </p:sp>
+      <p:sp>
+        <p:nvSpPr>
+          <p:cNvPr id="4" name="Text 2"/>
+          <p:cNvSpPr/>
+          <p:nvPr/>
+        </p:nvSpPr>
+        <p:spPr>
+          <a:xfrm>
+            <a:off x="502920" y="1371600"/>
+            <a:ext cx="11155680" cy="457200"/>
+          </a:xfrm>
+          <a:prstGeom prst="rect">
+            <a:avLst/>
+          </a:prstGeom>
+          <a:noFill/>
+          <a:ln/>
+        </p:spPr>
+        <p:txBody>
+          <a:bodyPr wrap="square" rtlCol="0" anchor="ctr"/>
+          <a:lstStyle/>
+          <a:p>
+            <a:pPr indent="0" marL="0">
+              <a:buNone/>
+            </a:pPr>
+            <a:r>
+              <a:rPr lang="en-US" sz="2000" dirty="0">
+                <a:solidFill>
+                  <a:srgbClr val="6B7280"/>
+                </a:solidFill>
+                <a:latin typeface="Calibri" pitchFamily="34" charset="0"/>
+                <a:ea typeface="Calibri" pitchFamily="34" charset="-122"/>
+                <a:cs typeface="Calibri" pitchFamily="34" charset="-120"/>
+              </a:rPr>
+              <a:t>Measured gaps first — then what we deliberately left out · full analysis: GAP-ANALYSIS.md.</a:t>
+            </a:r>
+            <a:endParaRPr lang="en-US" sz="2000" dirty="0"/>
+          </a:p>
+        </p:txBody>
+      </p:sp>
+      <p:sp>
+        <p:nvSpPr>
+          <p:cNvPr id="5" name="Shape 3"/>
+          <p:cNvSpPr/>
+          <p:nvPr/>
+        </p:nvSpPr>
+        <p:spPr>
+          <a:xfrm>
+            <a:off x="685800" y="2103120"/>
+            <a:ext cx="5349240" cy="3429000"/>
+          </a:xfrm>
+          <a:prstGeom prst="roundRect">
+            <a:avLst>
+              <a:gd name="adj" fmla="val 2667"/>
+            </a:avLst>
+          </a:prstGeom>
+          <a:solidFill>
+            <a:srgbClr val="FBF3E2"/>
+          </a:solidFill>
+          <a:ln w="15875">
+            <a:solidFill>
+              <a:srgbClr val="B98A00"/>
+            </a:solidFill>
+            <a:prstDash val="solid"/>
+          </a:ln>
+        </p:spPr>
+      </p:sp>
+      <p:sp>
+        <p:nvSpPr>
+          <p:cNvPr id="6" name="Text 4"/>
+          <p:cNvSpPr/>
+          <p:nvPr/>
+        </p:nvSpPr>
+        <p:spPr>
+          <a:xfrm>
+            <a:off x="960120" y="2286000"/>
+            <a:ext cx="4800600" cy="365760"/>
+          </a:xfrm>
+          <a:prstGeom prst="rect">
+            <a:avLst/>
+          </a:prstGeom>
+          <a:noFill/>
+          <a:ln/>
+        </p:spPr>
+        <p:txBody>
+          <a:bodyPr wrap="square" rtlCol="0" anchor="ctr"/>
+          <a:lstStyle/>
+          <a:p>
+            <a:pPr indent="0" marL="0">
+              <a:buNone/>
+            </a:pPr>
+            <a:r>
+              <a:rPr lang="en-US" sz="1700" b="1" dirty="0">
+                <a:solidFill>
+                  <a:srgbClr val="7A5C00"/>
+                </a:solidFill>
+                <a:latin typeface="Calibri" pitchFamily="34" charset="0"/>
+                <a:ea typeface="Calibri" pitchFamily="34" charset="-122"/>
+                <a:cs typeface="Calibri" pitchFamily="34" charset="-120"/>
+              </a:rPr>
+              <a:t>MEASURED GAPS</a:t>
+            </a:r>
+            <a:endParaRPr lang="en-US" sz="1700" dirty="0"/>
+          </a:p>
+        </p:txBody>
+      </p:sp>
+      <p:sp>
+        <p:nvSpPr>
+          <p:cNvPr id="7" name="Text 5"/>
+          <p:cNvSpPr/>
+          <p:nvPr/>
+        </p:nvSpPr>
+        <p:spPr>
+          <a:xfrm>
+            <a:off x="960120" y="2670048"/>
+            <a:ext cx="1234440" cy="237744"/>
+          </a:xfrm>
+          <a:prstGeom prst="rect">
+            <a:avLst/>
+          </a:prstGeom>
+          <a:noFill/>
+          <a:ln/>
+        </p:spPr>
+        <p:txBody>
+          <a:bodyPr wrap="square" lIns="0" tIns="0" rIns="0" bIns="0" rtlCol="0" anchor="ctr"/>
+          <a:lstStyle/>
+          <a:p>
+            <a:pPr indent="0" marL="0">
+              <a:buNone/>
+            </a:pPr>
+            <a:r>
+              <a:rPr lang="en-US" sz="1100" b="1" dirty="0">
+                <a:solidFill>
+                  <a:srgbClr val="B91C1C"/>
+                </a:solidFill>
+                <a:latin typeface="Calibri" pitchFamily="34" charset="0"/>
+                <a:ea typeface="Calibri" pitchFamily="34" charset="-122"/>
+                <a:cs typeface="Calibri" pitchFamily="34" charset="-120"/>
+              </a:rPr>
+              <a:t>COST · HIGH</a:t>
+            </a:r>
+            <a:endParaRPr lang="en-US" sz="1100" dirty="0"/>
+          </a:p>
+        </p:txBody>
+      </p:sp>
+      <p:sp>
+        <p:nvSpPr>
+          <p:cNvPr id="8" name="Text 6"/>
+          <p:cNvSpPr/>
+          <p:nvPr/>
+        </p:nvSpPr>
+        <p:spPr>
+          <a:xfrm>
+            <a:off x="2240280" y="2670048"/>
+            <a:ext cx="3337560" cy="530352"/>
+          </a:xfrm>
+          <a:prstGeom prst="rect">
+            <a:avLst/>
+          </a:prstGeom>
+          <a:noFill/>
+          <a:ln/>
+        </p:spPr>
+        <p:txBody>
+          <a:bodyPr wrap="square" lIns="0" tIns="0" rIns="0" bIns="0" rtlCol="0" anchor="ctr"/>
+          <a:lstStyle/>
+          <a:p>
+            <a:pPr indent="0" marL="0">
+              <a:buNone/>
+            </a:pPr>
+            <a:r>
+              <a:rPr lang="en-US" sz="1100" dirty="0">
+                <a:solidFill>
+                  <a:srgbClr val="1F2937"/>
+                </a:solidFill>
+                <a:latin typeface="Calibri" pitchFamily="34" charset="0"/>
+                <a:ea typeface="Calibri" pitchFamily="34" charset="-122"/>
+                <a:cs typeface="Calibri" pitchFamily="34" charset="-120"/>
+              </a:rPr>
+              <a:t>No trusted metering — cost basis unknown, cache reads inflate A+wave 5–8×; no per-task budget; a wrong-model probe ($0.17/turn) slipped through.</a:t>
+            </a:r>
+            <a:endParaRPr lang="en-US" sz="1100" dirty="0"/>
+          </a:p>
+        </p:txBody>
+      </p:sp>
+      <p:sp>
+        <p:nvSpPr>
+          <p:cNvPr id="9" name="Text 7"/>
+          <p:cNvSpPr/>
+          <p:nvPr/>
+        </p:nvSpPr>
+        <p:spPr>
+          <a:xfrm>
+            <a:off x="960120" y="3236976"/>
+            <a:ext cx="1234440" cy="237744"/>
+          </a:xfrm>
+          <a:prstGeom prst="rect">
+            <a:avLst/>
+          </a:prstGeom>
+          <a:noFill/>
+          <a:ln/>
+        </p:spPr>
+        <p:txBody>
+          <a:bodyPr wrap="square" lIns="0" tIns="0" rIns="0" bIns="0" rtlCol="0" anchor="ctr"/>
+          <a:lstStyle/>
+          <a:p>
+            <a:pPr indent="0" marL="0">
+              <a:buNone/>
+            </a:pPr>
+            <a:r>
+              <a:rPr lang="en-US" sz="1100" b="1" dirty="0">
+                <a:solidFill>
+                  <a:srgbClr val="B91C1C"/>
+                </a:solidFill>
+                <a:latin typeface="Calibri" pitchFamily="34" charset="0"/>
+                <a:ea typeface="Calibri" pitchFamily="34" charset="-122"/>
+                <a:cs typeface="Calibri" pitchFamily="34" charset="-120"/>
+              </a:rPr>
+              <a:t>GUARDRAILS · HIGH</a:t>
+            </a:r>
+            <a:endParaRPr lang="en-US" sz="1100" dirty="0"/>
+          </a:p>
+        </p:txBody>
+      </p:sp>
+      <p:sp>
+        <p:nvSpPr>
+          <p:cNvPr id="10" name="Text 8"/>
+          <p:cNvSpPr/>
+          <p:nvPr/>
+        </p:nvSpPr>
+        <p:spPr>
+          <a:xfrm>
+            <a:off x="2240280" y="3236976"/>
+            <a:ext cx="3337560" cy="530352"/>
+          </a:xfrm>
+          <a:prstGeom prst="rect">
+            <a:avLst/>
+          </a:prstGeom>
+          <a:noFill/>
+          <a:ln/>
+        </p:spPr>
+        <p:txBody>
+          <a:bodyPr wrap="square" lIns="0" tIns="0" rIns="0" bIns="0" rtlCol="0" anchor="ctr"/>
+          <a:lstStyle/>
+          <a:p>
+            <a:pPr indent="0" marL="0">
+              <a:buNone/>
+            </a:pPr>
+            <a:r>
+              <a:rPr lang="en-US" sz="1100" dirty="0">
+                <a:solidFill>
+                  <a:srgbClr val="1F2937"/>
+                </a:solidFill>
+                <a:latin typeface="Calibri" pitchFamily="34" charset="0"/>
+                <a:ea typeface="Calibri" pitchFamily="34" charset="-122"/>
+                <a:cs typeface="Calibri" pitchFamily="34" charset="-120"/>
+              </a:rPr>
+              <a:t>Advisory, not mechanical — R4 pushed a fragile-file change through an operator approval; no CI check enforces plan-vs-PR files.</a:t>
+            </a:r>
+            <a:endParaRPr lang="en-US" sz="1100" dirty="0"/>
+          </a:p>
+        </p:txBody>
+      </p:sp>
+      <p:sp>
+        <p:nvSpPr>
+          <p:cNvPr id="11" name="Text 9"/>
+          <p:cNvSpPr/>
+          <p:nvPr/>
+        </p:nvSpPr>
+        <p:spPr>
+          <a:xfrm>
+            <a:off x="960120" y="3803904"/>
+            <a:ext cx="1234440" cy="237744"/>
+          </a:xfrm>
+          <a:prstGeom prst="rect">
+            <a:avLst/>
+          </a:prstGeom>
+          <a:noFill/>
+          <a:ln/>
+        </p:spPr>
+        <p:txBody>
+          <a:bodyPr wrap="square" lIns="0" tIns="0" rIns="0" bIns="0" rtlCol="0" anchor="ctr"/>
+          <a:lstStyle/>
+          <a:p>
+            <a:pPr indent="0" marL="0">
+              <a:buNone/>
+            </a:pPr>
+            <a:r>
+              <a:rPr lang="en-US" sz="1100" b="1" dirty="0">
+                <a:solidFill>
+                  <a:srgbClr val="B91C1C"/>
+                </a:solidFill>
+                <a:latin typeface="Calibri" pitchFamily="34" charset="0"/>
+                <a:ea typeface="Calibri" pitchFamily="34" charset="-122"/>
+                <a:cs typeface="Calibri" pitchFamily="34" charset="-120"/>
+              </a:rPr>
+              <a:t>BENCH · MED</a:t>
+            </a:r>
+            <a:endParaRPr lang="en-US" sz="1100" dirty="0"/>
+          </a:p>
+        </p:txBody>
+      </p:sp>
+      <p:sp>
+        <p:nvSpPr>
+          <p:cNvPr id="12" name="Text 10"/>
+          <p:cNvSpPr/>
+          <p:nvPr/>
+        </p:nvSpPr>
+        <p:spPr>
+          <a:xfrm>
+            <a:off x="2240280" y="3803904"/>
+            <a:ext cx="3337560" cy="530352"/>
+          </a:xfrm>
+          <a:prstGeom prst="rect">
+            <a:avLst/>
+          </a:prstGeom>
+          <a:noFill/>
+          <a:ln/>
+        </p:spPr>
+        <p:txBody>
+          <a:bodyPr wrap="square" lIns="0" tIns="0" rIns="0" bIns="0" rtlCol="0" anchor="ctr"/>
+          <a:lstStyle/>
+          <a:p>
+            <a:pPr indent="0" marL="0">
+              <a:buNone/>
+            </a:pPr>
+            <a:r>
+              <a:rPr lang="en-US" sz="1100" dirty="0">
+                <a:solidFill>
+                  <a:srgbClr val="1F2937"/>
+                </a:solidFill>
+                <a:latin typeface="Calibri" pitchFamily="34" charset="0"/>
+                <a:ea typeface="Calibri" pitchFamily="34" charset="-122"/>
+                <a:cs typeface="Calibri" pitchFamily="34" charset="-120"/>
+              </a:rPr>
+              <a:t>Every cell is N=1 — variance unmeasured; the 4.2× headline is one run.</a:t>
+            </a:r>
+            <a:endParaRPr lang="en-US" sz="1100" dirty="0"/>
+          </a:p>
+        </p:txBody>
+      </p:sp>
+      <p:sp>
+        <p:nvSpPr>
+          <p:cNvPr id="13" name="Text 11"/>
+          <p:cNvSpPr/>
+          <p:nvPr/>
+        </p:nvSpPr>
+        <p:spPr>
+          <a:xfrm>
+            <a:off x="960120" y="4370832"/>
+            <a:ext cx="1234440" cy="237744"/>
+          </a:xfrm>
+          <a:prstGeom prst="rect">
+            <a:avLst/>
+          </a:prstGeom>
+          <a:noFill/>
+          <a:ln/>
+        </p:spPr>
+        <p:txBody>
+          <a:bodyPr wrap="square" lIns="0" tIns="0" rIns="0" bIns="0" rtlCol="0" anchor="ctr"/>
+          <a:lstStyle/>
+          <a:p>
+            <a:pPr indent="0" marL="0">
+              <a:buNone/>
+            </a:pPr>
+            <a:r>
+              <a:rPr lang="en-US" sz="1100" b="1" dirty="0">
+                <a:solidFill>
+                  <a:srgbClr val="B91C1C"/>
+                </a:solidFill>
+                <a:latin typeface="Calibri" pitchFamily="34" charset="0"/>
+                <a:ea typeface="Calibri" pitchFamily="34" charset="-122"/>
+                <a:cs typeface="Calibri" pitchFamily="34" charset="-120"/>
+              </a:rPr>
+              <a:t>DEVOPS · MED</a:t>
+            </a:r>
+            <a:endParaRPr lang="en-US" sz="1100" dirty="0"/>
+          </a:p>
+        </p:txBody>
+      </p:sp>
+      <p:sp>
+        <p:nvSpPr>
+          <p:cNvPr id="14" name="Text 12"/>
+          <p:cNvSpPr/>
+          <p:nvPr/>
+        </p:nvSpPr>
+        <p:spPr>
+          <a:xfrm>
+            <a:off x="2240280" y="4370832"/>
+            <a:ext cx="3337560" cy="530352"/>
+          </a:xfrm>
+          <a:prstGeom prst="rect">
+            <a:avLst/>
+          </a:prstGeom>
+          <a:noFill/>
+          <a:ln/>
+        </p:spPr>
+        <p:txBody>
+          <a:bodyPr wrap="square" lIns="0" tIns="0" rIns="0" bIns="0" rtlCol="0" anchor="ctr"/>
+          <a:lstStyle/>
+          <a:p>
+            <a:pPr indent="0" marL="0">
+              <a:buNone/>
+            </a:pPr>
+            <a:r>
+              <a:rPr lang="en-US" sz="1100" dirty="0">
+                <a:solidFill>
+                  <a:srgbClr val="1F2937"/>
+                </a:solidFill>
+                <a:latin typeface="Calibri" pitchFamily="34" charset="0"/>
+                <a:ea typeface="Calibri" pitchFamily="34" charset="-122"/>
+                <a:cs typeface="Calibri" pitchFamily="34" charset="-120"/>
+              </a:rPr>
+              <a:t>CI/Vercel/rollback lanes never fire offline — live-tested only, no regression cell.</a:t>
+            </a:r>
+            <a:endParaRPr lang="en-US" sz="1100" dirty="0"/>
+          </a:p>
+        </p:txBody>
+      </p:sp>
+      <p:sp>
+        <p:nvSpPr>
+          <p:cNvPr id="15" name="Text 13"/>
+          <p:cNvSpPr/>
+          <p:nvPr/>
+        </p:nvSpPr>
+        <p:spPr>
+          <a:xfrm>
+            <a:off x="960120" y="4937760"/>
+            <a:ext cx="1234440" cy="237744"/>
+          </a:xfrm>
+          <a:prstGeom prst="rect">
+            <a:avLst/>
+          </a:prstGeom>
+          <a:noFill/>
+          <a:ln/>
+        </p:spPr>
+        <p:txBody>
+          <a:bodyPr wrap="square" lIns="0" tIns="0" rIns="0" bIns="0" rtlCol="0" anchor="ctr"/>
+          <a:lstStyle/>
+          <a:p>
+            <a:pPr indent="0" marL="0">
+              <a:buNone/>
+            </a:pPr>
+            <a:r>
+              <a:rPr lang="en-US" sz="1100" b="1" dirty="0">
+                <a:solidFill>
+                  <a:srgbClr val="B91C1C"/>
+                </a:solidFill>
+                <a:latin typeface="Calibri" pitchFamily="34" charset="0"/>
+                <a:ea typeface="Calibri" pitchFamily="34" charset="-122"/>
+                <a:cs typeface="Calibri" pitchFamily="34" charset="-120"/>
+              </a:rPr>
+              <a:t>HUMAN-HOUR · MED</a:t>
+            </a:r>
+            <a:endParaRPr lang="en-US" sz="1100" dirty="0"/>
+          </a:p>
+        </p:txBody>
+      </p:sp>
+      <p:sp>
+        <p:nvSpPr>
+          <p:cNvPr id="16" name="Text 14"/>
+          <p:cNvSpPr/>
+          <p:nvPr/>
+        </p:nvSpPr>
+        <p:spPr>
+          <a:xfrm>
+            <a:off x="2240280" y="4937760"/>
+            <a:ext cx="3337560" cy="530352"/>
+          </a:xfrm>
+          <a:prstGeom prst="rect">
+            <a:avLst/>
+          </a:prstGeom>
+          <a:noFill/>
+          <a:ln/>
+        </p:spPr>
+        <p:txBody>
+          <a:bodyPr wrap="square" lIns="0" tIns="0" rIns="0" bIns="0" rtlCol="0" anchor="ctr"/>
+          <a:lstStyle/>
+          <a:p>
+            <a:pPr indent="0" marL="0">
+              <a:buNone/>
+            </a:pPr>
+            <a:r>
+              <a:rPr lang="en-US" sz="1100" dirty="0">
+                <a:solidFill>
+                  <a:srgbClr val="1F2937"/>
+                </a:solidFill>
+                <a:latin typeface="Calibri" pitchFamily="34" charset="0"/>
+                <a:ea typeface="Calibri" pitchFamily="34" charset="-122"/>
+                <a:cs typeface="Calibri" pitchFamily="34" charset="-120"/>
+              </a:rPr>
+              <a:t>Method exists (hooks + PR windows) — public evidence still pending.</a:t>
+            </a:r>
+            <a:endParaRPr lang="en-US" sz="1100" dirty="0"/>
+          </a:p>
+        </p:txBody>
+      </p:sp>
+      <p:sp>
+        <p:nvSpPr>
+          <p:cNvPr id="17" name="Shape 15"/>
+          <p:cNvSpPr/>
+          <p:nvPr/>
+        </p:nvSpPr>
+        <p:spPr>
+          <a:xfrm>
+            <a:off x="6263640" y="2103120"/>
+            <a:ext cx="5257800" cy="3429000"/>
+          </a:xfrm>
+          <a:prstGeom prst="roundRect">
+            <a:avLst>
+              <a:gd name="adj" fmla="val 2667"/>
+            </a:avLst>
+          </a:prstGeom>
+          <a:solidFill>
+            <a:srgbClr val="EAF5EC"/>
+          </a:solidFill>
+          <a:ln w="15875">
+            <a:solidFill>
+              <a:srgbClr val="2E7D32"/>
+            </a:solidFill>
+            <a:prstDash val="solid"/>
+          </a:ln>
+        </p:spPr>
+      </p:sp>
+      <p:sp>
+        <p:nvSpPr>
+          <p:cNvPr id="18" name="Text 16"/>
+          <p:cNvSpPr/>
+          <p:nvPr/>
+        </p:nvSpPr>
+        <p:spPr>
+          <a:xfrm>
+            <a:off x="6537960" y="2286000"/>
+            <a:ext cx="4709160" cy="365760"/>
+          </a:xfrm>
+          <a:prstGeom prst="rect">
+            <a:avLst/>
+          </a:prstGeom>
+          <a:noFill/>
+          <a:ln/>
+        </p:spPr>
+        <p:txBody>
+          <a:bodyPr wrap="square" rtlCol="0" anchor="ctr"/>
+          <a:lstStyle/>
+          <a:p>
+            <a:pPr indent="0" marL="0">
+              <a:buNone/>
+            </a:pPr>
+            <a:r>
+              <a:rPr lang="en-US" sz="1700" b="1" dirty="0">
+                <a:solidFill>
+                  <a:srgbClr val="1B5E20"/>
+                </a:solidFill>
+                <a:latin typeface="Calibri" pitchFamily="34" charset="0"/>
+                <a:ea typeface="Calibri" pitchFamily="34" charset="-122"/>
+                <a:cs typeface="Calibri" pitchFamily="34" charset="-120"/>
+              </a:rPr>
+              <a:t>DELIBERATELY NOT INCLUDED</a:t>
+            </a:r>
+            <a:endParaRPr lang="en-US" sz="1700" dirty="0"/>
+          </a:p>
+        </p:txBody>
+      </p:sp>
+      <p:sp>
+        <p:nvSpPr>
+          <p:cNvPr id="19" name="Text 17"/>
+          <p:cNvSpPr/>
+          <p:nvPr/>
+        </p:nvSpPr>
+        <p:spPr>
+          <a:xfrm>
+            <a:off x="6537960" y="2743200"/>
+            <a:ext cx="4709160" cy="310896"/>
+          </a:xfrm>
+          <a:prstGeom prst="rect">
+            <a:avLst/>
+          </a:prstGeom>
+          <a:noFill/>
+          <a:ln/>
+        </p:spPr>
+        <p:txBody>
+          <a:bodyPr wrap="square" lIns="0" tIns="0" rIns="0" bIns="0" rtlCol="0" anchor="ctr"/>
+          <a:lstStyle/>
+          <a:p>
+            <a:pPr indent="0" marL="0">
+              <a:buNone/>
+            </a:pPr>
+            <a:r>
+              <a:rPr lang="en-US" sz="1200" dirty="0">
+                <a:solidFill>
+                  <a:srgbClr val="1F2937"/>
+                </a:solidFill>
+                <a:latin typeface="Calibri" pitchFamily="34" charset="0"/>
+                <a:ea typeface="Calibri" pitchFamily="34" charset="-122"/>
+                <a:cs typeface="Calibri" pitchFamily="34" charset="-120"/>
+              </a:rPr>
+              <a:t>• No hooks / auto-runtime / silent telemetry — v1 lesson</a:t>
+            </a:r>
+            <a:endParaRPr lang="en-US" sz="1200" dirty="0"/>
+          </a:p>
+        </p:txBody>
+      </p:sp>
+      <p:sp>
+        <p:nvSpPr>
+          <p:cNvPr id="20" name="Text 18"/>
+          <p:cNvSpPr/>
+          <p:nvPr/>
+        </p:nvSpPr>
+        <p:spPr>
+          <a:xfrm>
+            <a:off x="6537960" y="3090672"/>
+            <a:ext cx="4709160" cy="310896"/>
+          </a:xfrm>
+          <a:prstGeom prst="rect">
+            <a:avLst/>
+          </a:prstGeom>
+          <a:noFill/>
+          <a:ln/>
+        </p:spPr>
+        <p:txBody>
+          <a:bodyPr wrap="square" lIns="0" tIns="0" rIns="0" bIns="0" rtlCol="0" anchor="ctr"/>
+          <a:lstStyle/>
+          <a:p>
+            <a:pPr indent="0" marL="0">
+              <a:buNone/>
+            </a:pPr>
+            <a:r>
+              <a:rPr lang="en-US" sz="1200" dirty="0">
+                <a:solidFill>
+                  <a:srgbClr val="1F2937"/>
+                </a:solidFill>
+                <a:latin typeface="Calibri" pitchFamily="34" charset="0"/>
+                <a:ea typeface="Calibri" pitchFamily="34" charset="-122"/>
+                <a:cs typeface="Calibri" pitchFamily="34" charset="-120"/>
+              </a:rPr>
+              <a:t>• No auto-approve — every gate is a human decision</a:t>
+            </a:r>
+            <a:endParaRPr lang="en-US" sz="1200" dirty="0"/>
+          </a:p>
+        </p:txBody>
+      </p:sp>
+      <p:sp>
+        <p:nvSpPr>
+          <p:cNvPr id="21" name="Text 19"/>
+          <p:cNvSpPr/>
+          <p:nvPr/>
+        </p:nvSpPr>
+        <p:spPr>
+          <a:xfrm>
+            <a:off x="6537960" y="3438144"/>
+            <a:ext cx="4709160" cy="310896"/>
+          </a:xfrm>
+          <a:prstGeom prst="rect">
+            <a:avLst/>
+          </a:prstGeom>
+          <a:noFill/>
+          <a:ln/>
+        </p:spPr>
+        <p:txBody>
+          <a:bodyPr wrap="square" lIns="0" tIns="0" rIns="0" bIns="0" rtlCol="0" anchor="ctr"/>
+          <a:lstStyle/>
+          <a:p>
+            <a:pPr indent="0" marL="0">
+              <a:buNone/>
+            </a:pPr>
+            <a:r>
+              <a:rPr lang="en-US" sz="1200" dirty="0">
+                <a:solidFill>
+                  <a:srgbClr val="1F2937"/>
+                </a:solidFill>
+                <a:latin typeface="Calibri" pitchFamily="34" charset="0"/>
+                <a:ea typeface="Calibri" pitchFamily="34" charset="-122"/>
+                <a:cs typeface="Calibri" pitchFamily="34" charset="-120"/>
+              </a:rPr>
+              <a:t>• No marketing agent lanes — removed v2.6.0 (unmeasured)</a:t>
+            </a:r>
+            <a:endParaRPr lang="en-US" sz="1200" dirty="0"/>
+          </a:p>
+        </p:txBody>
+      </p:sp>
+      <p:sp>
+        <p:nvSpPr>
+          <p:cNvPr id="22" name="Text 20"/>
+          <p:cNvSpPr/>
+          <p:nvPr/>
+        </p:nvSpPr>
+        <p:spPr>
+          <a:xfrm>
+            <a:off x="6537960" y="3785616"/>
+            <a:ext cx="4709160" cy="310896"/>
+          </a:xfrm>
+          <a:prstGeom prst="rect">
+            <a:avLst/>
+          </a:prstGeom>
+          <a:noFill/>
+          <a:ln/>
+        </p:spPr>
+        <p:txBody>
+          <a:bodyPr wrap="square" lIns="0" tIns="0" rIns="0" bIns="0" rtlCol="0" anchor="ctr"/>
+          <a:lstStyle/>
+          <a:p>
+            <a:pPr indent="0" marL="0">
+              <a:buNone/>
+            </a:pPr>
+            <a:r>
+              <a:rPr lang="en-US" sz="1200" dirty="0">
+                <a:solidFill>
+                  <a:srgbClr val="1F2937"/>
+                </a:solidFill>
+                <a:latin typeface="Calibri" pitchFamily="34" charset="0"/>
+                <a:ea typeface="Calibri" pitchFamily="34" charset="-122"/>
+                <a:cs typeface="Calibri" pitchFamily="34" charset="-120"/>
+              </a:rPr>
+              <a:t>• No permissions grants — Bash(*) killed v1</a:t>
+            </a:r>
+            <a:endParaRPr lang="en-US" sz="1200" dirty="0"/>
+          </a:p>
+        </p:txBody>
+      </p:sp>
+      <p:sp>
+        <p:nvSpPr>
+          <p:cNvPr id="23" name="Text 21"/>
+          <p:cNvSpPr/>
+          <p:nvPr/>
+        </p:nvSpPr>
+        <p:spPr>
+          <a:xfrm>
+            <a:off x="6537960" y="4133088"/>
+            <a:ext cx="4709160" cy="310896"/>
+          </a:xfrm>
+          <a:prstGeom prst="rect">
+            <a:avLst/>
+          </a:prstGeom>
+          <a:noFill/>
+          <a:ln/>
+        </p:spPr>
+        <p:txBody>
+          <a:bodyPr wrap="square" lIns="0" tIns="0" rIns="0" bIns="0" rtlCol="0" anchor="ctr"/>
+          <a:lstStyle/>
+          <a:p>
+            <a:pPr indent="0" marL="0">
+              <a:buNone/>
+            </a:pPr>
+            <a:r>
+              <a:rPr lang="en-US" sz="1200" dirty="0">
+                <a:solidFill>
+                  <a:srgbClr val="1F2937"/>
+                </a:solidFill>
+                <a:latin typeface="Calibri" pitchFamily="34" charset="0"/>
+                <a:ea typeface="Calibri" pitchFamily="34" charset="-122"/>
+                <a:cs typeface="Calibri" pitchFamily="34" charset="-120"/>
+              </a:rPr>
+              <a:t>• No SWE-bench floor — documented trade-off</a:t>
+            </a:r>
+            <a:endParaRPr lang="en-US" sz="1200" dirty="0"/>
+          </a:p>
+        </p:txBody>
+      </p:sp>
+      <p:sp>
+        <p:nvSpPr>
+          <p:cNvPr id="24" name="Text 22"/>
+          <p:cNvSpPr/>
+          <p:nvPr/>
+        </p:nvSpPr>
+        <p:spPr>
+          <a:xfrm>
+            <a:off x="6537960" y="4480560"/>
+            <a:ext cx="4709160" cy="310896"/>
+          </a:xfrm>
+          <a:prstGeom prst="rect">
+            <a:avLst/>
+          </a:prstGeom>
+          <a:noFill/>
+          <a:ln/>
+        </p:spPr>
+        <p:txBody>
+          <a:bodyPr wrap="square" lIns="0" tIns="0" rIns="0" bIns="0" rtlCol="0" anchor="ctr"/>
+          <a:lstStyle/>
+          <a:p>
+            <a:pPr indent="0" marL="0">
+              <a:buNone/>
+            </a:pPr>
+            <a:r>
+              <a:rPr lang="en-US" sz="1200" dirty="0">
+                <a:solidFill>
+                  <a:srgbClr val="1F2937"/>
+                </a:solidFill>
+                <a:latin typeface="Calibri" pitchFamily="34" charset="0"/>
+                <a:ea typeface="Calibri" pitchFamily="34" charset="-122"/>
+                <a:cs typeface="Calibri" pitchFamily="34" charset="-120"/>
+              </a:rPr>
+              <a:t>• No global memory — repo artifacts ARE the memory</a:t>
+            </a:r>
+            <a:endParaRPr lang="en-US" sz="1200" dirty="0"/>
+          </a:p>
+        </p:txBody>
+      </p:sp>
+      <p:sp>
+        <p:nvSpPr>
+          <p:cNvPr id="25" name="Text 23"/>
+          <p:cNvSpPr/>
+          <p:nvPr/>
+        </p:nvSpPr>
+        <p:spPr>
+          <a:xfrm>
+            <a:off x="6537960" y="4828032"/>
+            <a:ext cx="4709160" cy="310896"/>
+          </a:xfrm>
+          <a:prstGeom prst="rect">
+            <a:avLst/>
+          </a:prstGeom>
+          <a:noFill/>
+          <a:ln/>
+        </p:spPr>
+        <p:txBody>
+          <a:bodyPr wrap="square" lIns="0" tIns="0" rIns="0" bIns="0" rtlCol="0" anchor="ctr"/>
+          <a:lstStyle/>
+          <a:p>
+            <a:pPr indent="0" marL="0">
+              <a:buNone/>
+            </a:pPr>
+            <a:r>
+              <a:rPr lang="en-US" sz="1200" dirty="0">
+                <a:solidFill>
+                  <a:srgbClr val="1F2937"/>
+                </a:solidFill>
+                <a:latin typeface="Calibri" pitchFamily="34" charset="0"/>
+                <a:ea typeface="Calibri" pitchFamily="34" charset="-122"/>
+                <a:cs typeface="Calibri" pitchFamily="34" charset="-120"/>
+              </a:rPr>
+              <a:t>• No wave loop in canonical — negative in headless proxy</a:t>
+            </a:r>
+            <a:endParaRPr lang="en-US" sz="1200" dirty="0"/>
+          </a:p>
+        </p:txBody>
+      </p:sp>
+      <p:sp>
+        <p:nvSpPr>
+          <p:cNvPr id="26" name="Text 24"/>
+          <p:cNvSpPr/>
+          <p:nvPr/>
+        </p:nvSpPr>
+        <p:spPr>
+          <a:xfrm>
+            <a:off x="685800" y="5760720"/>
+            <a:ext cx="10835640" cy="457200"/>
+          </a:xfrm>
+          <a:prstGeom prst="rect">
+            <a:avLst/>
+          </a:prstGeom>
+          <a:noFill/>
+          <a:ln/>
+        </p:spPr>
+        <p:txBody>
+          <a:bodyPr wrap="square" rtlCol="0" anchor="ctr"/>
+          <a:lstStyle/>
+          <a:p>
+            <a:pPr indent="0" marL="0">
+              <a:buNone/>
+            </a:pPr>
+            <a:r>
+              <a:rPr lang="en-US" sz="1400" b="1" dirty="0">
+                <a:solidFill>
+                  <a:srgbClr val="1E2761"/>
+                </a:solidFill>
+                <a:latin typeface="Calibri" pitchFamily="34" charset="0"/>
+                <a:ea typeface="Calibri" pitchFamily="34" charset="-122"/>
+                <a:cs typeface="Calibri" pitchFamily="34" charset="-120"/>
+              </a:rPr>
+              <a:t>FOCUS LIST · next: trusted cost loop (pin check + baseline + budgets) · CI plan-vs-PR + fragile-file enforcement · headline cells N≥3 · devops staging smoke · second-model matrix.</a:t>
+            </a:r>
+            <a:endParaRPr lang="en-US" sz="1400" dirty="0"/>
+          </a:p>
+        </p:txBody>
+      </p:sp>
+      <p:sp>
+        <p:nvSpPr>
+          <p:cNvPr id="27" name="Shape 25"/>
+          <p:cNvSpPr/>
+          <p:nvPr/>
+        </p:nvSpPr>
+        <p:spPr>
+          <a:xfrm>
+            <a:off x="685800" y="6263640"/>
+            <a:ext cx="987552" cy="292608"/>
+          </a:xfrm>
+          <a:prstGeom prst="roundRect">
+            <a:avLst>
+              <a:gd name="adj" fmla="val 50000"/>
+            </a:avLst>
+          </a:prstGeom>
+          <a:solidFill>
+            <a:srgbClr val="2E7D32"/>
+          </a:solidFill>
+          <a:ln w="12700">
+            <a:solidFill>
+              <a:srgbClr val="2E7D32"/>
+            </a:solidFill>
+            <a:prstDash val="solid"/>
+          </a:ln>
+        </p:spPr>
+      </p:sp>
+      <p:sp>
+        <p:nvSpPr>
+          <p:cNvPr id="28" name="Text 26"/>
+          <p:cNvSpPr/>
+          <p:nvPr/>
+        </p:nvSpPr>
+        <p:spPr>
+          <a:xfrm>
+            <a:off x="685800" y="6236208"/>
+            <a:ext cx="987552" cy="292608"/>
+          </a:xfrm>
+          <a:prstGeom prst="rect">
+            <a:avLst/>
+          </a:prstGeom>
+          <a:noFill/>
+          <a:ln/>
+        </p:spPr>
+        <p:txBody>
+          <a:bodyPr wrap="square" lIns="0" tIns="0" rIns="0" bIns="0" rtlCol="0" anchor="ctr"/>
+          <a:lstStyle/>
+          <a:p>
+            <a:pPr algn="ctr" indent="0" marL="0">
+              <a:buNone/>
+            </a:pPr>
+            <a:r>
+              <a:rPr lang="en-US" sz="1100" b="1" dirty="0">
+                <a:solidFill>
+                  <a:srgbClr val="FFFFFF"/>
+                </a:solidFill>
+                <a:latin typeface="Calibri" pitchFamily="34" charset="0"/>
+                <a:ea typeface="Calibri" pitchFamily="34" charset="-122"/>
+                <a:cs typeface="Calibri" pitchFamily="34" charset="-120"/>
+              </a:rPr>
+              <a:t>VERIFIED</a:t>
+            </a:r>
+            <a:endParaRPr lang="en-US" sz="1100" dirty="0"/>
+          </a:p>
+        </p:txBody>
+      </p:sp>
+      <p:sp>
+        <p:nvSpPr>
+          <p:cNvPr id="29" name="Text 27"/>
+          <p:cNvSpPr/>
+          <p:nvPr/>
+        </p:nvSpPr>
+        <p:spPr>
+          <a:xfrm>
+            <a:off x="2286000" y="6291072"/>
+            <a:ext cx="9052560" cy="320040"/>
+          </a:xfrm>
+          <a:prstGeom prst="rect">
+            <a:avLst/>
+          </a:prstGeom>
+          <a:noFill/>
+          <a:ln/>
+        </p:spPr>
+        <p:txBody>
+          <a:bodyPr wrap="square" rtlCol="0" anchor="ctr"/>
+          <a:lstStyle/>
+          <a:p>
+            <a:pPr indent="0" marL="0">
+              <a:buNone/>
+            </a:pPr>
+            <a:r>
+              <a:rPr lang="en-US" sz="1200" i="1" dirty="0">
+                <a:solidFill>
+                  <a:srgbClr val="6B7280"/>
+                </a:solidFill>
+                <a:latin typeface="Calibri" pitchFamily="34" charset="0"/>
+                <a:ea typeface="Calibri" pitchFamily="34" charset="-122"/>
+                <a:cs typeface="Calibri" pitchFamily="34" charset="-120"/>
+              </a:rPr>
+              <a:t>Gap list is provable; exclusions are design choices, not defects — both are in GAP-ANALYSIS.md.</a:t>
+            </a:r>
+            <a:endParaRPr lang="en-US" sz="1200" dirty="0"/>
+          </a:p>
+        </p:txBody>
+      </p:sp>
+    </p:spTree>
+  </p:cSld>
+  <p:clrMapOvr>
+    <a:masterClrMapping/>
+  </p:clrMapOvr>
+</p:sld>
+</file>
+
+<file path=ppt/slides/slide19.xml><?xml version="1.0" encoding="utf-8"?>
+<p:sld xmlns:a="http://schemas.openxmlformats.org/drawingml/2006/main" xmlns:r="http://schemas.openxmlformats.org/officeDocument/2006/relationships" xmlns:p="http://schemas.openxmlformats.org/presentationml/2006/main">
+  <p:cSld name="Slide 19">
+    <p:bg>
+      <p:bgPr>
+        <a:solidFill>
           <a:srgbClr val="1E2761"/>
         </a:solidFill>
       </p:bgPr>
@@ -11469,7 +12646,7 @@
                 <a:ea typeface="Calibri" pitchFamily="34" charset="-122"/>
                 <a:cs typeface="Calibri" pitchFamily="34" charset="-120"/>
               </a:rPr>
-              <a:t>Next: token budget baseline · SWE-bench-style floor check · telemetry on live traffic.</a:t>
+              <a:t>Next: trusted cost loop · CI plan-vs-PR enforcement · N≥3 headline cells · devops staging smoke · second-model matrix.</a:t>
             </a:r>
             <a:endParaRPr lang="en-US" sz="2000" dirty="0"/>
           </a:p>

</xml_diff>

<commit_message>
evidence: raw artifact bundle (12 greenfield project folders + gate logs + session JSONs + tree captures for adopt/scaffold/A-vs-B, validate.py reruns all gates — 12/12 claims reproduce, manifest + README); deck links slide gains evidence row
</commit_message>
<xml_diff>
--- a/docs/slides/Agentic-SDLC-Tech-Audience.pptx
+++ b/docs/slides/Agentic-SDLC-Tech-Audience.pptx
@@ -6888,12 +6888,12 @@
         </p:nvSpPr>
         <p:spPr>
           <a:xfrm>
-            <a:off x="685800" y="2011680"/>
-            <a:ext cx="10835640" cy="420624"/>
+            <a:off x="685800" y="1920240"/>
+            <a:ext cx="10835640" cy="402336"/>
           </a:xfrm>
           <a:prstGeom prst="roundRect">
             <a:avLst>
-              <a:gd name="adj" fmla="val 21739"/>
+              <a:gd name="adj" fmla="val 22727"/>
             </a:avLst>
           </a:prstGeom>
           <a:solidFill>
@@ -6915,8 +6915,8 @@
         </p:nvSpPr>
         <p:spPr>
           <a:xfrm>
-            <a:off x="914400" y="2075688"/>
-            <a:ext cx="5669280" cy="310896"/>
+            <a:off x="914400" y="1975104"/>
+            <a:ext cx="5669280" cy="292608"/>
           </a:xfrm>
           <a:prstGeom prst="rect">
             <a:avLst/>
@@ -6932,7 +6932,7 @@
               <a:buNone/>
             </a:pPr>
             <a:r>
-              <a:rPr lang="en-US" sz="1350" b="1" dirty="0">
+              <a:rPr lang="en-US" sz="1300" b="1" dirty="0">
                 <a:solidFill>
                   <a:srgbClr val="1E2761"/>
                 </a:solidFill>
@@ -6942,7 +6942,7 @@
               </a:rPr>
               <a:t>Recommended fork — framework · plugin · bench kit · deck source</a:t>
             </a:r>
-            <a:endParaRPr lang="en-US" sz="1350" dirty="0"/>
+            <a:endParaRPr lang="en-US" sz="1300" dirty="0"/>
           </a:p>
         </p:txBody>
       </p:sp>
@@ -6954,8 +6954,8 @@
         </p:nvSpPr>
         <p:spPr>
           <a:xfrm>
-            <a:off x="6675120" y="2075688"/>
-            <a:ext cx="4663440" cy="310896"/>
+            <a:off x="6675120" y="1975104"/>
+            <a:ext cx="4663440" cy="292608"/>
           </a:xfrm>
           <a:prstGeom prst="rect">
             <a:avLst/>
@@ -6971,7 +6971,7 @@
               <a:buNone/>
             </a:pPr>
             <a:r>
-              <a:rPr lang="en-US" sz="1300" b="1" dirty="0">
+              <a:rPr lang="en-US" sz="1250" b="1" dirty="0">
                 <a:solidFill>
                   <a:srgbClr val="1F4FBF"/>
                 </a:solidFill>
@@ -6981,7 +6981,7 @@
               </a:rPr>
               <a:t>trac41799/claude-code-agentic-sdlc</a:t>
             </a:r>
-            <a:endParaRPr lang="en-US" sz="1300" dirty="0"/>
+            <a:endParaRPr lang="en-US" sz="1250" dirty="0"/>
           </a:p>
         </p:txBody>
       </p:sp>
@@ -6993,12 +6993,12 @@
         </p:nvSpPr>
         <p:spPr>
           <a:xfrm>
-            <a:off x="685800" y="2468880"/>
-            <a:ext cx="10835640" cy="420624"/>
+            <a:off x="685800" y="2350008"/>
+            <a:ext cx="10835640" cy="402336"/>
           </a:xfrm>
           <a:prstGeom prst="roundRect">
             <a:avLst>
-              <a:gd name="adj" fmla="val 21739"/>
+              <a:gd name="adj" fmla="val 22727"/>
             </a:avLst>
           </a:prstGeom>
           <a:solidFill>
@@ -7020,8 +7020,8 @@
         </p:nvSpPr>
         <p:spPr>
           <a:xfrm>
-            <a:off x="914400" y="2532888"/>
-            <a:ext cx="5669280" cy="310896"/>
+            <a:off x="914400" y="2404872"/>
+            <a:ext cx="5669280" cy="292608"/>
           </a:xfrm>
           <a:prstGeom prst="rect">
             <a:avLst/>
@@ -7037,7 +7037,7 @@
               <a:buNone/>
             </a:pPr>
             <a:r>
-              <a:rPr lang="en-US" sz="1350" b="1" dirty="0">
+              <a:rPr lang="en-US" sz="1300" b="1" dirty="0">
                 <a:solidFill>
                   <a:srgbClr val="1E2761"/>
                 </a:solidFill>
@@ -7045,9 +7045,9 @@
                 <a:ea typeface="Calibri" pitchFamily="34" charset="-122"/>
                 <a:cs typeface="Calibri" pitchFamily="34" charset="-120"/>
               </a:rPr>
-              <a:t>Benchmark evidence — 12 runs, repro commands</a:t>
-            </a:r>
-            <a:endParaRPr lang="en-US" sz="1350" dirty="0"/>
+              <a:t>Raw evidence — trees + bench projects + validator</a:t>
+            </a:r>
+            <a:endParaRPr lang="en-US" sz="1300" dirty="0"/>
           </a:p>
         </p:txBody>
       </p:sp>
@@ -7059,8 +7059,8 @@
         </p:nvSpPr>
         <p:spPr>
           <a:xfrm>
-            <a:off x="6675120" y="2532888"/>
-            <a:ext cx="4663440" cy="310896"/>
+            <a:off x="6675120" y="2404872"/>
+            <a:ext cx="4663440" cy="292608"/>
           </a:xfrm>
           <a:prstGeom prst="rect">
             <a:avLst/>
@@ -7076,7 +7076,7 @@
               <a:buNone/>
             </a:pPr>
             <a:r>
-              <a:rPr lang="en-US" sz="1300" b="1" dirty="0">
+              <a:rPr lang="en-US" sz="1250" b="1" dirty="0">
                 <a:solidFill>
                   <a:srgbClr val="1F4FBF"/>
                 </a:solidFill>
@@ -7084,9 +7084,9 @@
                 <a:ea typeface="Courier New" pitchFamily="34" charset="-122"/>
                 <a:cs typeface="Courier New" pitchFamily="34" charset="-120"/>
               </a:rPr>
-              <a:t>docs/benchmarks/BENCHMARK-SUMMARY.md</a:t>
-            </a:r>
-            <a:endParaRPr lang="en-US" sz="1300" dirty="0"/>
+              <a:t>evidence/ (README · manifest · validate.py)</a:t>
+            </a:r>
+            <a:endParaRPr lang="en-US" sz="1250" dirty="0"/>
           </a:p>
         </p:txBody>
       </p:sp>
@@ -7098,12 +7098,12 @@
         </p:nvSpPr>
         <p:spPr>
           <a:xfrm>
-            <a:off x="685800" y="2926080"/>
-            <a:ext cx="10835640" cy="420624"/>
+            <a:off x="685800" y="2779776"/>
+            <a:ext cx="10835640" cy="402336"/>
           </a:xfrm>
           <a:prstGeom prst="roundRect">
             <a:avLst>
-              <a:gd name="adj" fmla="val 21739"/>
+              <a:gd name="adj" fmla="val 22727"/>
             </a:avLst>
           </a:prstGeom>
           <a:solidFill>
@@ -7125,8 +7125,8 @@
         </p:nvSpPr>
         <p:spPr>
           <a:xfrm>
-            <a:off x="914400" y="2990088"/>
-            <a:ext cx="5669280" cy="310896"/>
+            <a:off x="914400" y="2834640"/>
+            <a:ext cx="5669280" cy="292608"/>
           </a:xfrm>
           <a:prstGeom prst="rect">
             <a:avLst/>
@@ -7142,7 +7142,7 @@
               <a:buNone/>
             </a:pPr>
             <a:r>
-              <a:rPr lang="en-US" sz="1350" b="1" dirty="0">
+              <a:rPr lang="en-US" sz="1300" b="1" dirty="0">
                 <a:solidFill>
                   <a:srgbClr val="1E2761"/>
                 </a:solidFill>
@@ -7150,9 +7150,9 @@
                 <a:ea typeface="Calibri" pitchFamily="34" charset="-122"/>
                 <a:cs typeface="Calibri" pitchFamily="34" charset="-120"/>
               </a:rPr>
-              <a:t>Live demo run guide (≤10 min)</a:t>
-            </a:r>
-            <a:endParaRPr lang="en-US" sz="1350" dirty="0"/>
+              <a:t>Benchmark evidence — 12 runs, repro commands</a:t>
+            </a:r>
+            <a:endParaRPr lang="en-US" sz="1300" dirty="0"/>
           </a:p>
         </p:txBody>
       </p:sp>
@@ -7164,8 +7164,8 @@
         </p:nvSpPr>
         <p:spPr>
           <a:xfrm>
-            <a:off x="6675120" y="2990088"/>
-            <a:ext cx="4663440" cy="310896"/>
+            <a:off x="6675120" y="2834640"/>
+            <a:ext cx="4663440" cy="292608"/>
           </a:xfrm>
           <a:prstGeom prst="rect">
             <a:avLst/>
@@ -7181,7 +7181,7 @@
               <a:buNone/>
             </a:pPr>
             <a:r>
-              <a:rPr lang="en-US" sz="1300" b="1" dirty="0">
+              <a:rPr lang="en-US" sz="1250" b="1" dirty="0">
                 <a:solidFill>
                   <a:srgbClr val="1F4FBF"/>
                 </a:solidFill>
@@ -7189,9 +7189,9 @@
                 <a:ea typeface="Courier New" pitchFamily="34" charset="-122"/>
                 <a:cs typeface="Courier New" pitchFamily="34" charset="-120"/>
               </a:rPr>
-              <a:t>docs/demo/live-demo-guide.md</a:t>
-            </a:r>
-            <a:endParaRPr lang="en-US" sz="1300" dirty="0"/>
+              <a:t>docs/benchmarks/BENCHMARK-SUMMARY.md</a:t>
+            </a:r>
+            <a:endParaRPr lang="en-US" sz="1250" dirty="0"/>
           </a:p>
         </p:txBody>
       </p:sp>
@@ -7203,12 +7203,12 @@
         </p:nvSpPr>
         <p:spPr>
           <a:xfrm>
-            <a:off x="685800" y="3383280"/>
-            <a:ext cx="10835640" cy="420624"/>
+            <a:off x="685800" y="3209544"/>
+            <a:ext cx="10835640" cy="402336"/>
           </a:xfrm>
           <a:prstGeom prst="roundRect">
             <a:avLst>
-              <a:gd name="adj" fmla="val 21739"/>
+              <a:gd name="adj" fmla="val 22727"/>
             </a:avLst>
           </a:prstGeom>
           <a:solidFill>
@@ -7230,8 +7230,8 @@
         </p:nvSpPr>
         <p:spPr>
           <a:xfrm>
-            <a:off x="914400" y="3447288"/>
-            <a:ext cx="5669280" cy="310896"/>
+            <a:off x="914400" y="3264408"/>
+            <a:ext cx="5669280" cy="292608"/>
           </a:xfrm>
           <a:prstGeom prst="rect">
             <a:avLst/>
@@ -7247,7 +7247,7 @@
               <a:buNone/>
             </a:pPr>
             <a:r>
-              <a:rPr lang="en-US" sz="1350" b="1" dirty="0">
+              <a:rPr lang="en-US" sz="1300" b="1" dirty="0">
                 <a:solidFill>
                   <a:srgbClr val="1E2761"/>
                 </a:solidFill>
@@ -7255,9 +7255,9 @@
                 <a:ea typeface="Calibri" pitchFamily="34" charset="-122"/>
                 <a:cs typeface="Calibri" pitchFamily="34" charset="-120"/>
               </a:rPr>
-              <a:t>Client setup — 5 prompts for non-technical founders</a:t>
-            </a:r>
-            <a:endParaRPr lang="en-US" sz="1350" dirty="0"/>
+              <a:t>Live demo run guide (≤10 min)</a:t>
+            </a:r>
+            <a:endParaRPr lang="en-US" sz="1300" dirty="0"/>
           </a:p>
         </p:txBody>
       </p:sp>
@@ -7269,8 +7269,8 @@
         </p:nvSpPr>
         <p:spPr>
           <a:xfrm>
-            <a:off x="6675120" y="3447288"/>
-            <a:ext cx="4663440" cy="310896"/>
+            <a:off x="6675120" y="3264408"/>
+            <a:ext cx="4663440" cy="292608"/>
           </a:xfrm>
           <a:prstGeom prst="rect">
             <a:avLst/>
@@ -7286,7 +7286,7 @@
               <a:buNone/>
             </a:pPr>
             <a:r>
-              <a:rPr lang="en-US" sz="1300" b="1" dirty="0">
+              <a:rPr lang="en-US" sz="1250" b="1" dirty="0">
                 <a:solidFill>
                   <a:srgbClr val="1F4FBF"/>
                 </a:solidFill>
@@ -7294,9 +7294,9 @@
                 <a:ea typeface="Courier New" pitchFamily="34" charset="-122"/>
                 <a:cs typeface="Courier New" pitchFamily="34" charset="-120"/>
               </a:rPr>
-              <a:t>docs/guide/CLIENT-SETUP.md</a:t>
-            </a:r>
-            <a:endParaRPr lang="en-US" sz="1300" dirty="0"/>
+              <a:t>docs/demo/live-demo-guide.md</a:t>
+            </a:r>
+            <a:endParaRPr lang="en-US" sz="1250" dirty="0"/>
           </a:p>
         </p:txBody>
       </p:sp>
@@ -7308,12 +7308,12 @@
         </p:nvSpPr>
         <p:spPr>
           <a:xfrm>
-            <a:off x="685800" y="3840480"/>
-            <a:ext cx="10835640" cy="420624"/>
+            <a:off x="685800" y="3639312"/>
+            <a:ext cx="10835640" cy="402336"/>
           </a:xfrm>
           <a:prstGeom prst="roundRect">
             <a:avLst>
-              <a:gd name="adj" fmla="val 21739"/>
+              <a:gd name="adj" fmla="val 22727"/>
             </a:avLst>
           </a:prstGeom>
           <a:solidFill>
@@ -7335,8 +7335,8 @@
         </p:nvSpPr>
         <p:spPr>
           <a:xfrm>
-            <a:off x="914400" y="3904488"/>
-            <a:ext cx="5669280" cy="310896"/>
+            <a:off x="914400" y="3694176"/>
+            <a:ext cx="5669280" cy="292608"/>
           </a:xfrm>
           <a:prstGeom prst="rect">
             <a:avLst/>
@@ -7352,7 +7352,7 @@
               <a:buNone/>
             </a:pPr>
             <a:r>
-              <a:rPr lang="en-US" sz="1350" b="1" dirty="0">
+              <a:rPr lang="en-US" sz="1300" b="1" dirty="0">
                 <a:solidFill>
                   <a:srgbClr val="1E2761"/>
                 </a:solidFill>
@@ -7360,9 +7360,9 @@
                 <a:ea typeface="Calibri" pitchFamily="34" charset="-122"/>
                 <a:cs typeface="Calibri" pitchFamily="34" charset="-120"/>
               </a:rPr>
-              <a:t>Benchmark product — FE (froam)</a:t>
-            </a:r>
-            <a:endParaRPr lang="en-US" sz="1350" dirty="0"/>
+              <a:t>Client setup — 5 prompts for non-technical founders</a:t>
+            </a:r>
+            <a:endParaRPr lang="en-US" sz="1300" dirty="0"/>
           </a:p>
         </p:txBody>
       </p:sp>
@@ -7374,8 +7374,8 @@
         </p:nvSpPr>
         <p:spPr>
           <a:xfrm>
-            <a:off x="6675120" y="3904488"/>
-            <a:ext cx="4663440" cy="310896"/>
+            <a:off x="6675120" y="3694176"/>
+            <a:ext cx="4663440" cy="292608"/>
           </a:xfrm>
           <a:prstGeom prst="rect">
             <a:avLst/>
@@ -7391,7 +7391,7 @@
               <a:buNone/>
             </a:pPr>
             <a:r>
-              <a:rPr lang="en-US" sz="1300" b="1" dirty="0">
+              <a:rPr lang="en-US" sz="1250" b="1" dirty="0">
                 <a:solidFill>
                   <a:srgbClr val="1F4FBF"/>
                 </a:solidFill>
@@ -7399,9 +7399,9 @@
                 <a:ea typeface="Courier New" pitchFamily="34" charset="-122"/>
                 <a:cs typeface="Courier New" pitchFamily="34" charset="-120"/>
               </a:rPr>
-              <a:t>trac41799/froam-journey-platform-fe</a:t>
-            </a:r>
-            <a:endParaRPr lang="en-US" sz="1300" dirty="0"/>
+              <a:t>docs/guide/CLIENT-SETUP.md</a:t>
+            </a:r>
+            <a:endParaRPr lang="en-US" sz="1250" dirty="0"/>
           </a:p>
         </p:txBody>
       </p:sp>
@@ -7413,12 +7413,12 @@
         </p:nvSpPr>
         <p:spPr>
           <a:xfrm>
-            <a:off x="685800" y="4297680"/>
-            <a:ext cx="10835640" cy="420624"/>
+            <a:off x="685800" y="4069080"/>
+            <a:ext cx="10835640" cy="402336"/>
           </a:xfrm>
           <a:prstGeom prst="roundRect">
             <a:avLst>
-              <a:gd name="adj" fmla="val 21739"/>
+              <a:gd name="adj" fmla="val 22727"/>
             </a:avLst>
           </a:prstGeom>
           <a:solidFill>
@@ -7440,8 +7440,8 @@
         </p:nvSpPr>
         <p:spPr>
           <a:xfrm>
-            <a:off x="914400" y="4361688"/>
-            <a:ext cx="5669280" cy="310896"/>
+            <a:off x="914400" y="4123944"/>
+            <a:ext cx="5669280" cy="292608"/>
           </a:xfrm>
           <a:prstGeom prst="rect">
             <a:avLst/>
@@ -7457,7 +7457,7 @@
               <a:buNone/>
             </a:pPr>
             <a:r>
-              <a:rPr lang="en-US" sz="1350" b="1" dirty="0">
+              <a:rPr lang="en-US" sz="1300" b="1" dirty="0">
                 <a:solidFill>
                   <a:srgbClr val="1E2761"/>
                 </a:solidFill>
@@ -7465,9 +7465,9 @@
                 <a:ea typeface="Calibri" pitchFamily="34" charset="-122"/>
                 <a:cs typeface="Calibri" pitchFamily="34" charset="-120"/>
               </a:rPr>
-              <a:t>Benchmark product — BE (froam)</a:t>
-            </a:r>
-            <a:endParaRPr lang="en-US" sz="1350" dirty="0"/>
+              <a:t>Benchmark product — FE (froam)</a:t>
+            </a:r>
+            <a:endParaRPr lang="en-US" sz="1300" dirty="0"/>
           </a:p>
         </p:txBody>
       </p:sp>
@@ -7479,8 +7479,8 @@
         </p:nvSpPr>
         <p:spPr>
           <a:xfrm>
-            <a:off x="6675120" y="4361688"/>
-            <a:ext cx="4663440" cy="310896"/>
+            <a:off x="6675120" y="4123944"/>
+            <a:ext cx="4663440" cy="292608"/>
           </a:xfrm>
           <a:prstGeom prst="rect">
             <a:avLst/>
@@ -7496,7 +7496,7 @@
               <a:buNone/>
             </a:pPr>
             <a:r>
-              <a:rPr lang="en-US" sz="1300" b="1" dirty="0">
+              <a:rPr lang="en-US" sz="1250" b="1" dirty="0">
                 <a:solidFill>
                   <a:srgbClr val="1F4FBF"/>
                 </a:solidFill>
@@ -7504,9 +7504,9 @@
                 <a:ea typeface="Courier New" pitchFamily="34" charset="-122"/>
                 <a:cs typeface="Courier New" pitchFamily="34" charset="-120"/>
               </a:rPr>
-              <a:t>trac41799/travelbuddy-agentic-be</a:t>
-            </a:r>
-            <a:endParaRPr lang="en-US" sz="1300" dirty="0"/>
+              <a:t>trac41799/froam-journey-platform-fe</a:t>
+            </a:r>
+            <a:endParaRPr lang="en-US" sz="1250" dirty="0"/>
           </a:p>
         </p:txBody>
       </p:sp>
@@ -7518,12 +7518,12 @@
         </p:nvSpPr>
         <p:spPr>
           <a:xfrm>
-            <a:off x="685800" y="4754880"/>
-            <a:ext cx="10835640" cy="420624"/>
+            <a:off x="685800" y="4498848"/>
+            <a:ext cx="10835640" cy="402336"/>
           </a:xfrm>
           <a:prstGeom prst="roundRect">
             <a:avLst>
-              <a:gd name="adj" fmla="val 21739"/>
+              <a:gd name="adj" fmla="val 22727"/>
             </a:avLst>
           </a:prstGeom>
           <a:solidFill>
@@ -7545,8 +7545,8 @@
         </p:nvSpPr>
         <p:spPr>
           <a:xfrm>
-            <a:off x="914400" y="4818888"/>
-            <a:ext cx="5669280" cy="310896"/>
+            <a:off x="914400" y="4553712"/>
+            <a:ext cx="5669280" cy="292608"/>
           </a:xfrm>
           <a:prstGeom prst="rect">
             <a:avLst/>
@@ -7562,7 +7562,7 @@
               <a:buNone/>
             </a:pPr>
             <a:r>
-              <a:rPr lang="en-US" sz="1350" b="1" dirty="0">
+              <a:rPr lang="en-US" sz="1300" b="1" dirty="0">
                 <a:solidFill>
                   <a:srgbClr val="1E2761"/>
                 </a:solidFill>
@@ -7570,9 +7570,9 @@
                 <a:ea typeface="Calibri" pitchFamily="34" charset="-122"/>
                 <a:cs typeface="Calibri" pitchFamily="34" charset="-120"/>
               </a:rPr>
-              <a:t>Official origin (ex-company) — v1 history, read-only</a:t>
-            </a:r>
-            <a:endParaRPr lang="en-US" sz="1350" dirty="0"/>
+              <a:t>Benchmark product — BE (froam)</a:t>
+            </a:r>
+            <a:endParaRPr lang="en-US" sz="1300" dirty="0"/>
           </a:p>
         </p:txBody>
       </p:sp>
@@ -7584,8 +7584,8 @@
         </p:nvSpPr>
         <p:spPr>
           <a:xfrm>
-            <a:off x="6675120" y="4818888"/>
-            <a:ext cx="4663440" cy="310896"/>
+            <a:off x="6675120" y="4553712"/>
+            <a:ext cx="4663440" cy="292608"/>
           </a:xfrm>
           <a:prstGeom prst="rect">
             <a:avLst/>
@@ -7601,7 +7601,7 @@
               <a:buNone/>
             </a:pPr>
             <a:r>
-              <a:rPr lang="en-US" sz="1300" b="1" dirty="0">
+              <a:rPr lang="en-US" sz="1250" b="1" dirty="0">
                 <a:solidFill>
                   <a:srgbClr val="1F4FBF"/>
                 </a:solidFill>
@@ -7609,9 +7609,9 @@
                 <a:ea typeface="Courier New" pitchFamily="34" charset="-122"/>
                 <a:cs typeface="Courier New" pitchFamily="34" charset="-120"/>
               </a:rPr>
-              <a:t>talentedgeai/infinite-leverage</a:t>
-            </a:r>
-            <a:endParaRPr lang="en-US" sz="1300" dirty="0"/>
+              <a:t>trac41799/travelbuddy-agentic-be</a:t>
+            </a:r>
+            <a:endParaRPr lang="en-US" sz="1250" dirty="0"/>
           </a:p>
         </p:txBody>
       </p:sp>
@@ -7623,12 +7623,12 @@
         </p:nvSpPr>
         <p:spPr>
           <a:xfrm>
-            <a:off x="685800" y="5212080"/>
-            <a:ext cx="10835640" cy="420624"/>
+            <a:off x="685800" y="4928616"/>
+            <a:ext cx="10835640" cy="402336"/>
           </a:xfrm>
           <a:prstGeom prst="roundRect">
             <a:avLst>
-              <a:gd name="adj" fmla="val 21739"/>
+              <a:gd name="adj" fmla="val 22727"/>
             </a:avLst>
           </a:prstGeom>
           <a:solidFill>
@@ -7650,8 +7650,8 @@
         </p:nvSpPr>
         <p:spPr>
           <a:xfrm>
-            <a:off x="914400" y="5276088"/>
-            <a:ext cx="5669280" cy="310896"/>
+            <a:off x="914400" y="4983480"/>
+            <a:ext cx="5669280" cy="292608"/>
           </a:xfrm>
           <a:prstGeom prst="rect">
             <a:avLst/>
@@ -7667,7 +7667,7 @@
               <a:buNone/>
             </a:pPr>
             <a:r>
-              <a:rPr lang="en-US" sz="1350" b="1" dirty="0">
+              <a:rPr lang="en-US" sz="1300" b="1" dirty="0">
                 <a:solidFill>
                   <a:srgbClr val="1E2761"/>
                 </a:solidFill>
@@ -7675,9 +7675,9 @@
                 <a:ea typeface="Calibri" pitchFamily="34" charset="-122"/>
                 <a:cs typeface="Calibri" pitchFamily="34" charset="-120"/>
               </a:rPr>
-              <a:t>Client cases</a:t>
-            </a:r>
-            <a:endParaRPr lang="en-US" sz="1350" dirty="0"/>
+              <a:t>Official origin (ex-company) — v1 history, read-only</a:t>
+            </a:r>
+            <a:endParaRPr lang="en-US" sz="1300" dirty="0"/>
           </a:p>
         </p:txBody>
       </p:sp>
@@ -7689,8 +7689,8 @@
         </p:nvSpPr>
         <p:spPr>
           <a:xfrm>
-            <a:off x="6675120" y="5276088"/>
-            <a:ext cx="4663440" cy="310896"/>
+            <a:off x="6675120" y="4983480"/>
+            <a:ext cx="4663440" cy="292608"/>
           </a:xfrm>
           <a:prstGeom prst="rect">
             <a:avLst/>
@@ -7706,7 +7706,7 @@
               <a:buNone/>
             </a:pPr>
             <a:r>
-              <a:rPr lang="en-US" sz="1300" b="1" dirty="0">
+              <a:rPr lang="en-US" sz="1250" b="1" dirty="0">
                 <a:solidFill>
                   <a:srgbClr val="1F4FBF"/>
                 </a:solidFill>
@@ -7714,9 +7714,9 @@
                 <a:ea typeface="Courier New" pitchFamily="34" charset="-122"/>
                 <a:cs typeface="Courier New" pitchFamily="34" charset="-120"/>
               </a:rPr>
-              <a:t>janet.care · occuspan.com</a:t>
-            </a:r>
-            <a:endParaRPr lang="en-US" sz="1300" dirty="0"/>
+              <a:t>talentedgeai/infinite-leverage</a:t>
+            </a:r>
+            <a:endParaRPr lang="en-US" sz="1250" dirty="0"/>
           </a:p>
         </p:txBody>
       </p:sp>
@@ -7728,12 +7728,12 @@
         </p:nvSpPr>
         <p:spPr>
           <a:xfrm>
-            <a:off x="685800" y="5669280"/>
-            <a:ext cx="10835640" cy="420624"/>
+            <a:off x="685800" y="5358384"/>
+            <a:ext cx="10835640" cy="402336"/>
           </a:xfrm>
           <a:prstGeom prst="roundRect">
             <a:avLst>
-              <a:gd name="adj" fmla="val 21739"/>
+              <a:gd name="adj" fmla="val 22727"/>
             </a:avLst>
           </a:prstGeom>
           <a:solidFill>
@@ -7755,8 +7755,8 @@
         </p:nvSpPr>
         <p:spPr>
           <a:xfrm>
-            <a:off x="914400" y="5733288"/>
-            <a:ext cx="5669280" cy="310896"/>
+            <a:off x="914400" y="5413248"/>
+            <a:ext cx="5669280" cy="292608"/>
           </a:xfrm>
           <a:prstGeom prst="rect">
             <a:avLst/>
@@ -7772,7 +7772,7 @@
               <a:buNone/>
             </a:pPr>
             <a:r>
-              <a:rPr lang="en-US" sz="1350" b="1" dirty="0">
+              <a:rPr lang="en-US" sz="1300" b="1" dirty="0">
                 <a:solidFill>
                   <a:srgbClr val="1E2761"/>
                 </a:solidFill>
@@ -7780,9 +7780,9 @@
                 <a:ea typeface="Calibri" pitchFamily="34" charset="-122"/>
                 <a:cs typeface="Calibri" pitchFamily="34" charset="-120"/>
               </a:rPr>
-              <a:t>Tool stack</a:t>
-            </a:r>
-            <a:endParaRPr lang="en-US" sz="1350" dirty="0"/>
+              <a:t>Client cases</a:t>
+            </a:r>
+            <a:endParaRPr lang="en-US" sz="1300" dirty="0"/>
           </a:p>
         </p:txBody>
       </p:sp>
@@ -7794,8 +7794,8 @@
         </p:nvSpPr>
         <p:spPr>
           <a:xfrm>
-            <a:off x="6675120" y="5733288"/>
-            <a:ext cx="4663440" cy="310896"/>
+            <a:off x="6675120" y="5413248"/>
+            <a:ext cx="4663440" cy="292608"/>
           </a:xfrm>
           <a:prstGeom prst="rect">
             <a:avLst/>
@@ -7811,7 +7811,7 @@
               <a:buNone/>
             </a:pPr>
             <a:r>
-              <a:rPr lang="en-US" sz="1300" b="1" dirty="0">
+              <a:rPr lang="en-US" sz="1250" b="1" dirty="0">
                 <a:solidFill>
                   <a:srgbClr val="1F4FBF"/>
                 </a:solidFill>
@@ -7819,21 +7819,126 @@
                 <a:ea typeface="Courier New" pitchFamily="34" charset="-122"/>
                 <a:cs typeface="Courier New" pitchFamily="34" charset="-120"/>
               </a:rPr>
+              <a:t>janet.care · occuspan.com</a:t>
+            </a:r>
+            <a:endParaRPr lang="en-US" sz="1250" dirty="0"/>
+          </a:p>
+        </p:txBody>
+      </p:sp>
+      <p:sp>
+        <p:nvSpPr>
+          <p:cNvPr id="32" name="Shape 30"/>
+          <p:cNvSpPr/>
+          <p:nvPr/>
+        </p:nvSpPr>
+        <p:spPr>
+          <a:xfrm>
+            <a:off x="685800" y="5788152"/>
+            <a:ext cx="10835640" cy="402336"/>
+          </a:xfrm>
+          <a:prstGeom prst="roundRect">
+            <a:avLst>
+              <a:gd name="adj" fmla="val 22727"/>
+            </a:avLst>
+          </a:prstGeom>
+          <a:solidFill>
+            <a:srgbClr val="F8FAFC"/>
+          </a:solidFill>
+          <a:ln w="15875">
+            <a:solidFill>
+              <a:srgbClr val="D1D5DB"/>
+            </a:solidFill>
+            <a:prstDash val="solid"/>
+          </a:ln>
+        </p:spPr>
+      </p:sp>
+      <p:sp>
+        <p:nvSpPr>
+          <p:cNvPr id="33" name="Text 31"/>
+          <p:cNvSpPr/>
+          <p:nvPr/>
+        </p:nvSpPr>
+        <p:spPr>
+          <a:xfrm>
+            <a:off x="914400" y="5843016"/>
+            <a:ext cx="5669280" cy="292608"/>
+          </a:xfrm>
+          <a:prstGeom prst="rect">
+            <a:avLst/>
+          </a:prstGeom>
+          <a:noFill/>
+          <a:ln/>
+        </p:spPr>
+        <p:txBody>
+          <a:bodyPr wrap="square" lIns="0" tIns="0" rIns="0" bIns="0" rtlCol="0" anchor="ctr"/>
+          <a:lstStyle/>
+          <a:p>
+            <a:pPr indent="0" marL="0">
+              <a:buNone/>
+            </a:pPr>
+            <a:r>
+              <a:rPr lang="en-US" sz="1300" b="1" dirty="0">
+                <a:solidFill>
+                  <a:srgbClr val="1E2761"/>
+                </a:solidFill>
+                <a:latin typeface="Calibri" pitchFamily="34" charset="0"/>
+                <a:ea typeface="Calibri" pitchFamily="34" charset="-122"/>
+                <a:cs typeface="Calibri" pitchFamily="34" charset="-120"/>
+              </a:rPr>
+              <a:t>Tool stack</a:t>
+            </a:r>
+            <a:endParaRPr lang="en-US" sz="1300" dirty="0"/>
+          </a:p>
+        </p:txBody>
+      </p:sp>
+      <p:sp>
+        <p:nvSpPr>
+          <p:cNvPr id="34" name="Text 32"/>
+          <p:cNvSpPr/>
+          <p:nvPr/>
+        </p:nvSpPr>
+        <p:spPr>
+          <a:xfrm>
+            <a:off x="6675120" y="5843016"/>
+            <a:ext cx="4663440" cy="292608"/>
+          </a:xfrm>
+          <a:prstGeom prst="rect">
+            <a:avLst/>
+          </a:prstGeom>
+          <a:noFill/>
+          <a:ln/>
+        </p:spPr>
+        <p:txBody>
+          <a:bodyPr wrap="square" lIns="0" tIns="0" rIns="0" bIns="0" rtlCol="0" anchor="ctr"/>
+          <a:lstStyle/>
+          <a:p>
+            <a:pPr algn="r" indent="0" marL="0">
+              <a:buNone/>
+            </a:pPr>
+            <a:r>
+              <a:rPr lang="en-US" sz="1250" b="1" dirty="0">
+                <a:solidFill>
+                  <a:srgbClr val="1F4FBF"/>
+                </a:solidFill>
+                <a:latin typeface="Courier New" pitchFamily="34" charset="0"/>
+                <a:ea typeface="Courier New" pitchFamily="34" charset="-122"/>
+                <a:cs typeface="Courier New" pitchFamily="34" charset="-120"/>
+              </a:rPr>
               <a:t>claude.com · github.com · vercel.com · supabase.com</a:t>
             </a:r>
-            <a:endParaRPr lang="en-US" sz="1300" dirty="0"/>
-          </a:p>
-        </p:txBody>
-      </p:sp>
-      <p:sp>
-        <p:nvSpPr>
-          <p:cNvPr id="32" name="Text 30"/>
-          <p:cNvSpPr/>
-          <p:nvPr/>
-        </p:nvSpPr>
-        <p:spPr>
-          <a:xfrm>
-            <a:off x="685800" y="6217920"/>
+            <a:endParaRPr lang="en-US" sz="1250" dirty="0"/>
+          </a:p>
+        </p:txBody>
+      </p:sp>
+      <p:sp>
+        <p:nvSpPr>
+          <p:cNvPr id="35" name="Text 33"/>
+          <p:cNvSpPr/>
+          <p:nvPr/>
+        </p:nvSpPr>
+        <p:spPr>
+          <a:xfrm>
+            <a:off x="685800" y="6355080"/>
             <a:ext cx="10835640" cy="320040"/>
           </a:xfrm>
           <a:prstGeom prst="rect">

</xml_diff>